<commit_message>
split: backup slides into separate file so "Спасибо" ends main deck
Per supervisor request, main presentation now ends on slide 13 "Спасибо
за внимание". The 5 technical reserve slides (DeepLabV3+ architecture,
Dice-BCE loss, SNAP preprocessing, metrics, confusion matrix) moved to a
separate file Презентация_Резерв_Байханов_2026.pptx for Q&A.

https://claude.ai/code/session_019hNMUj3P61dTB8aYHXMjHP
</commit_message>
<xml_diff>
--- a/thesis/vkr_final/Презентация_Финал_Байханов_2026.pptx
+++ b/thesis/vkr_final/Презентация_Финал_Байханов_2026.pptx
@@ -18,11 +18,6 @@
     <p:sldId id="266" r:id="rId17"/>
     <p:sldId id="267" r:id="rId18"/>
     <p:sldId id="268" r:id="rId19"/>
-    <p:sldId id="269" r:id="rId20"/>
-    <p:sldId id="270" r:id="rId21"/>
-    <p:sldId id="271" r:id="rId22"/>
-    <p:sldId id="272" r:id="rId23"/>
-    <p:sldId id="273" r:id="rId24"/>
   </p:sldIdLst>
   <p:sldSz cx="12191695" cy="6858000" type="screen4x3"/>
   <p:notesSz cx="6858000" cy="9144000"/>
@@ -4045,7 +4040,7 @@
                 </a:solidFill>
                 <a:latin typeface="Arial"/>
               </a:rPr>
-              <a:t>10 / 18</a:t>
+              <a:t>10 / 13</a:t>
             </a:r>
           </a:p>
         </p:txBody>
@@ -4619,7 +4614,7 @@
                 </a:solidFill>
                 <a:latin typeface="Arial"/>
               </a:rPr>
-              <a:t>11 / 18</a:t>
+              <a:t>11 / 13</a:t>
             </a:r>
           </a:p>
         </p:txBody>
@@ -5409,7 +5404,7 @@
                 </a:solidFill>
                 <a:latin typeface="Arial"/>
               </a:rPr>
-              <a:t>12 / 18</a:t>
+              <a:t>12 / 13</a:t>
             </a:r>
           </a:p>
         </p:txBody>
@@ -6396,4412 +6391,7 @@
                 </a:solidFill>
                 <a:latin typeface="Arial"/>
               </a:rPr>
-              <a:t>13 / 18</a:t>
-            </a:r>
-          </a:p>
-        </p:txBody>
-      </p:sp>
-    </p:spTree>
-  </p:cSld>
-  <p:clrMapOvr>
-    <a:masterClrMapping/>
-  </p:clrMapOvr>
-</p:sld>
-</file>
-
-<file path=ppt/slides/slide14.xml><?xml version="1.0" encoding="utf-8"?>
-<p:sld xmlns:a="http://schemas.openxmlformats.org/drawingml/2006/main" xmlns:p="http://schemas.openxmlformats.org/presentationml/2006/main" xmlns:r="http://schemas.openxmlformats.org/officeDocument/2006/relationships">
-  <p:cSld>
-    <p:spTree>
-      <p:nvGrpSpPr>
-        <p:cNvPr id="1" name=""/>
-        <p:cNvGrpSpPr/>
-        <p:nvPr/>
-      </p:nvGrpSpPr>
-      <p:grpSpPr/>
-      <p:sp>
-        <p:nvSpPr>
-          <p:cNvPr id="2" name="Rectangle 1"/>
-          <p:cNvSpPr/>
-          <p:nvPr/>
-        </p:nvSpPr>
-        <p:spPr>
-          <a:xfrm>
-            <a:off x="0" y="0"/>
-            <a:ext cx="12191695" cy="6858000"/>
-          </a:xfrm>
-          <a:prstGeom prst="rect">
-            <a:avLst/>
-          </a:prstGeom>
-          <a:solidFill>
-            <a:srgbClr val="FFFFFF"/>
-          </a:solidFill>
-          <a:ln>
-            <a:noFill/>
-          </a:ln>
-          <a:effectLst/>
-        </p:spPr>
-        <p:style>
-          <a:lnRef idx="1">
-            <a:schemeClr val="accent1"/>
-          </a:lnRef>
-          <a:fillRef idx="3">
-            <a:schemeClr val="accent1"/>
-          </a:fillRef>
-          <a:effectRef idx="2">
-            <a:schemeClr val="accent1"/>
-          </a:effectRef>
-          <a:fontRef idx="minor">
-            <a:schemeClr val="lt1"/>
-          </a:fontRef>
-        </p:style>
-        <p:txBody>
-          <a:bodyPr rtlCol="0" anchor="ctr"/>
-          <a:lstStyle/>
-          <a:p>
-            <a:pPr algn="ctr"/>
-          </a:p>
-        </p:txBody>
-      </p:sp>
-      <p:sp>
-        <p:nvSpPr>
-          <p:cNvPr id="3" name="Rectangle 2"/>
-          <p:cNvSpPr/>
-          <p:nvPr/>
-        </p:nvSpPr>
-        <p:spPr>
-          <a:xfrm>
-            <a:off x="0" y="0"/>
-            <a:ext cx="146304" cy="6858000"/>
-          </a:xfrm>
-          <a:prstGeom prst="rect">
-            <a:avLst/>
-          </a:prstGeom>
-          <a:solidFill>
-            <a:srgbClr val="2563EB"/>
-          </a:solidFill>
-          <a:ln>
-            <a:noFill/>
-          </a:ln>
-          <a:effectLst/>
-        </p:spPr>
-        <p:style>
-          <a:lnRef idx="1">
-            <a:schemeClr val="accent1"/>
-          </a:lnRef>
-          <a:fillRef idx="3">
-            <a:schemeClr val="accent1"/>
-          </a:fillRef>
-          <a:effectRef idx="2">
-            <a:schemeClr val="accent1"/>
-          </a:effectRef>
-          <a:fontRef idx="minor">
-            <a:schemeClr val="lt1"/>
-          </a:fontRef>
-        </p:style>
-        <p:txBody>
-          <a:bodyPr rtlCol="0" anchor="ctr"/>
-          <a:lstStyle/>
-          <a:p>
-            <a:pPr algn="ctr"/>
-          </a:p>
-        </p:txBody>
-      </p:sp>
-      <p:sp>
-        <p:nvSpPr>
-          <p:cNvPr id="4" name="TextBox 3"/>
-          <p:cNvSpPr txBox="1"/>
-          <p:nvPr/>
-        </p:nvSpPr>
-        <p:spPr>
-          <a:xfrm>
-            <a:off x="640080" y="310896"/>
-            <a:ext cx="10058400" cy="274320"/>
-          </a:xfrm>
-          <a:prstGeom prst="rect">
-            <a:avLst/>
-          </a:prstGeom>
-          <a:noFill/>
-        </p:spPr>
-        <p:txBody>
-          <a:bodyPr wrap="square" anchor="t" lIns="0" rIns="0" tIns="0" bIns="0">
-            <a:spAutoFit/>
-          </a:bodyPr>
-          <a:lstStyle/>
-          <a:p>
-            <a:pPr algn="l">
-              <a:lnSpc>
-                <a:spcPct val="105000"/>
-              </a:lnSpc>
-              <a:spcBef>
-                <a:spcPts val="0"/>
-              </a:spcBef>
-              <a:spcAft>
-                <a:spcPts val="600"/>
-              </a:spcAft>
-            </a:pPr>
-            <a:r>
-              <a:rPr sz="1100" b="1" i="0">
-                <a:solidFill>
-                  <a:srgbClr val="6B7280"/>
-                </a:solidFill>
-                <a:latin typeface="Arial"/>
-              </a:rPr>
-              <a:t>РЕЗЕРВНЫЙ СЛАЙД</a:t>
-            </a:r>
-          </a:p>
-        </p:txBody>
-      </p:sp>
-      <p:sp>
-        <p:nvSpPr>
-          <p:cNvPr id="5" name="TextBox 4"/>
-          <p:cNvSpPr txBox="1"/>
-          <p:nvPr/>
-        </p:nvSpPr>
-        <p:spPr>
-          <a:xfrm>
-            <a:off x="640080" y="566928"/>
-            <a:ext cx="10972800" cy="731520"/>
-          </a:xfrm>
-          <a:prstGeom prst="rect">
-            <a:avLst/>
-          </a:prstGeom>
-          <a:noFill/>
-        </p:spPr>
-        <p:txBody>
-          <a:bodyPr wrap="square" anchor="t" lIns="0" rIns="0" tIns="0" bIns="0">
-            <a:spAutoFit/>
-          </a:bodyPr>
-          <a:lstStyle/>
-          <a:p>
-            <a:pPr algn="l">
-              <a:lnSpc>
-                <a:spcPct val="105000"/>
-              </a:lnSpc>
-              <a:spcBef>
-                <a:spcPts val="0"/>
-              </a:spcBef>
-              <a:spcAft>
-                <a:spcPts val="600"/>
-              </a:spcAft>
-            </a:pPr>
-            <a:r>
-              <a:rPr sz="3000" b="1" i="0">
-                <a:solidFill>
-                  <a:srgbClr val="2563EB"/>
-                </a:solidFill>
-                <a:latin typeface="Arial"/>
-              </a:rPr>
-              <a:t>DeepLabV3+ с энкодером ResNet-50</a:t>
-            </a:r>
-          </a:p>
-        </p:txBody>
-      </p:sp>
-      <p:sp>
-        <p:nvSpPr>
-          <p:cNvPr id="6" name="Rectangle 5"/>
-          <p:cNvSpPr/>
-          <p:nvPr/>
-        </p:nvSpPr>
-        <p:spPr>
-          <a:xfrm>
-            <a:off x="640080" y="1225296"/>
-            <a:ext cx="2011680" cy="38100"/>
-          </a:xfrm>
-          <a:prstGeom prst="rect">
-            <a:avLst/>
-          </a:prstGeom>
-          <a:solidFill>
-            <a:srgbClr val="2563EB"/>
-          </a:solidFill>
-          <a:ln>
-            <a:noFill/>
-          </a:ln>
-          <a:effectLst/>
-        </p:spPr>
-        <p:style>
-          <a:lnRef idx="1">
-            <a:schemeClr val="accent1"/>
-          </a:lnRef>
-          <a:fillRef idx="3">
-            <a:schemeClr val="accent1"/>
-          </a:fillRef>
-          <a:effectRef idx="2">
-            <a:schemeClr val="accent1"/>
-          </a:effectRef>
-          <a:fontRef idx="minor">
-            <a:schemeClr val="lt1"/>
-          </a:fontRef>
-        </p:style>
-        <p:txBody>
-          <a:bodyPr rtlCol="0" anchor="ctr"/>
-          <a:lstStyle/>
-          <a:p>
-            <a:pPr algn="ctr"/>
-          </a:p>
-        </p:txBody>
-      </p:sp>
-      <p:sp>
-        <p:nvSpPr>
-          <p:cNvPr id="7" name="Rounded Rectangle 6"/>
-          <p:cNvSpPr/>
-          <p:nvPr/>
-        </p:nvSpPr>
-        <p:spPr>
-          <a:xfrm>
-            <a:off x="11140135" y="6355080"/>
-            <a:ext cx="777240" cy="310896"/>
-          </a:xfrm>
-          <a:prstGeom prst="roundRect">
-            <a:avLst/>
-          </a:prstGeom>
-          <a:solidFill>
-            <a:srgbClr val="F3F6FC"/>
-          </a:solidFill>
-          <a:ln w="9525">
-            <a:solidFill>
-              <a:srgbClr val="E2E8F0"/>
-            </a:solidFill>
-          </a:ln>
-          <a:effectLst/>
-        </p:spPr>
-        <p:style>
-          <a:lnRef idx="1">
-            <a:schemeClr val="accent1"/>
-          </a:lnRef>
-          <a:fillRef idx="3">
-            <a:schemeClr val="accent1"/>
-          </a:fillRef>
-          <a:effectRef idx="2">
-            <a:schemeClr val="accent1"/>
-          </a:effectRef>
-          <a:fontRef idx="minor">
-            <a:schemeClr val="lt1"/>
-          </a:fontRef>
-        </p:style>
-        <p:txBody>
-          <a:bodyPr rtlCol="0" anchor="ctr" wrap="none" lIns="0" rIns="0" tIns="0" bIns="0"/>
-          <a:lstStyle/>
-          <a:p>
-            <a:pPr algn="ctr"/>
-            <a:r>
-              <a:rPr sz="1100">
-                <a:solidFill>
-                  <a:srgbClr val="6B7280"/>
-                </a:solidFill>
-                <a:latin typeface="Arial"/>
-              </a:rPr>
-              <a:t>14 / 18</a:t>
-            </a:r>
-          </a:p>
-        </p:txBody>
-      </p:sp>
-      <p:sp>
-        <p:nvSpPr>
-          <p:cNvPr id="8" name="Oval 7"/>
-          <p:cNvSpPr/>
-          <p:nvPr/>
-        </p:nvSpPr>
-        <p:spPr>
-          <a:xfrm>
-            <a:off x="640080" y="1691640"/>
-            <a:ext cx="457200" cy="457200"/>
-          </a:xfrm>
-          <a:prstGeom prst="ellipse">
-            <a:avLst/>
-          </a:prstGeom>
-          <a:solidFill>
-            <a:srgbClr val="2563EB"/>
-          </a:solidFill>
-          <a:ln>
-            <a:noFill/>
-          </a:ln>
-          <a:effectLst/>
-        </p:spPr>
-        <p:style>
-          <a:lnRef idx="1">
-            <a:schemeClr val="accent1"/>
-          </a:lnRef>
-          <a:fillRef idx="3">
-            <a:schemeClr val="accent1"/>
-          </a:fillRef>
-          <a:effectRef idx="2">
-            <a:schemeClr val="accent1"/>
-          </a:effectRef>
-          <a:fontRef idx="minor">
-            <a:schemeClr val="lt1"/>
-          </a:fontRef>
-        </p:style>
-        <p:txBody>
-          <a:bodyPr rtlCol="0" anchor="ctr" lIns="0" rIns="0" tIns="0" bIns="0"/>
-          <a:lstStyle/>
-          <a:p>
-            <a:pPr algn="ctr"/>
-            <a:r>
-              <a:rPr sz="1600" b="1">
-                <a:solidFill>
-                  <a:srgbClr val="FFFFFF"/>
-                </a:solidFill>
-                <a:latin typeface="Arial"/>
-              </a:rPr>
-              <a:t>1</a:t>
-            </a:r>
-          </a:p>
-        </p:txBody>
-      </p:sp>
-      <p:sp>
-        <p:nvSpPr>
-          <p:cNvPr id="9" name="TextBox 8"/>
-          <p:cNvSpPr txBox="1"/>
-          <p:nvPr/>
-        </p:nvSpPr>
-        <p:spPr>
-          <a:xfrm>
-            <a:off x="1280160" y="1673352"/>
-            <a:ext cx="10241280" cy="1005840"/>
-          </a:xfrm>
-          <a:prstGeom prst="rect">
-            <a:avLst/>
-          </a:prstGeom>
-          <a:noFill/>
-        </p:spPr>
-        <p:txBody>
-          <a:bodyPr wrap="square" anchor="t" lIns="0" rIns="0" tIns="0" bIns="0">
-            <a:spAutoFit/>
-          </a:bodyPr>
-          <a:lstStyle/>
-          <a:p>
-            <a:pPr algn="l">
-              <a:lnSpc>
-                <a:spcPct val="110000"/>
-              </a:lnSpc>
-              <a:spcBef>
-                <a:spcPts val="0"/>
-              </a:spcBef>
-              <a:spcAft>
-                <a:spcPts val="600"/>
-              </a:spcAft>
-            </a:pPr>
-            <a:r>
-              <a:rPr sz="1500" b="1" i="0">
-                <a:solidFill>
-                  <a:srgbClr val="1E40AF"/>
-                </a:solidFill>
-                <a:latin typeface="Arial"/>
-              </a:rPr>
-              <a:t>Энкодер ResNet-50 — </a:t>
-            </a:r>
-            <a:r>
-              <a:rPr sz="1500" b="0" i="0">
-                <a:solidFill>
-                  <a:srgbClr val="1F2937"/>
-                </a:solidFill>
-                <a:latin typeface="Arial"/>
-              </a:rPr>
-              <a:t>извлечение признаков из SAR-тайла 256×256; предобучен на ImageNet, адаптирован к 1-канальному входу</a:t>
-            </a:r>
-          </a:p>
-        </p:txBody>
-      </p:sp>
-      <p:sp>
-        <p:nvSpPr>
-          <p:cNvPr id="10" name="Oval 9"/>
-          <p:cNvSpPr/>
-          <p:nvPr/>
-        </p:nvSpPr>
-        <p:spPr>
-          <a:xfrm>
-            <a:off x="640080" y="2770632"/>
-            <a:ext cx="457200" cy="457200"/>
-          </a:xfrm>
-          <a:prstGeom prst="ellipse">
-            <a:avLst/>
-          </a:prstGeom>
-          <a:solidFill>
-            <a:srgbClr val="2563EB"/>
-          </a:solidFill>
-          <a:ln>
-            <a:noFill/>
-          </a:ln>
-          <a:effectLst/>
-        </p:spPr>
-        <p:style>
-          <a:lnRef idx="1">
-            <a:schemeClr val="accent1"/>
-          </a:lnRef>
-          <a:fillRef idx="3">
-            <a:schemeClr val="accent1"/>
-          </a:fillRef>
-          <a:effectRef idx="2">
-            <a:schemeClr val="accent1"/>
-          </a:effectRef>
-          <a:fontRef idx="minor">
-            <a:schemeClr val="lt1"/>
-          </a:fontRef>
-        </p:style>
-        <p:txBody>
-          <a:bodyPr rtlCol="0" anchor="ctr" lIns="0" rIns="0" tIns="0" bIns="0"/>
-          <a:lstStyle/>
-          <a:p>
-            <a:pPr algn="ctr"/>
-            <a:r>
-              <a:rPr sz="1600" b="1">
-                <a:solidFill>
-                  <a:srgbClr val="FFFFFF"/>
-                </a:solidFill>
-                <a:latin typeface="Arial"/>
-              </a:rPr>
-              <a:t>2</a:t>
-            </a:r>
-          </a:p>
-        </p:txBody>
-      </p:sp>
-      <p:sp>
-        <p:nvSpPr>
-          <p:cNvPr id="11" name="TextBox 10"/>
-          <p:cNvSpPr txBox="1"/>
-          <p:nvPr/>
-        </p:nvSpPr>
-        <p:spPr>
-          <a:xfrm>
-            <a:off x="1280160" y="2752344"/>
-            <a:ext cx="10241280" cy="1005840"/>
-          </a:xfrm>
-          <a:prstGeom prst="rect">
-            <a:avLst/>
-          </a:prstGeom>
-          <a:noFill/>
-        </p:spPr>
-        <p:txBody>
-          <a:bodyPr wrap="square" anchor="t" lIns="0" rIns="0" tIns="0" bIns="0">
-            <a:spAutoFit/>
-          </a:bodyPr>
-          <a:lstStyle/>
-          <a:p>
-            <a:pPr algn="l">
-              <a:lnSpc>
-                <a:spcPct val="110000"/>
-              </a:lnSpc>
-              <a:spcBef>
-                <a:spcPts val="0"/>
-              </a:spcBef>
-              <a:spcAft>
-                <a:spcPts val="600"/>
-              </a:spcAft>
-            </a:pPr>
-            <a:r>
-              <a:rPr sz="1500" b="1" i="0">
-                <a:solidFill>
-                  <a:srgbClr val="1E40AF"/>
-                </a:solidFill>
-                <a:latin typeface="Arial"/>
-              </a:rPr>
-              <a:t>ASPP — </a:t>
-            </a:r>
-            <a:r>
-              <a:rPr sz="1500" b="0" i="0">
-                <a:solidFill>
-                  <a:srgbClr val="1F2937"/>
-                </a:solidFill>
-                <a:latin typeface="Arial"/>
-              </a:rPr>
-              <a:t>Atrous Spatial Pyramid Pooling — параллельные свёртки с коэффициентами разрежения 6/12/18 + image-level pooling: охват разномасштабного контекста пятен</a:t>
-            </a:r>
-          </a:p>
-        </p:txBody>
-      </p:sp>
-      <p:sp>
-        <p:nvSpPr>
-          <p:cNvPr id="12" name="Oval 11"/>
-          <p:cNvSpPr/>
-          <p:nvPr/>
-        </p:nvSpPr>
-        <p:spPr>
-          <a:xfrm>
-            <a:off x="640080" y="3849624"/>
-            <a:ext cx="457200" cy="457200"/>
-          </a:xfrm>
-          <a:prstGeom prst="ellipse">
-            <a:avLst/>
-          </a:prstGeom>
-          <a:solidFill>
-            <a:srgbClr val="2563EB"/>
-          </a:solidFill>
-          <a:ln>
-            <a:noFill/>
-          </a:ln>
-          <a:effectLst/>
-        </p:spPr>
-        <p:style>
-          <a:lnRef idx="1">
-            <a:schemeClr val="accent1"/>
-          </a:lnRef>
-          <a:fillRef idx="3">
-            <a:schemeClr val="accent1"/>
-          </a:fillRef>
-          <a:effectRef idx="2">
-            <a:schemeClr val="accent1"/>
-          </a:effectRef>
-          <a:fontRef idx="minor">
-            <a:schemeClr val="lt1"/>
-          </a:fontRef>
-        </p:style>
-        <p:txBody>
-          <a:bodyPr rtlCol="0" anchor="ctr" lIns="0" rIns="0" tIns="0" bIns="0"/>
-          <a:lstStyle/>
-          <a:p>
-            <a:pPr algn="ctr"/>
-            <a:r>
-              <a:rPr sz="1600" b="1">
-                <a:solidFill>
-                  <a:srgbClr val="FFFFFF"/>
-                </a:solidFill>
-                <a:latin typeface="Arial"/>
-              </a:rPr>
-              <a:t>3</a:t>
-            </a:r>
-          </a:p>
-        </p:txBody>
-      </p:sp>
-      <p:sp>
-        <p:nvSpPr>
-          <p:cNvPr id="13" name="TextBox 12"/>
-          <p:cNvSpPr txBox="1"/>
-          <p:nvPr/>
-        </p:nvSpPr>
-        <p:spPr>
-          <a:xfrm>
-            <a:off x="1280160" y="3831336"/>
-            <a:ext cx="10241280" cy="1005840"/>
-          </a:xfrm>
-          <a:prstGeom prst="rect">
-            <a:avLst/>
-          </a:prstGeom>
-          <a:noFill/>
-        </p:spPr>
-        <p:txBody>
-          <a:bodyPr wrap="square" anchor="t" lIns="0" rIns="0" tIns="0" bIns="0">
-            <a:spAutoFit/>
-          </a:bodyPr>
-          <a:lstStyle/>
-          <a:p>
-            <a:pPr algn="l">
-              <a:lnSpc>
-                <a:spcPct val="110000"/>
-              </a:lnSpc>
-              <a:spcBef>
-                <a:spcPts val="0"/>
-              </a:spcBef>
-              <a:spcAft>
-                <a:spcPts val="600"/>
-              </a:spcAft>
-            </a:pPr>
-            <a:r>
-              <a:rPr sz="1500" b="1" i="0">
-                <a:solidFill>
-                  <a:srgbClr val="1E40AF"/>
-                </a:solidFill>
-                <a:latin typeface="Arial"/>
-              </a:rPr>
-              <a:t>scSE-внимание — </a:t>
-            </a:r>
-            <a:r>
-              <a:rPr sz="1500" b="0" i="0">
-                <a:solidFill>
-                  <a:srgbClr val="1F2937"/>
-                </a:solidFill>
-                <a:latin typeface="Arial"/>
-              </a:rPr>
-              <a:t>spatial + channel Squeeze-and-Excitation: усиление информативных каналов и пространственных зон</a:t>
-            </a:r>
-          </a:p>
-        </p:txBody>
-      </p:sp>
-      <p:sp>
-        <p:nvSpPr>
-          <p:cNvPr id="14" name="Oval 13"/>
-          <p:cNvSpPr/>
-          <p:nvPr/>
-        </p:nvSpPr>
-        <p:spPr>
-          <a:xfrm>
-            <a:off x="640080" y="4928616"/>
-            <a:ext cx="457200" cy="457200"/>
-          </a:xfrm>
-          <a:prstGeom prst="ellipse">
-            <a:avLst/>
-          </a:prstGeom>
-          <a:solidFill>
-            <a:srgbClr val="2563EB"/>
-          </a:solidFill>
-          <a:ln>
-            <a:noFill/>
-          </a:ln>
-          <a:effectLst/>
-        </p:spPr>
-        <p:style>
-          <a:lnRef idx="1">
-            <a:schemeClr val="accent1"/>
-          </a:lnRef>
-          <a:fillRef idx="3">
-            <a:schemeClr val="accent1"/>
-          </a:fillRef>
-          <a:effectRef idx="2">
-            <a:schemeClr val="accent1"/>
-          </a:effectRef>
-          <a:fontRef idx="minor">
-            <a:schemeClr val="lt1"/>
-          </a:fontRef>
-        </p:style>
-        <p:txBody>
-          <a:bodyPr rtlCol="0" anchor="ctr" lIns="0" rIns="0" tIns="0" bIns="0"/>
-          <a:lstStyle/>
-          <a:p>
-            <a:pPr algn="ctr"/>
-            <a:r>
-              <a:rPr sz="1600" b="1">
-                <a:solidFill>
-                  <a:srgbClr val="FFFFFF"/>
-                </a:solidFill>
-                <a:latin typeface="Arial"/>
-              </a:rPr>
-              <a:t>4</a:t>
-            </a:r>
-          </a:p>
-        </p:txBody>
-      </p:sp>
-      <p:sp>
-        <p:nvSpPr>
-          <p:cNvPr id="15" name="TextBox 14"/>
-          <p:cNvSpPr txBox="1"/>
-          <p:nvPr/>
-        </p:nvSpPr>
-        <p:spPr>
-          <a:xfrm>
-            <a:off x="1280160" y="4910328"/>
-            <a:ext cx="10241280" cy="1005840"/>
-          </a:xfrm>
-          <a:prstGeom prst="rect">
-            <a:avLst/>
-          </a:prstGeom>
-          <a:noFill/>
-        </p:spPr>
-        <p:txBody>
-          <a:bodyPr wrap="square" anchor="t" lIns="0" rIns="0" tIns="0" bIns="0">
-            <a:spAutoFit/>
-          </a:bodyPr>
-          <a:lstStyle/>
-          <a:p>
-            <a:pPr algn="l">
-              <a:lnSpc>
-                <a:spcPct val="110000"/>
-              </a:lnSpc>
-              <a:spcBef>
-                <a:spcPts val="0"/>
-              </a:spcBef>
-              <a:spcAft>
-                <a:spcPts val="600"/>
-              </a:spcAft>
-            </a:pPr>
-            <a:r>
-              <a:rPr sz="1500" b="1" i="0">
-                <a:solidFill>
-                  <a:srgbClr val="1E40AF"/>
-                </a:solidFill>
-                <a:latin typeface="Arial"/>
-              </a:rPr>
-              <a:t>Декодер — </a:t>
-            </a:r>
-            <a:r>
-              <a:rPr sz="1500" b="0" i="0">
-                <a:solidFill>
-                  <a:srgbClr val="1F2937"/>
-                </a:solidFill>
-                <a:latin typeface="Arial"/>
-              </a:rPr>
-              <a:t>объединение низко- и высокоуровневых признаков, апсемплинг до исходного разрешения, попиксельная классификация на 3 класса</a:t>
-            </a:r>
-          </a:p>
-        </p:txBody>
-      </p:sp>
-    </p:spTree>
-  </p:cSld>
-  <p:clrMapOvr>
-    <a:masterClrMapping/>
-  </p:clrMapOvr>
-</p:sld>
-</file>
-
-<file path=ppt/slides/slide15.xml><?xml version="1.0" encoding="utf-8"?>
-<p:sld xmlns:a="http://schemas.openxmlformats.org/drawingml/2006/main" xmlns:p="http://schemas.openxmlformats.org/presentationml/2006/main" xmlns:r="http://schemas.openxmlformats.org/officeDocument/2006/relationships">
-  <p:cSld>
-    <p:spTree>
-      <p:nvGrpSpPr>
-        <p:cNvPr id="1" name=""/>
-        <p:cNvGrpSpPr/>
-        <p:nvPr/>
-      </p:nvGrpSpPr>
-      <p:grpSpPr/>
-      <p:sp>
-        <p:nvSpPr>
-          <p:cNvPr id="2" name="Rectangle 1"/>
-          <p:cNvSpPr/>
-          <p:nvPr/>
-        </p:nvSpPr>
-        <p:spPr>
-          <a:xfrm>
-            <a:off x="0" y="0"/>
-            <a:ext cx="12191695" cy="6858000"/>
-          </a:xfrm>
-          <a:prstGeom prst="rect">
-            <a:avLst/>
-          </a:prstGeom>
-          <a:solidFill>
-            <a:srgbClr val="FFFFFF"/>
-          </a:solidFill>
-          <a:ln>
-            <a:noFill/>
-          </a:ln>
-          <a:effectLst/>
-        </p:spPr>
-        <p:style>
-          <a:lnRef idx="1">
-            <a:schemeClr val="accent1"/>
-          </a:lnRef>
-          <a:fillRef idx="3">
-            <a:schemeClr val="accent1"/>
-          </a:fillRef>
-          <a:effectRef idx="2">
-            <a:schemeClr val="accent1"/>
-          </a:effectRef>
-          <a:fontRef idx="minor">
-            <a:schemeClr val="lt1"/>
-          </a:fontRef>
-        </p:style>
-        <p:txBody>
-          <a:bodyPr rtlCol="0" anchor="ctr"/>
-          <a:lstStyle/>
-          <a:p>
-            <a:pPr algn="ctr"/>
-          </a:p>
-        </p:txBody>
-      </p:sp>
-      <p:sp>
-        <p:nvSpPr>
-          <p:cNvPr id="3" name="Rectangle 2"/>
-          <p:cNvSpPr/>
-          <p:nvPr/>
-        </p:nvSpPr>
-        <p:spPr>
-          <a:xfrm>
-            <a:off x="0" y="0"/>
-            <a:ext cx="146304" cy="6858000"/>
-          </a:xfrm>
-          <a:prstGeom prst="rect">
-            <a:avLst/>
-          </a:prstGeom>
-          <a:solidFill>
-            <a:srgbClr val="2563EB"/>
-          </a:solidFill>
-          <a:ln>
-            <a:noFill/>
-          </a:ln>
-          <a:effectLst/>
-        </p:spPr>
-        <p:style>
-          <a:lnRef idx="1">
-            <a:schemeClr val="accent1"/>
-          </a:lnRef>
-          <a:fillRef idx="3">
-            <a:schemeClr val="accent1"/>
-          </a:fillRef>
-          <a:effectRef idx="2">
-            <a:schemeClr val="accent1"/>
-          </a:effectRef>
-          <a:fontRef idx="minor">
-            <a:schemeClr val="lt1"/>
-          </a:fontRef>
-        </p:style>
-        <p:txBody>
-          <a:bodyPr rtlCol="0" anchor="ctr"/>
-          <a:lstStyle/>
-          <a:p>
-            <a:pPr algn="ctr"/>
-          </a:p>
-        </p:txBody>
-      </p:sp>
-      <p:sp>
-        <p:nvSpPr>
-          <p:cNvPr id="4" name="TextBox 3"/>
-          <p:cNvSpPr txBox="1"/>
-          <p:nvPr/>
-        </p:nvSpPr>
-        <p:spPr>
-          <a:xfrm>
-            <a:off x="640080" y="310896"/>
-            <a:ext cx="10058400" cy="274320"/>
-          </a:xfrm>
-          <a:prstGeom prst="rect">
-            <a:avLst/>
-          </a:prstGeom>
-          <a:noFill/>
-        </p:spPr>
-        <p:txBody>
-          <a:bodyPr wrap="square" anchor="t" lIns="0" rIns="0" tIns="0" bIns="0">
-            <a:spAutoFit/>
-          </a:bodyPr>
-          <a:lstStyle/>
-          <a:p>
-            <a:pPr algn="l">
-              <a:lnSpc>
-                <a:spcPct val="105000"/>
-              </a:lnSpc>
-              <a:spcBef>
-                <a:spcPts val="0"/>
-              </a:spcBef>
-              <a:spcAft>
-                <a:spcPts val="600"/>
-              </a:spcAft>
-            </a:pPr>
-            <a:r>
-              <a:rPr sz="1100" b="1" i="0">
-                <a:solidFill>
-                  <a:srgbClr val="6B7280"/>
-                </a:solidFill>
-                <a:latin typeface="Arial"/>
-              </a:rPr>
-              <a:t>РЕЗЕРВНЫЙ СЛАЙД</a:t>
-            </a:r>
-          </a:p>
-        </p:txBody>
-      </p:sp>
-      <p:sp>
-        <p:nvSpPr>
-          <p:cNvPr id="5" name="TextBox 4"/>
-          <p:cNvSpPr txBox="1"/>
-          <p:nvPr/>
-        </p:nvSpPr>
-        <p:spPr>
-          <a:xfrm>
-            <a:off x="640080" y="566928"/>
-            <a:ext cx="10972800" cy="731520"/>
-          </a:xfrm>
-          <a:prstGeom prst="rect">
-            <a:avLst/>
-          </a:prstGeom>
-          <a:noFill/>
-        </p:spPr>
-        <p:txBody>
-          <a:bodyPr wrap="square" anchor="t" lIns="0" rIns="0" tIns="0" bIns="0">
-            <a:spAutoFit/>
-          </a:bodyPr>
-          <a:lstStyle/>
-          <a:p>
-            <a:pPr algn="l">
-              <a:lnSpc>
-                <a:spcPct val="105000"/>
-              </a:lnSpc>
-              <a:spcBef>
-                <a:spcPts val="0"/>
-              </a:spcBef>
-              <a:spcAft>
-                <a:spcPts val="600"/>
-              </a:spcAft>
-            </a:pPr>
-            <a:r>
-              <a:rPr sz="3000" b="1" i="0">
-                <a:solidFill>
-                  <a:srgbClr val="2563EB"/>
-                </a:solidFill>
-                <a:latin typeface="Arial"/>
-              </a:rPr>
-              <a:t>Функция потерь и гиперпараметры</a:t>
-            </a:r>
-          </a:p>
-        </p:txBody>
-      </p:sp>
-      <p:sp>
-        <p:nvSpPr>
-          <p:cNvPr id="6" name="Rectangle 5"/>
-          <p:cNvSpPr/>
-          <p:nvPr/>
-        </p:nvSpPr>
-        <p:spPr>
-          <a:xfrm>
-            <a:off x="640080" y="1225296"/>
-            <a:ext cx="2011680" cy="38100"/>
-          </a:xfrm>
-          <a:prstGeom prst="rect">
-            <a:avLst/>
-          </a:prstGeom>
-          <a:solidFill>
-            <a:srgbClr val="2563EB"/>
-          </a:solidFill>
-          <a:ln>
-            <a:noFill/>
-          </a:ln>
-          <a:effectLst/>
-        </p:spPr>
-        <p:style>
-          <a:lnRef idx="1">
-            <a:schemeClr val="accent1"/>
-          </a:lnRef>
-          <a:fillRef idx="3">
-            <a:schemeClr val="accent1"/>
-          </a:fillRef>
-          <a:effectRef idx="2">
-            <a:schemeClr val="accent1"/>
-          </a:effectRef>
-          <a:fontRef idx="minor">
-            <a:schemeClr val="lt1"/>
-          </a:fontRef>
-        </p:style>
-        <p:txBody>
-          <a:bodyPr rtlCol="0" anchor="ctr"/>
-          <a:lstStyle/>
-          <a:p>
-            <a:pPr algn="ctr"/>
-          </a:p>
-        </p:txBody>
-      </p:sp>
-      <p:sp>
-        <p:nvSpPr>
-          <p:cNvPr id="7" name="Rounded Rectangle 6"/>
-          <p:cNvSpPr/>
-          <p:nvPr/>
-        </p:nvSpPr>
-        <p:spPr>
-          <a:xfrm>
-            <a:off x="11140135" y="6355080"/>
-            <a:ext cx="777240" cy="310896"/>
-          </a:xfrm>
-          <a:prstGeom prst="roundRect">
-            <a:avLst/>
-          </a:prstGeom>
-          <a:solidFill>
-            <a:srgbClr val="F3F6FC"/>
-          </a:solidFill>
-          <a:ln w="9525">
-            <a:solidFill>
-              <a:srgbClr val="E2E8F0"/>
-            </a:solidFill>
-          </a:ln>
-          <a:effectLst/>
-        </p:spPr>
-        <p:style>
-          <a:lnRef idx="1">
-            <a:schemeClr val="accent1"/>
-          </a:lnRef>
-          <a:fillRef idx="3">
-            <a:schemeClr val="accent1"/>
-          </a:fillRef>
-          <a:effectRef idx="2">
-            <a:schemeClr val="accent1"/>
-          </a:effectRef>
-          <a:fontRef idx="minor">
-            <a:schemeClr val="lt1"/>
-          </a:fontRef>
-        </p:style>
-        <p:txBody>
-          <a:bodyPr rtlCol="0" anchor="ctr" wrap="none" lIns="0" rIns="0" tIns="0" bIns="0"/>
-          <a:lstStyle/>
-          <a:p>
-            <a:pPr algn="ctr"/>
-            <a:r>
-              <a:rPr sz="1100">
-                <a:solidFill>
-                  <a:srgbClr val="6B7280"/>
-                </a:solidFill>
-                <a:latin typeface="Arial"/>
-              </a:rPr>
-              <a:t>15 / 18</a:t>
-            </a:r>
-          </a:p>
-        </p:txBody>
-      </p:sp>
-      <p:sp>
-        <p:nvSpPr>
-          <p:cNvPr id="8" name="TextBox 7"/>
-          <p:cNvSpPr txBox="1"/>
-          <p:nvPr/>
-        </p:nvSpPr>
-        <p:spPr>
-          <a:xfrm>
-            <a:off x="640080" y="1600200"/>
-            <a:ext cx="5486400" cy="365760"/>
-          </a:xfrm>
-          <a:prstGeom prst="rect">
-            <a:avLst/>
-          </a:prstGeom>
-          <a:noFill/>
-        </p:spPr>
-        <p:txBody>
-          <a:bodyPr wrap="square" anchor="t" lIns="0" rIns="0" tIns="0" bIns="0">
-            <a:spAutoFit/>
-          </a:bodyPr>
-          <a:lstStyle/>
-          <a:p>
-            <a:pPr algn="l">
-              <a:lnSpc>
-                <a:spcPct val="105000"/>
-              </a:lnSpc>
-              <a:spcBef>
-                <a:spcPts val="0"/>
-              </a:spcBef>
-              <a:spcAft>
-                <a:spcPts val="600"/>
-              </a:spcAft>
-            </a:pPr>
-            <a:r>
-              <a:rPr sz="1600" b="1" i="0">
-                <a:solidFill>
-                  <a:srgbClr val="1F2937"/>
-                </a:solidFill>
-                <a:latin typeface="Arial"/>
-              </a:rPr>
-              <a:t>Комбинированная функция потерь Dice-BCE</a:t>
-            </a:r>
-          </a:p>
-        </p:txBody>
-      </p:sp>
-      <p:sp>
-        <p:nvSpPr>
-          <p:cNvPr id="9" name="TextBox 8"/>
-          <p:cNvSpPr txBox="1"/>
-          <p:nvPr/>
-        </p:nvSpPr>
-        <p:spPr>
-          <a:xfrm>
-            <a:off x="640080" y="2057400"/>
-            <a:ext cx="5394960" cy="914400"/>
-          </a:xfrm>
-          <a:prstGeom prst="rect">
-            <a:avLst/>
-          </a:prstGeom>
-          <a:noFill/>
-        </p:spPr>
-        <p:txBody>
-          <a:bodyPr wrap="square" anchor="t" lIns="0" rIns="0" tIns="0" bIns="0">
-            <a:spAutoFit/>
-          </a:bodyPr>
-          <a:lstStyle/>
-          <a:p>
-            <a:pPr algn="l">
-              <a:lnSpc>
-                <a:spcPct val="115000"/>
-              </a:lnSpc>
-              <a:spcBef>
-                <a:spcPts val="0"/>
-              </a:spcBef>
-              <a:spcAft>
-                <a:spcPts val="600"/>
-              </a:spcAft>
-            </a:pPr>
-            <a:r>
-              <a:rPr sz="1400" b="0" i="0">
-                <a:solidFill>
-                  <a:srgbClr val="1F2937"/>
-                </a:solidFill>
-                <a:latin typeface="Arial"/>
-              </a:rPr>
-              <a:t>L = L_Dice + L_BCE с весами классов для устранения дисбаланса. Dice работает с перекрытием масок, BCE — с попиксельной вероятностью.</a:t>
-            </a:r>
-          </a:p>
-        </p:txBody>
-      </p:sp>
-      <p:graphicFrame>
-        <p:nvGraphicFramePr>
-          <p:cNvPr id="10" name="Table 9"/>
-          <p:cNvGraphicFramePr>
-            <a:graphicFrameLocks noGrp="1"/>
-          </p:cNvGraphicFramePr>
-          <p:nvPr/>
-        </p:nvGraphicFramePr>
-        <p:xfrm>
-          <a:off x="640080" y="3291840"/>
-          <a:ext cx="3657600" cy="1828800"/>
-        </p:xfrm>
-        <a:graphic>
-          <a:graphicData uri="http://schemas.openxmlformats.org/drawingml/2006/table">
-            <a:tbl>
-              <a:tblPr>
-                <a:tableStyleId>{5C22544A-7EE6-4342-B048-85BDC9FD1C3A}</a:tableStyleId>
-              </a:tblPr>
-              <a:tblGrid>
-                <a:gridCol w="2194560"/>
-                <a:gridCol w="1463040"/>
-              </a:tblGrid>
-              <a:tr h="457200">
-                <a:tc>
-                  <a:txBody>
-                    <a:bodyPr/>
-                    <a:lstStyle/>
-                    <a:p>
-                      <a:pPr algn="l"/>
-                      <a:r>
-                        <a:rPr sz="1200" b="1">
-                          <a:solidFill>
-                            <a:srgbClr val="1E40AF"/>
-                          </a:solidFill>
-                          <a:latin typeface="Arial"/>
-                        </a:rPr>
-                        <a:t>Класс</a:t>
-                      </a:r>
-                    </a:p>
-                  </a:txBody>
-                  <a:tcPr marL="73152" marR="54864" marT="27432" marB="27432" anchor="ctr">
-                    <a:solidFill>
-                      <a:srgbClr val="DBEAFE"/>
-                    </a:solidFill>
-                  </a:tcPr>
-                </a:tc>
-                <a:tc>
-                  <a:txBody>
-                    <a:bodyPr/>
-                    <a:lstStyle/>
-                    <a:p>
-                      <a:pPr algn="ctr"/>
-                      <a:r>
-                        <a:rPr sz="1200" b="1">
-                          <a:solidFill>
-                            <a:srgbClr val="1E40AF"/>
-                          </a:solidFill>
-                          <a:latin typeface="Arial"/>
-                        </a:rPr>
-                        <a:t>Вес</a:t>
-                      </a:r>
-                    </a:p>
-                  </a:txBody>
-                  <a:tcPr marL="73152" marR="54864" marT="27432" marB="27432" anchor="ctr">
-                    <a:solidFill>
-                      <a:srgbClr val="DBEAFE"/>
-                    </a:solidFill>
-                  </a:tcPr>
-                </a:tc>
-              </a:tr>
-              <a:tr h="457200">
-                <a:tc>
-                  <a:txBody>
-                    <a:bodyPr/>
-                    <a:lstStyle/>
-                    <a:p>
-                      <a:pPr algn="l"/>
-                      <a:r>
-                        <a:rPr sz="1200" b="1">
-                          <a:solidFill>
-                            <a:srgbClr val="1F2937"/>
-                          </a:solidFill>
-                          <a:latin typeface="Arial"/>
-                        </a:rPr>
-                        <a:t>вода</a:t>
-                      </a:r>
-                    </a:p>
-                  </a:txBody>
-                  <a:tcPr marL="73152" marR="54864" marT="27432" marB="27432" anchor="ctr">
-                    <a:solidFill>
-                      <a:srgbClr val="FFFFFF"/>
-                    </a:solidFill>
-                  </a:tcPr>
-                </a:tc>
-                <a:tc>
-                  <a:txBody>
-                    <a:bodyPr/>
-                    <a:lstStyle/>
-                    <a:p>
-                      <a:pPr algn="ctr"/>
-                      <a:r>
-                        <a:rPr sz="1200" b="0">
-                          <a:solidFill>
-                            <a:srgbClr val="1F2937"/>
-                          </a:solidFill>
-                          <a:latin typeface="Arial"/>
-                        </a:rPr>
-                        <a:t>0,3</a:t>
-                      </a:r>
-                    </a:p>
-                  </a:txBody>
-                  <a:tcPr marL="73152" marR="54864" marT="27432" marB="27432" anchor="ctr">
-                    <a:solidFill>
-                      <a:srgbClr val="FFFFFF"/>
-                    </a:solidFill>
-                  </a:tcPr>
-                </a:tc>
-              </a:tr>
-              <a:tr h="457200">
-                <a:tc>
-                  <a:txBody>
-                    <a:bodyPr/>
-                    <a:lstStyle/>
-                    <a:p>
-                      <a:pPr algn="l"/>
-                      <a:r>
-                        <a:rPr sz="1200" b="1">
-                          <a:solidFill>
-                            <a:srgbClr val="1F2937"/>
-                          </a:solidFill>
-                          <a:latin typeface="Arial"/>
-                        </a:rPr>
-                        <a:t>нефть</a:t>
-                      </a:r>
-                    </a:p>
-                  </a:txBody>
-                  <a:tcPr marL="73152" marR="54864" marT="27432" marB="27432" anchor="ctr">
-                    <a:solidFill>
-                      <a:srgbClr val="F3F6FC"/>
-                    </a:solidFill>
-                  </a:tcPr>
-                </a:tc>
-                <a:tc>
-                  <a:txBody>
-                    <a:bodyPr/>
-                    <a:lstStyle/>
-                    <a:p>
-                      <a:pPr algn="ctr"/>
-                      <a:r>
-                        <a:rPr sz="1200" b="0">
-                          <a:solidFill>
-                            <a:srgbClr val="1F2937"/>
-                          </a:solidFill>
-                          <a:latin typeface="Arial"/>
-                        </a:rPr>
-                        <a:t>9,8</a:t>
-                      </a:r>
-                    </a:p>
-                  </a:txBody>
-                  <a:tcPr marL="73152" marR="54864" marT="27432" marB="27432" anchor="ctr">
-                    <a:solidFill>
-                      <a:srgbClr val="F3F6FC"/>
-                    </a:solidFill>
-                  </a:tcPr>
-                </a:tc>
-              </a:tr>
-              <a:tr h="457200">
-                <a:tc>
-                  <a:txBody>
-                    <a:bodyPr/>
-                    <a:lstStyle/>
-                    <a:p>
-                      <a:pPr algn="l"/>
-                      <a:r>
-                        <a:rPr sz="1200" b="1">
-                          <a:solidFill>
-                            <a:srgbClr val="1F2937"/>
-                          </a:solidFill>
-                          <a:latin typeface="Arial"/>
-                        </a:rPr>
-                        <a:t>лёд + суша</a:t>
-                      </a:r>
-                    </a:p>
-                  </a:txBody>
-                  <a:tcPr marL="73152" marR="54864" marT="27432" marB="27432" anchor="ctr">
-                    <a:solidFill>
-                      <a:srgbClr val="FFFFFF"/>
-                    </a:solidFill>
-                  </a:tcPr>
-                </a:tc>
-                <a:tc>
-                  <a:txBody>
-                    <a:bodyPr/>
-                    <a:lstStyle/>
-                    <a:p>
-                      <a:pPr algn="ctr"/>
-                      <a:r>
-                        <a:rPr sz="1200" b="0">
-                          <a:solidFill>
-                            <a:srgbClr val="1F2937"/>
-                          </a:solidFill>
-                          <a:latin typeface="Arial"/>
-                        </a:rPr>
-                        <a:t>1,2</a:t>
-                      </a:r>
-                    </a:p>
-                  </a:txBody>
-                  <a:tcPr marL="73152" marR="54864" marT="27432" marB="27432" anchor="ctr">
-                    <a:solidFill>
-                      <a:srgbClr val="FFFFFF"/>
-                    </a:solidFill>
-                  </a:tcPr>
-                </a:tc>
-              </a:tr>
-            </a:tbl>
-          </a:graphicData>
-        </a:graphic>
-      </p:graphicFrame>
-      <p:sp>
-        <p:nvSpPr>
-          <p:cNvPr id="11" name="TextBox 10"/>
-          <p:cNvSpPr txBox="1"/>
-          <p:nvPr/>
-        </p:nvSpPr>
-        <p:spPr>
-          <a:xfrm>
-            <a:off x="6400800" y="1600200"/>
-            <a:ext cx="5120640" cy="365760"/>
-          </a:xfrm>
-          <a:prstGeom prst="rect">
-            <a:avLst/>
-          </a:prstGeom>
-          <a:noFill/>
-        </p:spPr>
-        <p:txBody>
-          <a:bodyPr wrap="square" anchor="t" lIns="0" rIns="0" tIns="0" bIns="0">
-            <a:spAutoFit/>
-          </a:bodyPr>
-          <a:lstStyle/>
-          <a:p>
-            <a:pPr algn="l">
-              <a:lnSpc>
-                <a:spcPct val="105000"/>
-              </a:lnSpc>
-              <a:spcBef>
-                <a:spcPts val="0"/>
-              </a:spcBef>
-              <a:spcAft>
-                <a:spcPts val="600"/>
-              </a:spcAft>
-            </a:pPr>
-            <a:r>
-              <a:rPr sz="1600" b="1" i="0">
-                <a:solidFill>
-                  <a:srgbClr val="1F2937"/>
-                </a:solidFill>
-                <a:latin typeface="Arial"/>
-              </a:rPr>
-              <a:t>Параметры обучения</a:t>
-            </a:r>
-          </a:p>
-        </p:txBody>
-      </p:sp>
-      <p:sp>
-        <p:nvSpPr>
-          <p:cNvPr id="12" name="TextBox 11"/>
-          <p:cNvSpPr txBox="1"/>
-          <p:nvPr/>
-        </p:nvSpPr>
-        <p:spPr>
-          <a:xfrm>
-            <a:off x="6400800" y="2103120"/>
-            <a:ext cx="2743200" cy="365760"/>
-          </a:xfrm>
-          <a:prstGeom prst="rect">
-            <a:avLst/>
-          </a:prstGeom>
-          <a:noFill/>
-        </p:spPr>
-        <p:txBody>
-          <a:bodyPr wrap="square" anchor="t" lIns="0" rIns="0" tIns="0" bIns="0">
-            <a:spAutoFit/>
-          </a:bodyPr>
-          <a:lstStyle/>
-          <a:p>
-            <a:pPr algn="l">
-              <a:lnSpc>
-                <a:spcPct val="105000"/>
-              </a:lnSpc>
-              <a:spcBef>
-                <a:spcPts val="0"/>
-              </a:spcBef>
-              <a:spcAft>
-                <a:spcPts val="600"/>
-              </a:spcAft>
-            </a:pPr>
-            <a:r>
-              <a:rPr sz="1400" b="1" i="0">
-                <a:solidFill>
-                  <a:srgbClr val="6B7280"/>
-                </a:solidFill>
-                <a:latin typeface="Arial"/>
-              </a:rPr>
-              <a:t>Оптимизатор</a:t>
-            </a:r>
-          </a:p>
-        </p:txBody>
-      </p:sp>
-      <p:sp>
-        <p:nvSpPr>
-          <p:cNvPr id="13" name="TextBox 12"/>
-          <p:cNvSpPr txBox="1"/>
-          <p:nvPr/>
-        </p:nvSpPr>
-        <p:spPr>
-          <a:xfrm>
-            <a:off x="9144000" y="2103120"/>
-            <a:ext cx="2377440" cy="365760"/>
-          </a:xfrm>
-          <a:prstGeom prst="rect">
-            <a:avLst/>
-          </a:prstGeom>
-          <a:noFill/>
-        </p:spPr>
-        <p:txBody>
-          <a:bodyPr wrap="square" anchor="t" lIns="0" rIns="0" tIns="0" bIns="0">
-            <a:spAutoFit/>
-          </a:bodyPr>
-          <a:lstStyle/>
-          <a:p>
-            <a:pPr algn="l">
-              <a:lnSpc>
-                <a:spcPct val="105000"/>
-              </a:lnSpc>
-              <a:spcBef>
-                <a:spcPts val="0"/>
-              </a:spcBef>
-              <a:spcAft>
-                <a:spcPts val="600"/>
-              </a:spcAft>
-            </a:pPr>
-            <a:r>
-              <a:rPr sz="1400" b="0" i="0">
-                <a:solidFill>
-                  <a:srgbClr val="1F2937"/>
-                </a:solidFill>
-                <a:latin typeface="Arial"/>
-              </a:rPr>
-              <a:t>AdamW</a:t>
-            </a:r>
-          </a:p>
-        </p:txBody>
-      </p:sp>
-      <p:sp>
-        <p:nvSpPr>
-          <p:cNvPr id="14" name="TextBox 13"/>
-          <p:cNvSpPr txBox="1"/>
-          <p:nvPr/>
-        </p:nvSpPr>
-        <p:spPr>
-          <a:xfrm>
-            <a:off x="6400800" y="2670048"/>
-            <a:ext cx="2743200" cy="365760"/>
-          </a:xfrm>
-          <a:prstGeom prst="rect">
-            <a:avLst/>
-          </a:prstGeom>
-          <a:noFill/>
-        </p:spPr>
-        <p:txBody>
-          <a:bodyPr wrap="square" anchor="t" lIns="0" rIns="0" tIns="0" bIns="0">
-            <a:spAutoFit/>
-          </a:bodyPr>
-          <a:lstStyle/>
-          <a:p>
-            <a:pPr algn="l">
-              <a:lnSpc>
-                <a:spcPct val="105000"/>
-              </a:lnSpc>
-              <a:spcBef>
-                <a:spcPts val="0"/>
-              </a:spcBef>
-              <a:spcAft>
-                <a:spcPts val="600"/>
-              </a:spcAft>
-            </a:pPr>
-            <a:r>
-              <a:rPr sz="1400" b="1" i="0">
-                <a:solidFill>
-                  <a:srgbClr val="6B7280"/>
-                </a:solidFill>
-                <a:latin typeface="Arial"/>
-              </a:rPr>
-              <a:t>Learning rate</a:t>
-            </a:r>
-          </a:p>
-        </p:txBody>
-      </p:sp>
-      <p:sp>
-        <p:nvSpPr>
-          <p:cNvPr id="15" name="TextBox 14"/>
-          <p:cNvSpPr txBox="1"/>
-          <p:nvPr/>
-        </p:nvSpPr>
-        <p:spPr>
-          <a:xfrm>
-            <a:off x="9144000" y="2670048"/>
-            <a:ext cx="2377440" cy="365760"/>
-          </a:xfrm>
-          <a:prstGeom prst="rect">
-            <a:avLst/>
-          </a:prstGeom>
-          <a:noFill/>
-        </p:spPr>
-        <p:txBody>
-          <a:bodyPr wrap="square" anchor="t" lIns="0" rIns="0" tIns="0" bIns="0">
-            <a:spAutoFit/>
-          </a:bodyPr>
-          <a:lstStyle/>
-          <a:p>
-            <a:pPr algn="l">
-              <a:lnSpc>
-                <a:spcPct val="105000"/>
-              </a:lnSpc>
-              <a:spcBef>
-                <a:spcPts val="0"/>
-              </a:spcBef>
-              <a:spcAft>
-                <a:spcPts val="600"/>
-              </a:spcAft>
-            </a:pPr>
-            <a:r>
-              <a:rPr sz="1400" b="0" i="0">
-                <a:solidFill>
-                  <a:srgbClr val="1F2937"/>
-                </a:solidFill>
-                <a:latin typeface="Arial"/>
-              </a:rPr>
-              <a:t>1·10⁻⁴</a:t>
-            </a:r>
-          </a:p>
-        </p:txBody>
-      </p:sp>
-      <p:sp>
-        <p:nvSpPr>
-          <p:cNvPr id="16" name="TextBox 15"/>
-          <p:cNvSpPr txBox="1"/>
-          <p:nvPr/>
-        </p:nvSpPr>
-        <p:spPr>
-          <a:xfrm>
-            <a:off x="6400800" y="3236976"/>
-            <a:ext cx="2743200" cy="365760"/>
-          </a:xfrm>
-          <a:prstGeom prst="rect">
-            <a:avLst/>
-          </a:prstGeom>
-          <a:noFill/>
-        </p:spPr>
-        <p:txBody>
-          <a:bodyPr wrap="square" anchor="t" lIns="0" rIns="0" tIns="0" bIns="0">
-            <a:spAutoFit/>
-          </a:bodyPr>
-          <a:lstStyle/>
-          <a:p>
-            <a:pPr algn="l">
-              <a:lnSpc>
-                <a:spcPct val="105000"/>
-              </a:lnSpc>
-              <a:spcBef>
-                <a:spcPts val="0"/>
-              </a:spcBef>
-              <a:spcAft>
-                <a:spcPts val="600"/>
-              </a:spcAft>
-            </a:pPr>
-            <a:r>
-              <a:rPr sz="1400" b="1" i="0">
-                <a:solidFill>
-                  <a:srgbClr val="6B7280"/>
-                </a:solidFill>
-                <a:latin typeface="Arial"/>
-              </a:rPr>
-              <a:t>Weight decay</a:t>
-            </a:r>
-          </a:p>
-        </p:txBody>
-      </p:sp>
-      <p:sp>
-        <p:nvSpPr>
-          <p:cNvPr id="17" name="TextBox 16"/>
-          <p:cNvSpPr txBox="1"/>
-          <p:nvPr/>
-        </p:nvSpPr>
-        <p:spPr>
-          <a:xfrm>
-            <a:off x="9144000" y="3236976"/>
-            <a:ext cx="2377440" cy="365760"/>
-          </a:xfrm>
-          <a:prstGeom prst="rect">
-            <a:avLst/>
-          </a:prstGeom>
-          <a:noFill/>
-        </p:spPr>
-        <p:txBody>
-          <a:bodyPr wrap="square" anchor="t" lIns="0" rIns="0" tIns="0" bIns="0">
-            <a:spAutoFit/>
-          </a:bodyPr>
-          <a:lstStyle/>
-          <a:p>
-            <a:pPr algn="l">
-              <a:lnSpc>
-                <a:spcPct val="105000"/>
-              </a:lnSpc>
-              <a:spcBef>
-                <a:spcPts val="0"/>
-              </a:spcBef>
-              <a:spcAft>
-                <a:spcPts val="600"/>
-              </a:spcAft>
-            </a:pPr>
-            <a:r>
-              <a:rPr sz="1400" b="0" i="0">
-                <a:solidFill>
-                  <a:srgbClr val="1F2937"/>
-                </a:solidFill>
-                <a:latin typeface="Arial"/>
-              </a:rPr>
-              <a:t>1·10⁻⁴</a:t>
-            </a:r>
-          </a:p>
-        </p:txBody>
-      </p:sp>
-      <p:sp>
-        <p:nvSpPr>
-          <p:cNvPr id="18" name="TextBox 17"/>
-          <p:cNvSpPr txBox="1"/>
-          <p:nvPr/>
-        </p:nvSpPr>
-        <p:spPr>
-          <a:xfrm>
-            <a:off x="6400800" y="3803904"/>
-            <a:ext cx="2743200" cy="365760"/>
-          </a:xfrm>
-          <a:prstGeom prst="rect">
-            <a:avLst/>
-          </a:prstGeom>
-          <a:noFill/>
-        </p:spPr>
-        <p:txBody>
-          <a:bodyPr wrap="square" anchor="t" lIns="0" rIns="0" tIns="0" bIns="0">
-            <a:spAutoFit/>
-          </a:bodyPr>
-          <a:lstStyle/>
-          <a:p>
-            <a:pPr algn="l">
-              <a:lnSpc>
-                <a:spcPct val="105000"/>
-              </a:lnSpc>
-              <a:spcBef>
-                <a:spcPts val="0"/>
-              </a:spcBef>
-              <a:spcAft>
-                <a:spcPts val="600"/>
-              </a:spcAft>
-            </a:pPr>
-            <a:r>
-              <a:rPr sz="1400" b="1" i="0">
-                <a:solidFill>
-                  <a:srgbClr val="6B7280"/>
-                </a:solidFill>
-                <a:latin typeface="Arial"/>
-              </a:rPr>
-              <a:t>Расписание LR</a:t>
-            </a:r>
-          </a:p>
-        </p:txBody>
-      </p:sp>
-      <p:sp>
-        <p:nvSpPr>
-          <p:cNvPr id="19" name="TextBox 18"/>
-          <p:cNvSpPr txBox="1"/>
-          <p:nvPr/>
-        </p:nvSpPr>
-        <p:spPr>
-          <a:xfrm>
-            <a:off x="9144000" y="3803904"/>
-            <a:ext cx="2377440" cy="365760"/>
-          </a:xfrm>
-          <a:prstGeom prst="rect">
-            <a:avLst/>
-          </a:prstGeom>
-          <a:noFill/>
-        </p:spPr>
-        <p:txBody>
-          <a:bodyPr wrap="square" anchor="t" lIns="0" rIns="0" tIns="0" bIns="0">
-            <a:spAutoFit/>
-          </a:bodyPr>
-          <a:lstStyle/>
-          <a:p>
-            <a:pPr algn="l">
-              <a:lnSpc>
-                <a:spcPct val="105000"/>
-              </a:lnSpc>
-              <a:spcBef>
-                <a:spcPts val="0"/>
-              </a:spcBef>
-              <a:spcAft>
-                <a:spcPts val="600"/>
-              </a:spcAft>
-            </a:pPr>
-            <a:r>
-              <a:rPr sz="1400" b="0" i="0">
-                <a:solidFill>
-                  <a:srgbClr val="1F2937"/>
-                </a:solidFill>
-                <a:latin typeface="Arial"/>
-              </a:rPr>
-              <a:t>ReduceLROnPlateau</a:t>
-            </a:r>
-          </a:p>
-        </p:txBody>
-      </p:sp>
-      <p:sp>
-        <p:nvSpPr>
-          <p:cNvPr id="20" name="TextBox 19"/>
-          <p:cNvSpPr txBox="1"/>
-          <p:nvPr/>
-        </p:nvSpPr>
-        <p:spPr>
-          <a:xfrm>
-            <a:off x="6400800" y="4370832"/>
-            <a:ext cx="2743200" cy="365760"/>
-          </a:xfrm>
-          <a:prstGeom prst="rect">
-            <a:avLst/>
-          </a:prstGeom>
-          <a:noFill/>
-        </p:spPr>
-        <p:txBody>
-          <a:bodyPr wrap="square" anchor="t" lIns="0" rIns="0" tIns="0" bIns="0">
-            <a:spAutoFit/>
-          </a:bodyPr>
-          <a:lstStyle/>
-          <a:p>
-            <a:pPr algn="l">
-              <a:lnSpc>
-                <a:spcPct val="105000"/>
-              </a:lnSpc>
-              <a:spcBef>
-                <a:spcPts val="0"/>
-              </a:spcBef>
-              <a:spcAft>
-                <a:spcPts val="600"/>
-              </a:spcAft>
-            </a:pPr>
-            <a:r>
-              <a:rPr sz="1400" b="1" i="0">
-                <a:solidFill>
-                  <a:srgbClr val="6B7280"/>
-                </a:solidFill>
-                <a:latin typeface="Arial"/>
-              </a:rPr>
-              <a:t>Эпохи / batch</a:t>
-            </a:r>
-          </a:p>
-        </p:txBody>
-      </p:sp>
-      <p:sp>
-        <p:nvSpPr>
-          <p:cNvPr id="21" name="TextBox 20"/>
-          <p:cNvSpPr txBox="1"/>
-          <p:nvPr/>
-        </p:nvSpPr>
-        <p:spPr>
-          <a:xfrm>
-            <a:off x="9144000" y="4370832"/>
-            <a:ext cx="2377440" cy="365760"/>
-          </a:xfrm>
-          <a:prstGeom prst="rect">
-            <a:avLst/>
-          </a:prstGeom>
-          <a:noFill/>
-        </p:spPr>
-        <p:txBody>
-          <a:bodyPr wrap="square" anchor="t" lIns="0" rIns="0" tIns="0" bIns="0">
-            <a:spAutoFit/>
-          </a:bodyPr>
-          <a:lstStyle/>
-          <a:p>
-            <a:pPr algn="l">
-              <a:lnSpc>
-                <a:spcPct val="105000"/>
-              </a:lnSpc>
-              <a:spcBef>
-                <a:spcPts val="0"/>
-              </a:spcBef>
-              <a:spcAft>
-                <a:spcPts val="600"/>
-              </a:spcAft>
-            </a:pPr>
-            <a:r>
-              <a:rPr sz="1400" b="0" i="0">
-                <a:solidFill>
-                  <a:srgbClr val="1F2937"/>
-                </a:solidFill>
-                <a:latin typeface="Arial"/>
-              </a:rPr>
-              <a:t>100 / 8</a:t>
-            </a:r>
-          </a:p>
-        </p:txBody>
-      </p:sp>
-      <p:sp>
-        <p:nvSpPr>
-          <p:cNvPr id="22" name="TextBox 21"/>
-          <p:cNvSpPr txBox="1"/>
-          <p:nvPr/>
-        </p:nvSpPr>
-        <p:spPr>
-          <a:xfrm>
-            <a:off x="6400800" y="4937760"/>
-            <a:ext cx="2743200" cy="365760"/>
-          </a:xfrm>
-          <a:prstGeom prst="rect">
-            <a:avLst/>
-          </a:prstGeom>
-          <a:noFill/>
-        </p:spPr>
-        <p:txBody>
-          <a:bodyPr wrap="square" anchor="t" lIns="0" rIns="0" tIns="0" bIns="0">
-            <a:spAutoFit/>
-          </a:bodyPr>
-          <a:lstStyle/>
-          <a:p>
-            <a:pPr algn="l">
-              <a:lnSpc>
-                <a:spcPct val="105000"/>
-              </a:lnSpc>
-              <a:spcBef>
-                <a:spcPts val="0"/>
-              </a:spcBef>
-              <a:spcAft>
-                <a:spcPts val="600"/>
-              </a:spcAft>
-            </a:pPr>
-            <a:r>
-              <a:rPr sz="1400" b="1" i="0">
-                <a:solidFill>
-                  <a:srgbClr val="6B7280"/>
-                </a:solidFill>
-                <a:latin typeface="Arial"/>
-              </a:rPr>
-              <a:t>Аугментации</a:t>
-            </a:r>
-          </a:p>
-        </p:txBody>
-      </p:sp>
-      <p:sp>
-        <p:nvSpPr>
-          <p:cNvPr id="23" name="TextBox 22"/>
-          <p:cNvSpPr txBox="1"/>
-          <p:nvPr/>
-        </p:nvSpPr>
-        <p:spPr>
-          <a:xfrm>
-            <a:off x="9144000" y="4937760"/>
-            <a:ext cx="2377440" cy="365760"/>
-          </a:xfrm>
-          <a:prstGeom prst="rect">
-            <a:avLst/>
-          </a:prstGeom>
-          <a:noFill/>
-        </p:spPr>
-        <p:txBody>
-          <a:bodyPr wrap="square" anchor="t" lIns="0" rIns="0" tIns="0" bIns="0">
-            <a:spAutoFit/>
-          </a:bodyPr>
-          <a:lstStyle/>
-          <a:p>
-            <a:pPr algn="l">
-              <a:lnSpc>
-                <a:spcPct val="105000"/>
-              </a:lnSpc>
-              <a:spcBef>
-                <a:spcPts val="0"/>
-              </a:spcBef>
-              <a:spcAft>
-                <a:spcPts val="600"/>
-              </a:spcAft>
-            </a:pPr>
-            <a:r>
-              <a:rPr sz="1400" b="0" i="0">
-                <a:solidFill>
-                  <a:srgbClr val="1F2937"/>
-                </a:solidFill>
-                <a:latin typeface="Arial"/>
-              </a:rPr>
-              <a:t>повороты, отражения, TTA ×4</a:t>
-            </a:r>
-          </a:p>
-        </p:txBody>
-      </p:sp>
-    </p:spTree>
-  </p:cSld>
-  <p:clrMapOvr>
-    <a:masterClrMapping/>
-  </p:clrMapOvr>
-</p:sld>
-</file>
-
-<file path=ppt/slides/slide16.xml><?xml version="1.0" encoding="utf-8"?>
-<p:sld xmlns:a="http://schemas.openxmlformats.org/drawingml/2006/main" xmlns:p="http://schemas.openxmlformats.org/presentationml/2006/main" xmlns:r="http://schemas.openxmlformats.org/officeDocument/2006/relationships">
-  <p:cSld>
-    <p:spTree>
-      <p:nvGrpSpPr>
-        <p:cNvPr id="1" name=""/>
-        <p:cNvGrpSpPr/>
-        <p:nvPr/>
-      </p:nvGrpSpPr>
-      <p:grpSpPr/>
-      <p:sp>
-        <p:nvSpPr>
-          <p:cNvPr id="2" name="Rectangle 1"/>
-          <p:cNvSpPr/>
-          <p:nvPr/>
-        </p:nvSpPr>
-        <p:spPr>
-          <a:xfrm>
-            <a:off x="0" y="0"/>
-            <a:ext cx="12191695" cy="6858000"/>
-          </a:xfrm>
-          <a:prstGeom prst="rect">
-            <a:avLst/>
-          </a:prstGeom>
-          <a:solidFill>
-            <a:srgbClr val="FFFFFF"/>
-          </a:solidFill>
-          <a:ln>
-            <a:noFill/>
-          </a:ln>
-          <a:effectLst/>
-        </p:spPr>
-        <p:style>
-          <a:lnRef idx="1">
-            <a:schemeClr val="accent1"/>
-          </a:lnRef>
-          <a:fillRef idx="3">
-            <a:schemeClr val="accent1"/>
-          </a:fillRef>
-          <a:effectRef idx="2">
-            <a:schemeClr val="accent1"/>
-          </a:effectRef>
-          <a:fontRef idx="minor">
-            <a:schemeClr val="lt1"/>
-          </a:fontRef>
-        </p:style>
-        <p:txBody>
-          <a:bodyPr rtlCol="0" anchor="ctr"/>
-          <a:lstStyle/>
-          <a:p>
-            <a:pPr algn="ctr"/>
-          </a:p>
-        </p:txBody>
-      </p:sp>
-      <p:sp>
-        <p:nvSpPr>
-          <p:cNvPr id="3" name="Rectangle 2"/>
-          <p:cNvSpPr/>
-          <p:nvPr/>
-        </p:nvSpPr>
-        <p:spPr>
-          <a:xfrm>
-            <a:off x="0" y="0"/>
-            <a:ext cx="146304" cy="6858000"/>
-          </a:xfrm>
-          <a:prstGeom prst="rect">
-            <a:avLst/>
-          </a:prstGeom>
-          <a:solidFill>
-            <a:srgbClr val="2563EB"/>
-          </a:solidFill>
-          <a:ln>
-            <a:noFill/>
-          </a:ln>
-          <a:effectLst/>
-        </p:spPr>
-        <p:style>
-          <a:lnRef idx="1">
-            <a:schemeClr val="accent1"/>
-          </a:lnRef>
-          <a:fillRef idx="3">
-            <a:schemeClr val="accent1"/>
-          </a:fillRef>
-          <a:effectRef idx="2">
-            <a:schemeClr val="accent1"/>
-          </a:effectRef>
-          <a:fontRef idx="minor">
-            <a:schemeClr val="lt1"/>
-          </a:fontRef>
-        </p:style>
-        <p:txBody>
-          <a:bodyPr rtlCol="0" anchor="ctr"/>
-          <a:lstStyle/>
-          <a:p>
-            <a:pPr algn="ctr"/>
-          </a:p>
-        </p:txBody>
-      </p:sp>
-      <p:sp>
-        <p:nvSpPr>
-          <p:cNvPr id="4" name="TextBox 3"/>
-          <p:cNvSpPr txBox="1"/>
-          <p:nvPr/>
-        </p:nvSpPr>
-        <p:spPr>
-          <a:xfrm>
-            <a:off x="640080" y="310896"/>
-            <a:ext cx="10058400" cy="274320"/>
-          </a:xfrm>
-          <a:prstGeom prst="rect">
-            <a:avLst/>
-          </a:prstGeom>
-          <a:noFill/>
-        </p:spPr>
-        <p:txBody>
-          <a:bodyPr wrap="square" anchor="t" lIns="0" rIns="0" tIns="0" bIns="0">
-            <a:spAutoFit/>
-          </a:bodyPr>
-          <a:lstStyle/>
-          <a:p>
-            <a:pPr algn="l">
-              <a:lnSpc>
-                <a:spcPct val="105000"/>
-              </a:lnSpc>
-              <a:spcBef>
-                <a:spcPts val="0"/>
-              </a:spcBef>
-              <a:spcAft>
-                <a:spcPts val="600"/>
-              </a:spcAft>
-            </a:pPr>
-            <a:r>
-              <a:rPr sz="1100" b="1" i="0">
-                <a:solidFill>
-                  <a:srgbClr val="6B7280"/>
-                </a:solidFill>
-                <a:latin typeface="Arial"/>
-              </a:rPr>
-              <a:t>РЕЗЕРВНЫЙ СЛАЙД</a:t>
-            </a:r>
-          </a:p>
-        </p:txBody>
-      </p:sp>
-      <p:sp>
-        <p:nvSpPr>
-          <p:cNvPr id="5" name="TextBox 4"/>
-          <p:cNvSpPr txBox="1"/>
-          <p:nvPr/>
-        </p:nvSpPr>
-        <p:spPr>
-          <a:xfrm>
-            <a:off x="640080" y="566928"/>
-            <a:ext cx="10972800" cy="731520"/>
-          </a:xfrm>
-          <a:prstGeom prst="rect">
-            <a:avLst/>
-          </a:prstGeom>
-          <a:noFill/>
-        </p:spPr>
-        <p:txBody>
-          <a:bodyPr wrap="square" anchor="t" lIns="0" rIns="0" tIns="0" bIns="0">
-            <a:spAutoFit/>
-          </a:bodyPr>
-          <a:lstStyle/>
-          <a:p>
-            <a:pPr algn="l">
-              <a:lnSpc>
-                <a:spcPct val="105000"/>
-              </a:lnSpc>
-              <a:spcBef>
-                <a:spcPts val="0"/>
-              </a:spcBef>
-              <a:spcAft>
-                <a:spcPts val="600"/>
-              </a:spcAft>
-            </a:pPr>
-            <a:r>
-              <a:rPr sz="3000" b="1" i="0">
-                <a:solidFill>
-                  <a:srgbClr val="2563EB"/>
-                </a:solidFill>
-                <a:latin typeface="Arial"/>
-              </a:rPr>
-              <a:t>Предобработка SAR в ESA SNAP</a:t>
-            </a:r>
-          </a:p>
-        </p:txBody>
-      </p:sp>
-      <p:sp>
-        <p:nvSpPr>
-          <p:cNvPr id="6" name="Rectangle 5"/>
-          <p:cNvSpPr/>
-          <p:nvPr/>
-        </p:nvSpPr>
-        <p:spPr>
-          <a:xfrm>
-            <a:off x="640080" y="1225296"/>
-            <a:ext cx="2011680" cy="38100"/>
-          </a:xfrm>
-          <a:prstGeom prst="rect">
-            <a:avLst/>
-          </a:prstGeom>
-          <a:solidFill>
-            <a:srgbClr val="2563EB"/>
-          </a:solidFill>
-          <a:ln>
-            <a:noFill/>
-          </a:ln>
-          <a:effectLst/>
-        </p:spPr>
-        <p:style>
-          <a:lnRef idx="1">
-            <a:schemeClr val="accent1"/>
-          </a:lnRef>
-          <a:fillRef idx="3">
-            <a:schemeClr val="accent1"/>
-          </a:fillRef>
-          <a:effectRef idx="2">
-            <a:schemeClr val="accent1"/>
-          </a:effectRef>
-          <a:fontRef idx="minor">
-            <a:schemeClr val="lt1"/>
-          </a:fontRef>
-        </p:style>
-        <p:txBody>
-          <a:bodyPr rtlCol="0" anchor="ctr"/>
-          <a:lstStyle/>
-          <a:p>
-            <a:pPr algn="ctr"/>
-          </a:p>
-        </p:txBody>
-      </p:sp>
-      <p:sp>
-        <p:nvSpPr>
-          <p:cNvPr id="7" name="Rounded Rectangle 6"/>
-          <p:cNvSpPr/>
-          <p:nvPr/>
-        </p:nvSpPr>
-        <p:spPr>
-          <a:xfrm>
-            <a:off x="11140135" y="6355080"/>
-            <a:ext cx="777240" cy="310896"/>
-          </a:xfrm>
-          <a:prstGeom prst="roundRect">
-            <a:avLst/>
-          </a:prstGeom>
-          <a:solidFill>
-            <a:srgbClr val="F3F6FC"/>
-          </a:solidFill>
-          <a:ln w="9525">
-            <a:solidFill>
-              <a:srgbClr val="E2E8F0"/>
-            </a:solidFill>
-          </a:ln>
-          <a:effectLst/>
-        </p:spPr>
-        <p:style>
-          <a:lnRef idx="1">
-            <a:schemeClr val="accent1"/>
-          </a:lnRef>
-          <a:fillRef idx="3">
-            <a:schemeClr val="accent1"/>
-          </a:fillRef>
-          <a:effectRef idx="2">
-            <a:schemeClr val="accent1"/>
-          </a:effectRef>
-          <a:fontRef idx="minor">
-            <a:schemeClr val="lt1"/>
-          </a:fontRef>
-        </p:style>
-        <p:txBody>
-          <a:bodyPr rtlCol="0" anchor="ctr" wrap="none" lIns="0" rIns="0" tIns="0" bIns="0"/>
-          <a:lstStyle/>
-          <a:p>
-            <a:pPr algn="ctr"/>
-            <a:r>
-              <a:rPr sz="1100">
-                <a:solidFill>
-                  <a:srgbClr val="6B7280"/>
-                </a:solidFill>
-                <a:latin typeface="Arial"/>
-              </a:rPr>
-              <a:t>16 / 18</a:t>
-            </a:r>
-          </a:p>
-        </p:txBody>
-      </p:sp>
-      <p:sp>
-        <p:nvSpPr>
-          <p:cNvPr id="8" name="Oval 7"/>
-          <p:cNvSpPr/>
-          <p:nvPr/>
-        </p:nvSpPr>
-        <p:spPr>
-          <a:xfrm>
-            <a:off x="640080" y="1737360"/>
-            <a:ext cx="420624" cy="420624"/>
-          </a:xfrm>
-          <a:prstGeom prst="ellipse">
-            <a:avLst/>
-          </a:prstGeom>
-          <a:solidFill>
-            <a:srgbClr val="2E7D7A"/>
-          </a:solidFill>
-          <a:ln>
-            <a:noFill/>
-          </a:ln>
-          <a:effectLst/>
-        </p:spPr>
-        <p:style>
-          <a:lnRef idx="1">
-            <a:schemeClr val="accent1"/>
-          </a:lnRef>
-          <a:fillRef idx="3">
-            <a:schemeClr val="accent1"/>
-          </a:fillRef>
-          <a:effectRef idx="2">
-            <a:schemeClr val="accent1"/>
-          </a:effectRef>
-          <a:fontRef idx="minor">
-            <a:schemeClr val="lt1"/>
-          </a:fontRef>
-        </p:style>
-        <p:txBody>
-          <a:bodyPr rtlCol="0" anchor="ctr" lIns="0" rIns="0" tIns="0" bIns="0"/>
-          <a:lstStyle/>
-          <a:p>
-            <a:pPr algn="ctr"/>
-            <a:r>
-              <a:rPr sz="1600" b="1">
-                <a:solidFill>
-                  <a:srgbClr val="FFFFFF"/>
-                </a:solidFill>
-                <a:latin typeface="Arial"/>
-              </a:rPr>
-              <a:t>1</a:t>
-            </a:r>
-          </a:p>
-        </p:txBody>
-      </p:sp>
-      <p:sp>
-        <p:nvSpPr>
-          <p:cNvPr id="9" name="TextBox 8"/>
-          <p:cNvSpPr txBox="1"/>
-          <p:nvPr/>
-        </p:nvSpPr>
-        <p:spPr>
-          <a:xfrm>
-            <a:off x="1234440" y="1728216"/>
-            <a:ext cx="10241280" cy="548640"/>
-          </a:xfrm>
-          <a:prstGeom prst="rect">
-            <a:avLst/>
-          </a:prstGeom>
-          <a:noFill/>
-        </p:spPr>
-        <p:txBody>
-          <a:bodyPr wrap="square" anchor="ctr" lIns="0" rIns="0" tIns="0" bIns="0">
-            <a:spAutoFit/>
-          </a:bodyPr>
-          <a:lstStyle/>
-          <a:p>
-            <a:pPr algn="l">
-              <a:lnSpc>
-                <a:spcPct val="105000"/>
-              </a:lnSpc>
-              <a:spcBef>
-                <a:spcPts val="0"/>
-              </a:spcBef>
-              <a:spcAft>
-                <a:spcPts val="600"/>
-              </a:spcAft>
-            </a:pPr>
-            <a:r>
-              <a:rPr sz="1500" b="1" i="0">
-                <a:solidFill>
-                  <a:srgbClr val="2E7D7A"/>
-                </a:solidFill>
-                <a:latin typeface="Arial"/>
-              </a:rPr>
-              <a:t>Apply Orbit File — </a:t>
-            </a:r>
-            <a:r>
-              <a:rPr sz="1500" b="0" i="0">
-                <a:solidFill>
-                  <a:srgbClr val="1F2937"/>
-                </a:solidFill>
-                <a:latin typeface="Arial"/>
-              </a:rPr>
-              <a:t>уточнение параметров орбиты спутника</a:t>
-            </a:r>
-          </a:p>
-        </p:txBody>
-      </p:sp>
-      <p:sp>
-        <p:nvSpPr>
-          <p:cNvPr id="10" name="Oval 9"/>
-          <p:cNvSpPr/>
-          <p:nvPr/>
-        </p:nvSpPr>
-        <p:spPr>
-          <a:xfrm>
-            <a:off x="640080" y="2450592"/>
-            <a:ext cx="420624" cy="420624"/>
-          </a:xfrm>
-          <a:prstGeom prst="ellipse">
-            <a:avLst/>
-          </a:prstGeom>
-          <a:solidFill>
-            <a:srgbClr val="2E7D7A"/>
-          </a:solidFill>
-          <a:ln>
-            <a:noFill/>
-          </a:ln>
-          <a:effectLst/>
-        </p:spPr>
-        <p:style>
-          <a:lnRef idx="1">
-            <a:schemeClr val="accent1"/>
-          </a:lnRef>
-          <a:fillRef idx="3">
-            <a:schemeClr val="accent1"/>
-          </a:fillRef>
-          <a:effectRef idx="2">
-            <a:schemeClr val="accent1"/>
-          </a:effectRef>
-          <a:fontRef idx="minor">
-            <a:schemeClr val="lt1"/>
-          </a:fontRef>
-        </p:style>
-        <p:txBody>
-          <a:bodyPr rtlCol="0" anchor="ctr" lIns="0" rIns="0" tIns="0" bIns="0"/>
-          <a:lstStyle/>
-          <a:p>
-            <a:pPr algn="ctr"/>
-            <a:r>
-              <a:rPr sz="1600" b="1">
-                <a:solidFill>
-                  <a:srgbClr val="FFFFFF"/>
-                </a:solidFill>
-                <a:latin typeface="Arial"/>
-              </a:rPr>
-              <a:t>2</a:t>
-            </a:r>
-          </a:p>
-        </p:txBody>
-      </p:sp>
-      <p:sp>
-        <p:nvSpPr>
-          <p:cNvPr id="11" name="TextBox 10"/>
-          <p:cNvSpPr txBox="1"/>
-          <p:nvPr/>
-        </p:nvSpPr>
-        <p:spPr>
-          <a:xfrm>
-            <a:off x="1234440" y="2441448"/>
-            <a:ext cx="10241280" cy="548640"/>
-          </a:xfrm>
-          <a:prstGeom prst="rect">
-            <a:avLst/>
-          </a:prstGeom>
-          <a:noFill/>
-        </p:spPr>
-        <p:txBody>
-          <a:bodyPr wrap="square" anchor="ctr" lIns="0" rIns="0" tIns="0" bIns="0">
-            <a:spAutoFit/>
-          </a:bodyPr>
-          <a:lstStyle/>
-          <a:p>
-            <a:pPr algn="l">
-              <a:lnSpc>
-                <a:spcPct val="105000"/>
-              </a:lnSpc>
-              <a:spcBef>
-                <a:spcPts val="0"/>
-              </a:spcBef>
-              <a:spcAft>
-                <a:spcPts val="600"/>
-              </a:spcAft>
-            </a:pPr>
-            <a:r>
-              <a:rPr sz="1500" b="1" i="0">
-                <a:solidFill>
-                  <a:srgbClr val="2E7D7A"/>
-                </a:solidFill>
-                <a:latin typeface="Arial"/>
-              </a:rPr>
-              <a:t>Thermal Noise Removal — </a:t>
-            </a:r>
-            <a:r>
-              <a:rPr sz="1500" b="0" i="0">
-                <a:solidFill>
-                  <a:srgbClr val="1F2937"/>
-                </a:solidFill>
-                <a:latin typeface="Arial"/>
-              </a:rPr>
-              <a:t>удаление теплового шума сенсора</a:t>
-            </a:r>
-          </a:p>
-        </p:txBody>
-      </p:sp>
-      <p:sp>
-        <p:nvSpPr>
-          <p:cNvPr id="12" name="Oval 11"/>
-          <p:cNvSpPr/>
-          <p:nvPr/>
-        </p:nvSpPr>
-        <p:spPr>
-          <a:xfrm>
-            <a:off x="640080" y="3163824"/>
-            <a:ext cx="420624" cy="420624"/>
-          </a:xfrm>
-          <a:prstGeom prst="ellipse">
-            <a:avLst/>
-          </a:prstGeom>
-          <a:solidFill>
-            <a:srgbClr val="2E7D7A"/>
-          </a:solidFill>
-          <a:ln>
-            <a:noFill/>
-          </a:ln>
-          <a:effectLst/>
-        </p:spPr>
-        <p:style>
-          <a:lnRef idx="1">
-            <a:schemeClr val="accent1"/>
-          </a:lnRef>
-          <a:fillRef idx="3">
-            <a:schemeClr val="accent1"/>
-          </a:fillRef>
-          <a:effectRef idx="2">
-            <a:schemeClr val="accent1"/>
-          </a:effectRef>
-          <a:fontRef idx="minor">
-            <a:schemeClr val="lt1"/>
-          </a:fontRef>
-        </p:style>
-        <p:txBody>
-          <a:bodyPr rtlCol="0" anchor="ctr" lIns="0" rIns="0" tIns="0" bIns="0"/>
-          <a:lstStyle/>
-          <a:p>
-            <a:pPr algn="ctr"/>
-            <a:r>
-              <a:rPr sz="1600" b="1">
-                <a:solidFill>
-                  <a:srgbClr val="FFFFFF"/>
-                </a:solidFill>
-                <a:latin typeface="Arial"/>
-              </a:rPr>
-              <a:t>3</a:t>
-            </a:r>
-          </a:p>
-        </p:txBody>
-      </p:sp>
-      <p:sp>
-        <p:nvSpPr>
-          <p:cNvPr id="13" name="TextBox 12"/>
-          <p:cNvSpPr txBox="1"/>
-          <p:nvPr/>
-        </p:nvSpPr>
-        <p:spPr>
-          <a:xfrm>
-            <a:off x="1234440" y="3154680"/>
-            <a:ext cx="10241280" cy="548640"/>
-          </a:xfrm>
-          <a:prstGeom prst="rect">
-            <a:avLst/>
-          </a:prstGeom>
-          <a:noFill/>
-        </p:spPr>
-        <p:txBody>
-          <a:bodyPr wrap="square" anchor="ctr" lIns="0" rIns="0" tIns="0" bIns="0">
-            <a:spAutoFit/>
-          </a:bodyPr>
-          <a:lstStyle/>
-          <a:p>
-            <a:pPr algn="l">
-              <a:lnSpc>
-                <a:spcPct val="105000"/>
-              </a:lnSpc>
-              <a:spcBef>
-                <a:spcPts val="0"/>
-              </a:spcBef>
-              <a:spcAft>
-                <a:spcPts val="600"/>
-              </a:spcAft>
-            </a:pPr>
-            <a:r>
-              <a:rPr sz="1500" b="1" i="0">
-                <a:solidFill>
-                  <a:srgbClr val="2E7D7A"/>
-                </a:solidFill>
-                <a:latin typeface="Arial"/>
-              </a:rPr>
-              <a:t>Радиометрическая калибровка — </a:t>
-            </a:r>
-            <a:r>
-              <a:rPr sz="1500" b="0" i="0">
-                <a:solidFill>
-                  <a:srgbClr val="1F2937"/>
-                </a:solidFill>
-                <a:latin typeface="Arial"/>
-              </a:rPr>
-              <a:t>перевод в σ⁰ (коэффициент обратного рассеяния)</a:t>
-            </a:r>
-          </a:p>
-        </p:txBody>
-      </p:sp>
-      <p:sp>
-        <p:nvSpPr>
-          <p:cNvPr id="14" name="Oval 13"/>
-          <p:cNvSpPr/>
-          <p:nvPr/>
-        </p:nvSpPr>
-        <p:spPr>
-          <a:xfrm>
-            <a:off x="640080" y="3877056"/>
-            <a:ext cx="420624" cy="420624"/>
-          </a:xfrm>
-          <a:prstGeom prst="ellipse">
-            <a:avLst/>
-          </a:prstGeom>
-          <a:solidFill>
-            <a:srgbClr val="2E7D7A"/>
-          </a:solidFill>
-          <a:ln>
-            <a:noFill/>
-          </a:ln>
-          <a:effectLst/>
-        </p:spPr>
-        <p:style>
-          <a:lnRef idx="1">
-            <a:schemeClr val="accent1"/>
-          </a:lnRef>
-          <a:fillRef idx="3">
-            <a:schemeClr val="accent1"/>
-          </a:fillRef>
-          <a:effectRef idx="2">
-            <a:schemeClr val="accent1"/>
-          </a:effectRef>
-          <a:fontRef idx="minor">
-            <a:schemeClr val="lt1"/>
-          </a:fontRef>
-        </p:style>
-        <p:txBody>
-          <a:bodyPr rtlCol="0" anchor="ctr" lIns="0" rIns="0" tIns="0" bIns="0"/>
-          <a:lstStyle/>
-          <a:p>
-            <a:pPr algn="ctr"/>
-            <a:r>
-              <a:rPr sz="1600" b="1">
-                <a:solidFill>
-                  <a:srgbClr val="FFFFFF"/>
-                </a:solidFill>
-                <a:latin typeface="Arial"/>
-              </a:rPr>
-              <a:t>4</a:t>
-            </a:r>
-          </a:p>
-        </p:txBody>
-      </p:sp>
-      <p:sp>
-        <p:nvSpPr>
-          <p:cNvPr id="15" name="TextBox 14"/>
-          <p:cNvSpPr txBox="1"/>
-          <p:nvPr/>
-        </p:nvSpPr>
-        <p:spPr>
-          <a:xfrm>
-            <a:off x="1234440" y="3867912"/>
-            <a:ext cx="10241280" cy="548640"/>
-          </a:xfrm>
-          <a:prstGeom prst="rect">
-            <a:avLst/>
-          </a:prstGeom>
-          <a:noFill/>
-        </p:spPr>
-        <p:txBody>
-          <a:bodyPr wrap="square" anchor="ctr" lIns="0" rIns="0" tIns="0" bIns="0">
-            <a:spAutoFit/>
-          </a:bodyPr>
-          <a:lstStyle/>
-          <a:p>
-            <a:pPr algn="l">
-              <a:lnSpc>
-                <a:spcPct val="105000"/>
-              </a:lnSpc>
-              <a:spcBef>
-                <a:spcPts val="0"/>
-              </a:spcBef>
-              <a:spcAft>
-                <a:spcPts val="600"/>
-              </a:spcAft>
-            </a:pPr>
-            <a:r>
-              <a:rPr sz="1500" b="1" i="0">
-                <a:solidFill>
-                  <a:srgbClr val="2E7D7A"/>
-                </a:solidFill>
-                <a:latin typeface="Arial"/>
-              </a:rPr>
-              <a:t>Фильтр Ли 7×7 — </a:t>
-            </a:r>
-            <a:r>
-              <a:rPr sz="1500" b="0" i="0">
-                <a:solidFill>
-                  <a:srgbClr val="1F2937"/>
-                </a:solidFill>
-                <a:latin typeface="Arial"/>
-              </a:rPr>
-              <a:t>подавление спекл-шума с сохранением границ</a:t>
-            </a:r>
-          </a:p>
-        </p:txBody>
-      </p:sp>
-      <p:sp>
-        <p:nvSpPr>
-          <p:cNvPr id="16" name="Oval 15"/>
-          <p:cNvSpPr/>
-          <p:nvPr/>
-        </p:nvSpPr>
-        <p:spPr>
-          <a:xfrm>
-            <a:off x="640080" y="4590288"/>
-            <a:ext cx="420624" cy="420624"/>
-          </a:xfrm>
-          <a:prstGeom prst="ellipse">
-            <a:avLst/>
-          </a:prstGeom>
-          <a:solidFill>
-            <a:srgbClr val="2E7D7A"/>
-          </a:solidFill>
-          <a:ln>
-            <a:noFill/>
-          </a:ln>
-          <a:effectLst/>
-        </p:spPr>
-        <p:style>
-          <a:lnRef idx="1">
-            <a:schemeClr val="accent1"/>
-          </a:lnRef>
-          <a:fillRef idx="3">
-            <a:schemeClr val="accent1"/>
-          </a:fillRef>
-          <a:effectRef idx="2">
-            <a:schemeClr val="accent1"/>
-          </a:effectRef>
-          <a:fontRef idx="minor">
-            <a:schemeClr val="lt1"/>
-          </a:fontRef>
-        </p:style>
-        <p:txBody>
-          <a:bodyPr rtlCol="0" anchor="ctr" lIns="0" rIns="0" tIns="0" bIns="0"/>
-          <a:lstStyle/>
-          <a:p>
-            <a:pPr algn="ctr"/>
-            <a:r>
-              <a:rPr sz="1600" b="1">
-                <a:solidFill>
-                  <a:srgbClr val="FFFFFF"/>
-                </a:solidFill>
-                <a:latin typeface="Arial"/>
-              </a:rPr>
-              <a:t>5</a:t>
-            </a:r>
-          </a:p>
-        </p:txBody>
-      </p:sp>
-      <p:sp>
-        <p:nvSpPr>
-          <p:cNvPr id="17" name="TextBox 16"/>
-          <p:cNvSpPr txBox="1"/>
-          <p:nvPr/>
-        </p:nvSpPr>
-        <p:spPr>
-          <a:xfrm>
-            <a:off x="1234440" y="4581144"/>
-            <a:ext cx="10241280" cy="548640"/>
-          </a:xfrm>
-          <a:prstGeom prst="rect">
-            <a:avLst/>
-          </a:prstGeom>
-          <a:noFill/>
-        </p:spPr>
-        <p:txBody>
-          <a:bodyPr wrap="square" anchor="ctr" lIns="0" rIns="0" tIns="0" bIns="0">
-            <a:spAutoFit/>
-          </a:bodyPr>
-          <a:lstStyle/>
-          <a:p>
-            <a:pPr algn="l">
-              <a:lnSpc>
-                <a:spcPct val="105000"/>
-              </a:lnSpc>
-              <a:spcBef>
-                <a:spcPts val="0"/>
-              </a:spcBef>
-              <a:spcAft>
-                <a:spcPts val="600"/>
-              </a:spcAft>
-            </a:pPr>
-            <a:r>
-              <a:rPr sz="1500" b="1" i="0">
-                <a:solidFill>
-                  <a:srgbClr val="2E7D7A"/>
-                </a:solidFill>
-                <a:latin typeface="Arial"/>
-              </a:rPr>
-              <a:t>Range-Doppler коррекция — </a:t>
-            </a:r>
-            <a:r>
-              <a:rPr sz="1500" b="0" i="0">
-                <a:solidFill>
-                  <a:srgbClr val="1F2937"/>
-                </a:solidFill>
-                <a:latin typeface="Arial"/>
-              </a:rPr>
-              <a:t>геометрическая привязка к местности</a:t>
-            </a:r>
-          </a:p>
-        </p:txBody>
-      </p:sp>
-      <p:sp>
-        <p:nvSpPr>
-          <p:cNvPr id="18" name="Oval 17"/>
-          <p:cNvSpPr/>
-          <p:nvPr/>
-        </p:nvSpPr>
-        <p:spPr>
-          <a:xfrm>
-            <a:off x="640080" y="5303520"/>
-            <a:ext cx="420624" cy="420624"/>
-          </a:xfrm>
-          <a:prstGeom prst="ellipse">
-            <a:avLst/>
-          </a:prstGeom>
-          <a:solidFill>
-            <a:srgbClr val="2E7D7A"/>
-          </a:solidFill>
-          <a:ln>
-            <a:noFill/>
-          </a:ln>
-          <a:effectLst/>
-        </p:spPr>
-        <p:style>
-          <a:lnRef idx="1">
-            <a:schemeClr val="accent1"/>
-          </a:lnRef>
-          <a:fillRef idx="3">
-            <a:schemeClr val="accent1"/>
-          </a:fillRef>
-          <a:effectRef idx="2">
-            <a:schemeClr val="accent1"/>
-          </a:effectRef>
-          <a:fontRef idx="minor">
-            <a:schemeClr val="lt1"/>
-          </a:fontRef>
-        </p:style>
-        <p:txBody>
-          <a:bodyPr rtlCol="0" anchor="ctr" lIns="0" rIns="0" tIns="0" bIns="0"/>
-          <a:lstStyle/>
-          <a:p>
-            <a:pPr algn="ctr"/>
-            <a:r>
-              <a:rPr sz="1600" b="1">
-                <a:solidFill>
-                  <a:srgbClr val="FFFFFF"/>
-                </a:solidFill>
-                <a:latin typeface="Arial"/>
-              </a:rPr>
-              <a:t>6</a:t>
-            </a:r>
-          </a:p>
-        </p:txBody>
-      </p:sp>
-      <p:sp>
-        <p:nvSpPr>
-          <p:cNvPr id="19" name="TextBox 18"/>
-          <p:cNvSpPr txBox="1"/>
-          <p:nvPr/>
-        </p:nvSpPr>
-        <p:spPr>
-          <a:xfrm>
-            <a:off x="1234440" y="5294376"/>
-            <a:ext cx="10241280" cy="548640"/>
-          </a:xfrm>
-          <a:prstGeom prst="rect">
-            <a:avLst/>
-          </a:prstGeom>
-          <a:noFill/>
-        </p:spPr>
-        <p:txBody>
-          <a:bodyPr wrap="square" anchor="ctr" lIns="0" rIns="0" tIns="0" bIns="0">
-            <a:spAutoFit/>
-          </a:bodyPr>
-          <a:lstStyle/>
-          <a:p>
-            <a:pPr algn="l">
-              <a:lnSpc>
-                <a:spcPct val="105000"/>
-              </a:lnSpc>
-              <a:spcBef>
-                <a:spcPts val="0"/>
-              </a:spcBef>
-              <a:spcAft>
-                <a:spcPts val="600"/>
-              </a:spcAft>
-            </a:pPr>
-            <a:r>
-              <a:rPr sz="1500" b="1" i="0">
-                <a:solidFill>
-                  <a:srgbClr val="2E7D7A"/>
-                </a:solidFill>
-                <a:latin typeface="Arial"/>
-              </a:rPr>
-              <a:t>Перевод в дБ — </a:t>
-            </a:r>
-            <a:r>
-              <a:rPr sz="1500" b="0" i="0">
-                <a:solidFill>
-                  <a:srgbClr val="1F2937"/>
-                </a:solidFill>
-                <a:latin typeface="Arial"/>
-              </a:rPr>
-              <a:t>логарифмическая шкала [−35; 0] дБ</a:t>
-            </a:r>
-          </a:p>
-        </p:txBody>
-      </p:sp>
-    </p:spTree>
-  </p:cSld>
-  <p:clrMapOvr>
-    <a:masterClrMapping/>
-  </p:clrMapOvr>
-</p:sld>
-</file>
-
-<file path=ppt/slides/slide17.xml><?xml version="1.0" encoding="utf-8"?>
-<p:sld xmlns:a="http://schemas.openxmlformats.org/drawingml/2006/main" xmlns:p="http://schemas.openxmlformats.org/presentationml/2006/main" xmlns:r="http://schemas.openxmlformats.org/officeDocument/2006/relationships">
-  <p:cSld>
-    <p:spTree>
-      <p:nvGrpSpPr>
-        <p:cNvPr id="1" name=""/>
-        <p:cNvGrpSpPr/>
-        <p:nvPr/>
-      </p:nvGrpSpPr>
-      <p:grpSpPr/>
-      <p:sp>
-        <p:nvSpPr>
-          <p:cNvPr id="2" name="Rectangle 1"/>
-          <p:cNvSpPr/>
-          <p:nvPr/>
-        </p:nvSpPr>
-        <p:spPr>
-          <a:xfrm>
-            <a:off x="0" y="0"/>
-            <a:ext cx="12191695" cy="6858000"/>
-          </a:xfrm>
-          <a:prstGeom prst="rect">
-            <a:avLst/>
-          </a:prstGeom>
-          <a:solidFill>
-            <a:srgbClr val="FFFFFF"/>
-          </a:solidFill>
-          <a:ln>
-            <a:noFill/>
-          </a:ln>
-          <a:effectLst/>
-        </p:spPr>
-        <p:style>
-          <a:lnRef idx="1">
-            <a:schemeClr val="accent1"/>
-          </a:lnRef>
-          <a:fillRef idx="3">
-            <a:schemeClr val="accent1"/>
-          </a:fillRef>
-          <a:effectRef idx="2">
-            <a:schemeClr val="accent1"/>
-          </a:effectRef>
-          <a:fontRef idx="minor">
-            <a:schemeClr val="lt1"/>
-          </a:fontRef>
-        </p:style>
-        <p:txBody>
-          <a:bodyPr rtlCol="0" anchor="ctr"/>
-          <a:lstStyle/>
-          <a:p>
-            <a:pPr algn="ctr"/>
-          </a:p>
-        </p:txBody>
-      </p:sp>
-      <p:sp>
-        <p:nvSpPr>
-          <p:cNvPr id="3" name="Rectangle 2"/>
-          <p:cNvSpPr/>
-          <p:nvPr/>
-        </p:nvSpPr>
-        <p:spPr>
-          <a:xfrm>
-            <a:off x="0" y="0"/>
-            <a:ext cx="146304" cy="6858000"/>
-          </a:xfrm>
-          <a:prstGeom prst="rect">
-            <a:avLst/>
-          </a:prstGeom>
-          <a:solidFill>
-            <a:srgbClr val="2563EB"/>
-          </a:solidFill>
-          <a:ln>
-            <a:noFill/>
-          </a:ln>
-          <a:effectLst/>
-        </p:spPr>
-        <p:style>
-          <a:lnRef idx="1">
-            <a:schemeClr val="accent1"/>
-          </a:lnRef>
-          <a:fillRef idx="3">
-            <a:schemeClr val="accent1"/>
-          </a:fillRef>
-          <a:effectRef idx="2">
-            <a:schemeClr val="accent1"/>
-          </a:effectRef>
-          <a:fontRef idx="minor">
-            <a:schemeClr val="lt1"/>
-          </a:fontRef>
-        </p:style>
-        <p:txBody>
-          <a:bodyPr rtlCol="0" anchor="ctr"/>
-          <a:lstStyle/>
-          <a:p>
-            <a:pPr algn="ctr"/>
-          </a:p>
-        </p:txBody>
-      </p:sp>
-      <p:sp>
-        <p:nvSpPr>
-          <p:cNvPr id="4" name="TextBox 3"/>
-          <p:cNvSpPr txBox="1"/>
-          <p:nvPr/>
-        </p:nvSpPr>
-        <p:spPr>
-          <a:xfrm>
-            <a:off x="640080" y="310896"/>
-            <a:ext cx="10058400" cy="274320"/>
-          </a:xfrm>
-          <a:prstGeom prst="rect">
-            <a:avLst/>
-          </a:prstGeom>
-          <a:noFill/>
-        </p:spPr>
-        <p:txBody>
-          <a:bodyPr wrap="square" anchor="t" lIns="0" rIns="0" tIns="0" bIns="0">
-            <a:spAutoFit/>
-          </a:bodyPr>
-          <a:lstStyle/>
-          <a:p>
-            <a:pPr algn="l">
-              <a:lnSpc>
-                <a:spcPct val="105000"/>
-              </a:lnSpc>
-              <a:spcBef>
-                <a:spcPts val="0"/>
-              </a:spcBef>
-              <a:spcAft>
-                <a:spcPts val="600"/>
-              </a:spcAft>
-            </a:pPr>
-            <a:r>
-              <a:rPr sz="1100" b="1" i="0">
-                <a:solidFill>
-                  <a:srgbClr val="6B7280"/>
-                </a:solidFill>
-                <a:latin typeface="Arial"/>
-              </a:rPr>
-              <a:t>РЕЗЕРВНЫЙ СЛАЙД</a:t>
-            </a:r>
-          </a:p>
-        </p:txBody>
-      </p:sp>
-      <p:sp>
-        <p:nvSpPr>
-          <p:cNvPr id="5" name="TextBox 4"/>
-          <p:cNvSpPr txBox="1"/>
-          <p:nvPr/>
-        </p:nvSpPr>
-        <p:spPr>
-          <a:xfrm>
-            <a:off x="640080" y="566928"/>
-            <a:ext cx="10972800" cy="731520"/>
-          </a:xfrm>
-          <a:prstGeom prst="rect">
-            <a:avLst/>
-          </a:prstGeom>
-          <a:noFill/>
-        </p:spPr>
-        <p:txBody>
-          <a:bodyPr wrap="square" anchor="t" lIns="0" rIns="0" tIns="0" bIns="0">
-            <a:spAutoFit/>
-          </a:bodyPr>
-          <a:lstStyle/>
-          <a:p>
-            <a:pPr algn="l">
-              <a:lnSpc>
-                <a:spcPct val="105000"/>
-              </a:lnSpc>
-              <a:spcBef>
-                <a:spcPts val="0"/>
-              </a:spcBef>
-              <a:spcAft>
-                <a:spcPts val="600"/>
-              </a:spcAft>
-            </a:pPr>
-            <a:r>
-              <a:rPr sz="3000" b="1" i="0">
-                <a:solidFill>
-                  <a:srgbClr val="2563EB"/>
-                </a:solidFill>
-                <a:latin typeface="Arial"/>
-              </a:rPr>
-              <a:t>Метрики оценки качества</a:t>
-            </a:r>
-          </a:p>
-        </p:txBody>
-      </p:sp>
-      <p:sp>
-        <p:nvSpPr>
-          <p:cNvPr id="6" name="Rectangle 5"/>
-          <p:cNvSpPr/>
-          <p:nvPr/>
-        </p:nvSpPr>
-        <p:spPr>
-          <a:xfrm>
-            <a:off x="640080" y="1225296"/>
-            <a:ext cx="2011680" cy="38100"/>
-          </a:xfrm>
-          <a:prstGeom prst="rect">
-            <a:avLst/>
-          </a:prstGeom>
-          <a:solidFill>
-            <a:srgbClr val="2563EB"/>
-          </a:solidFill>
-          <a:ln>
-            <a:noFill/>
-          </a:ln>
-          <a:effectLst/>
-        </p:spPr>
-        <p:style>
-          <a:lnRef idx="1">
-            <a:schemeClr val="accent1"/>
-          </a:lnRef>
-          <a:fillRef idx="3">
-            <a:schemeClr val="accent1"/>
-          </a:fillRef>
-          <a:effectRef idx="2">
-            <a:schemeClr val="accent1"/>
-          </a:effectRef>
-          <a:fontRef idx="minor">
-            <a:schemeClr val="lt1"/>
-          </a:fontRef>
-        </p:style>
-        <p:txBody>
-          <a:bodyPr rtlCol="0" anchor="ctr"/>
-          <a:lstStyle/>
-          <a:p>
-            <a:pPr algn="ctr"/>
-          </a:p>
-        </p:txBody>
-      </p:sp>
-      <p:sp>
-        <p:nvSpPr>
-          <p:cNvPr id="7" name="Rounded Rectangle 6"/>
-          <p:cNvSpPr/>
-          <p:nvPr/>
-        </p:nvSpPr>
-        <p:spPr>
-          <a:xfrm>
-            <a:off x="11140135" y="6355080"/>
-            <a:ext cx="777240" cy="310896"/>
-          </a:xfrm>
-          <a:prstGeom prst="roundRect">
-            <a:avLst/>
-          </a:prstGeom>
-          <a:solidFill>
-            <a:srgbClr val="F3F6FC"/>
-          </a:solidFill>
-          <a:ln w="9525">
-            <a:solidFill>
-              <a:srgbClr val="E2E8F0"/>
-            </a:solidFill>
-          </a:ln>
-          <a:effectLst/>
-        </p:spPr>
-        <p:style>
-          <a:lnRef idx="1">
-            <a:schemeClr val="accent1"/>
-          </a:lnRef>
-          <a:fillRef idx="3">
-            <a:schemeClr val="accent1"/>
-          </a:fillRef>
-          <a:effectRef idx="2">
-            <a:schemeClr val="accent1"/>
-          </a:effectRef>
-          <a:fontRef idx="minor">
-            <a:schemeClr val="lt1"/>
-          </a:fontRef>
-        </p:style>
-        <p:txBody>
-          <a:bodyPr rtlCol="0" anchor="ctr" wrap="none" lIns="0" rIns="0" tIns="0" bIns="0"/>
-          <a:lstStyle/>
-          <a:p>
-            <a:pPr algn="ctr"/>
-            <a:r>
-              <a:rPr sz="1100">
-                <a:solidFill>
-                  <a:srgbClr val="6B7280"/>
-                </a:solidFill>
-                <a:latin typeface="Arial"/>
-              </a:rPr>
-              <a:t>17 / 18</a:t>
-            </a:r>
-          </a:p>
-        </p:txBody>
-      </p:sp>
-      <p:sp>
-        <p:nvSpPr>
-          <p:cNvPr id="8" name="Rounded Rectangle 7"/>
-          <p:cNvSpPr/>
-          <p:nvPr/>
-        </p:nvSpPr>
-        <p:spPr>
-          <a:xfrm>
-            <a:off x="640080" y="1783080"/>
-            <a:ext cx="10927080" cy="749808"/>
-          </a:xfrm>
-          <a:prstGeom prst="roundRect">
-            <a:avLst/>
-          </a:prstGeom>
-          <a:solidFill>
-            <a:srgbClr val="F3F6FC"/>
-          </a:solidFill>
-          <a:ln w="12700">
-            <a:solidFill>
-              <a:srgbClr val="DBEAFE"/>
-            </a:solidFill>
-          </a:ln>
-          <a:effectLst/>
-        </p:spPr>
-        <p:style>
-          <a:lnRef idx="1">
-            <a:schemeClr val="accent1"/>
-          </a:lnRef>
-          <a:fillRef idx="3">
-            <a:schemeClr val="accent1"/>
-          </a:fillRef>
-          <a:effectRef idx="2">
-            <a:schemeClr val="accent1"/>
-          </a:effectRef>
-          <a:fontRef idx="minor">
-            <a:schemeClr val="lt1"/>
-          </a:fontRef>
-        </p:style>
-        <p:txBody>
-          <a:bodyPr rtlCol="0" anchor="ctr"/>
-          <a:lstStyle/>
-          <a:p>
-            <a:pPr algn="ctr"/>
-          </a:p>
-        </p:txBody>
-      </p:sp>
-      <p:sp>
-        <p:nvSpPr>
-          <p:cNvPr id="9" name="Rectangle 8"/>
-          <p:cNvSpPr/>
-          <p:nvPr/>
-        </p:nvSpPr>
-        <p:spPr>
-          <a:xfrm>
-            <a:off x="640080" y="1783080"/>
-            <a:ext cx="82296" cy="749808"/>
-          </a:xfrm>
-          <a:prstGeom prst="rect">
-            <a:avLst/>
-          </a:prstGeom>
-          <a:solidFill>
-            <a:srgbClr val="2563EB"/>
-          </a:solidFill>
-          <a:ln>
-            <a:noFill/>
-          </a:ln>
-          <a:effectLst/>
-        </p:spPr>
-        <p:style>
-          <a:lnRef idx="1">
-            <a:schemeClr val="accent1"/>
-          </a:lnRef>
-          <a:fillRef idx="3">
-            <a:schemeClr val="accent1"/>
-          </a:fillRef>
-          <a:effectRef idx="2">
-            <a:schemeClr val="accent1"/>
-          </a:effectRef>
-          <a:fontRef idx="minor">
-            <a:schemeClr val="lt1"/>
-          </a:fontRef>
-        </p:style>
-        <p:txBody>
-          <a:bodyPr rtlCol="0" anchor="ctr"/>
-          <a:lstStyle/>
-          <a:p>
-            <a:pPr algn="ctr"/>
-          </a:p>
-        </p:txBody>
-      </p:sp>
-      <p:sp>
-        <p:nvSpPr>
-          <p:cNvPr id="10" name="TextBox 9"/>
-          <p:cNvSpPr txBox="1"/>
-          <p:nvPr/>
-        </p:nvSpPr>
-        <p:spPr>
-          <a:xfrm>
-            <a:off x="914400" y="1929384"/>
-            <a:ext cx="10424160" cy="548640"/>
-          </a:xfrm>
-          <a:prstGeom prst="rect">
-            <a:avLst/>
-          </a:prstGeom>
-          <a:noFill/>
-        </p:spPr>
-        <p:txBody>
-          <a:bodyPr wrap="square" anchor="ctr" lIns="0" rIns="0" tIns="0" bIns="0">
-            <a:spAutoFit/>
-          </a:bodyPr>
-          <a:lstStyle/>
-          <a:p>
-            <a:pPr algn="l">
-              <a:lnSpc>
-                <a:spcPct val="105000"/>
-              </a:lnSpc>
-              <a:spcBef>
-                <a:spcPts val="0"/>
-              </a:spcBef>
-              <a:spcAft>
-                <a:spcPts val="600"/>
-              </a:spcAft>
-            </a:pPr>
-            <a:r>
-              <a:rPr sz="1500" b="1" i="0">
-                <a:solidFill>
-                  <a:srgbClr val="1E40AF"/>
-                </a:solidFill>
-                <a:latin typeface="Arial"/>
-              </a:rPr>
-              <a:t>Precision — </a:t>
-            </a:r>
-            <a:r>
-              <a:rPr sz="1500" b="0" i="0">
-                <a:solidFill>
-                  <a:srgbClr val="1F2937"/>
-                </a:solidFill>
-                <a:latin typeface="Arial"/>
-              </a:rPr>
-              <a:t>доля верных среди предсказанных пикселей «нефть»</a:t>
-            </a:r>
-          </a:p>
-        </p:txBody>
-      </p:sp>
-      <p:sp>
-        <p:nvSpPr>
-          <p:cNvPr id="11" name="Rounded Rectangle 10"/>
-          <p:cNvSpPr/>
-          <p:nvPr/>
-        </p:nvSpPr>
-        <p:spPr>
-          <a:xfrm>
-            <a:off x="640080" y="2679192"/>
-            <a:ext cx="10927080" cy="749808"/>
-          </a:xfrm>
-          <a:prstGeom prst="roundRect">
-            <a:avLst/>
-          </a:prstGeom>
-          <a:solidFill>
-            <a:srgbClr val="F3F6FC"/>
-          </a:solidFill>
-          <a:ln w="12700">
-            <a:solidFill>
-              <a:srgbClr val="DBEAFE"/>
-            </a:solidFill>
-          </a:ln>
-          <a:effectLst/>
-        </p:spPr>
-        <p:style>
-          <a:lnRef idx="1">
-            <a:schemeClr val="accent1"/>
-          </a:lnRef>
-          <a:fillRef idx="3">
-            <a:schemeClr val="accent1"/>
-          </a:fillRef>
-          <a:effectRef idx="2">
-            <a:schemeClr val="accent1"/>
-          </a:effectRef>
-          <a:fontRef idx="minor">
-            <a:schemeClr val="lt1"/>
-          </a:fontRef>
-        </p:style>
-        <p:txBody>
-          <a:bodyPr rtlCol="0" anchor="ctr"/>
-          <a:lstStyle/>
-          <a:p>
-            <a:pPr algn="ctr"/>
-          </a:p>
-        </p:txBody>
-      </p:sp>
-      <p:sp>
-        <p:nvSpPr>
-          <p:cNvPr id="12" name="Rectangle 11"/>
-          <p:cNvSpPr/>
-          <p:nvPr/>
-        </p:nvSpPr>
-        <p:spPr>
-          <a:xfrm>
-            <a:off x="640080" y="2679192"/>
-            <a:ext cx="82296" cy="749808"/>
-          </a:xfrm>
-          <a:prstGeom prst="rect">
-            <a:avLst/>
-          </a:prstGeom>
-          <a:solidFill>
-            <a:srgbClr val="2563EB"/>
-          </a:solidFill>
-          <a:ln>
-            <a:noFill/>
-          </a:ln>
-          <a:effectLst/>
-        </p:spPr>
-        <p:style>
-          <a:lnRef idx="1">
-            <a:schemeClr val="accent1"/>
-          </a:lnRef>
-          <a:fillRef idx="3">
-            <a:schemeClr val="accent1"/>
-          </a:fillRef>
-          <a:effectRef idx="2">
-            <a:schemeClr val="accent1"/>
-          </a:effectRef>
-          <a:fontRef idx="minor">
-            <a:schemeClr val="lt1"/>
-          </a:fontRef>
-        </p:style>
-        <p:txBody>
-          <a:bodyPr rtlCol="0" anchor="ctr"/>
-          <a:lstStyle/>
-          <a:p>
-            <a:pPr algn="ctr"/>
-          </a:p>
-        </p:txBody>
-      </p:sp>
-      <p:sp>
-        <p:nvSpPr>
-          <p:cNvPr id="13" name="TextBox 12"/>
-          <p:cNvSpPr txBox="1"/>
-          <p:nvPr/>
-        </p:nvSpPr>
-        <p:spPr>
-          <a:xfrm>
-            <a:off x="914400" y="2825496"/>
-            <a:ext cx="10424160" cy="548640"/>
-          </a:xfrm>
-          <a:prstGeom prst="rect">
-            <a:avLst/>
-          </a:prstGeom>
-          <a:noFill/>
-        </p:spPr>
-        <p:txBody>
-          <a:bodyPr wrap="square" anchor="ctr" lIns="0" rIns="0" tIns="0" bIns="0">
-            <a:spAutoFit/>
-          </a:bodyPr>
-          <a:lstStyle/>
-          <a:p>
-            <a:pPr algn="l">
-              <a:lnSpc>
-                <a:spcPct val="105000"/>
-              </a:lnSpc>
-              <a:spcBef>
-                <a:spcPts val="0"/>
-              </a:spcBef>
-              <a:spcAft>
-                <a:spcPts val="600"/>
-              </a:spcAft>
-            </a:pPr>
-            <a:r>
-              <a:rPr sz="1500" b="1" i="0">
-                <a:solidFill>
-                  <a:srgbClr val="1E40AF"/>
-                </a:solidFill>
-                <a:latin typeface="Arial"/>
-              </a:rPr>
-              <a:t>Recall — </a:t>
-            </a:r>
-            <a:r>
-              <a:rPr sz="1500" b="0" i="0">
-                <a:solidFill>
-                  <a:srgbClr val="1F2937"/>
-                </a:solidFill>
-                <a:latin typeface="Arial"/>
-              </a:rPr>
-              <a:t>доля найденных среди всех истинных пикселей «нефть»</a:t>
-            </a:r>
-          </a:p>
-        </p:txBody>
-      </p:sp>
-      <p:sp>
-        <p:nvSpPr>
-          <p:cNvPr id="14" name="Rounded Rectangle 13"/>
-          <p:cNvSpPr/>
-          <p:nvPr/>
-        </p:nvSpPr>
-        <p:spPr>
-          <a:xfrm>
-            <a:off x="640080" y="3575304"/>
-            <a:ext cx="10927080" cy="749808"/>
-          </a:xfrm>
-          <a:prstGeom prst="roundRect">
-            <a:avLst/>
-          </a:prstGeom>
-          <a:solidFill>
-            <a:srgbClr val="F3F6FC"/>
-          </a:solidFill>
-          <a:ln w="12700">
-            <a:solidFill>
-              <a:srgbClr val="DBEAFE"/>
-            </a:solidFill>
-          </a:ln>
-          <a:effectLst/>
-        </p:spPr>
-        <p:style>
-          <a:lnRef idx="1">
-            <a:schemeClr val="accent1"/>
-          </a:lnRef>
-          <a:fillRef idx="3">
-            <a:schemeClr val="accent1"/>
-          </a:fillRef>
-          <a:effectRef idx="2">
-            <a:schemeClr val="accent1"/>
-          </a:effectRef>
-          <a:fontRef idx="minor">
-            <a:schemeClr val="lt1"/>
-          </a:fontRef>
-        </p:style>
-        <p:txBody>
-          <a:bodyPr rtlCol="0" anchor="ctr"/>
-          <a:lstStyle/>
-          <a:p>
-            <a:pPr algn="ctr"/>
-          </a:p>
-        </p:txBody>
-      </p:sp>
-      <p:sp>
-        <p:nvSpPr>
-          <p:cNvPr id="15" name="Rectangle 14"/>
-          <p:cNvSpPr/>
-          <p:nvPr/>
-        </p:nvSpPr>
-        <p:spPr>
-          <a:xfrm>
-            <a:off x="640080" y="3575304"/>
-            <a:ext cx="82296" cy="749808"/>
-          </a:xfrm>
-          <a:prstGeom prst="rect">
-            <a:avLst/>
-          </a:prstGeom>
-          <a:solidFill>
-            <a:srgbClr val="2563EB"/>
-          </a:solidFill>
-          <a:ln>
-            <a:noFill/>
-          </a:ln>
-          <a:effectLst/>
-        </p:spPr>
-        <p:style>
-          <a:lnRef idx="1">
-            <a:schemeClr val="accent1"/>
-          </a:lnRef>
-          <a:fillRef idx="3">
-            <a:schemeClr val="accent1"/>
-          </a:fillRef>
-          <a:effectRef idx="2">
-            <a:schemeClr val="accent1"/>
-          </a:effectRef>
-          <a:fontRef idx="minor">
-            <a:schemeClr val="lt1"/>
-          </a:fontRef>
-        </p:style>
-        <p:txBody>
-          <a:bodyPr rtlCol="0" anchor="ctr"/>
-          <a:lstStyle/>
-          <a:p>
-            <a:pPr algn="ctr"/>
-          </a:p>
-        </p:txBody>
-      </p:sp>
-      <p:sp>
-        <p:nvSpPr>
-          <p:cNvPr id="16" name="TextBox 15"/>
-          <p:cNvSpPr txBox="1"/>
-          <p:nvPr/>
-        </p:nvSpPr>
-        <p:spPr>
-          <a:xfrm>
-            <a:off x="914400" y="3721608"/>
-            <a:ext cx="10424160" cy="548640"/>
-          </a:xfrm>
-          <a:prstGeom prst="rect">
-            <a:avLst/>
-          </a:prstGeom>
-          <a:noFill/>
-        </p:spPr>
-        <p:txBody>
-          <a:bodyPr wrap="square" anchor="ctr" lIns="0" rIns="0" tIns="0" bIns="0">
-            <a:spAutoFit/>
-          </a:bodyPr>
-          <a:lstStyle/>
-          <a:p>
-            <a:pPr algn="l">
-              <a:lnSpc>
-                <a:spcPct val="105000"/>
-              </a:lnSpc>
-              <a:spcBef>
-                <a:spcPts val="0"/>
-              </a:spcBef>
-              <a:spcAft>
-                <a:spcPts val="600"/>
-              </a:spcAft>
-            </a:pPr>
-            <a:r>
-              <a:rPr sz="1500" b="1" i="0">
-                <a:solidFill>
-                  <a:srgbClr val="1E40AF"/>
-                </a:solidFill>
-                <a:latin typeface="Arial"/>
-              </a:rPr>
-              <a:t>F1-score — </a:t>
-            </a:r>
-            <a:r>
-              <a:rPr sz="1500" b="0" i="0">
-                <a:solidFill>
-                  <a:srgbClr val="1F2937"/>
-                </a:solidFill>
-                <a:latin typeface="Arial"/>
-              </a:rPr>
-              <a:t>гармоническое среднее Precision и Recall — основная метрика</a:t>
-            </a:r>
-          </a:p>
-        </p:txBody>
-      </p:sp>
-      <p:sp>
-        <p:nvSpPr>
-          <p:cNvPr id="17" name="Rounded Rectangle 16"/>
-          <p:cNvSpPr/>
-          <p:nvPr/>
-        </p:nvSpPr>
-        <p:spPr>
-          <a:xfrm>
-            <a:off x="640080" y="4471416"/>
-            <a:ext cx="10927080" cy="749808"/>
-          </a:xfrm>
-          <a:prstGeom prst="roundRect">
-            <a:avLst/>
-          </a:prstGeom>
-          <a:solidFill>
-            <a:srgbClr val="F3F6FC"/>
-          </a:solidFill>
-          <a:ln w="12700">
-            <a:solidFill>
-              <a:srgbClr val="DBEAFE"/>
-            </a:solidFill>
-          </a:ln>
-          <a:effectLst/>
-        </p:spPr>
-        <p:style>
-          <a:lnRef idx="1">
-            <a:schemeClr val="accent1"/>
-          </a:lnRef>
-          <a:fillRef idx="3">
-            <a:schemeClr val="accent1"/>
-          </a:fillRef>
-          <a:effectRef idx="2">
-            <a:schemeClr val="accent1"/>
-          </a:effectRef>
-          <a:fontRef idx="minor">
-            <a:schemeClr val="lt1"/>
-          </a:fontRef>
-        </p:style>
-        <p:txBody>
-          <a:bodyPr rtlCol="0" anchor="ctr"/>
-          <a:lstStyle/>
-          <a:p>
-            <a:pPr algn="ctr"/>
-          </a:p>
-        </p:txBody>
-      </p:sp>
-      <p:sp>
-        <p:nvSpPr>
-          <p:cNvPr id="18" name="Rectangle 17"/>
-          <p:cNvSpPr/>
-          <p:nvPr/>
-        </p:nvSpPr>
-        <p:spPr>
-          <a:xfrm>
-            <a:off x="640080" y="4471416"/>
-            <a:ext cx="82296" cy="749808"/>
-          </a:xfrm>
-          <a:prstGeom prst="rect">
-            <a:avLst/>
-          </a:prstGeom>
-          <a:solidFill>
-            <a:srgbClr val="2563EB"/>
-          </a:solidFill>
-          <a:ln>
-            <a:noFill/>
-          </a:ln>
-          <a:effectLst/>
-        </p:spPr>
-        <p:style>
-          <a:lnRef idx="1">
-            <a:schemeClr val="accent1"/>
-          </a:lnRef>
-          <a:fillRef idx="3">
-            <a:schemeClr val="accent1"/>
-          </a:fillRef>
-          <a:effectRef idx="2">
-            <a:schemeClr val="accent1"/>
-          </a:effectRef>
-          <a:fontRef idx="minor">
-            <a:schemeClr val="lt1"/>
-          </a:fontRef>
-        </p:style>
-        <p:txBody>
-          <a:bodyPr rtlCol="0" anchor="ctr"/>
-          <a:lstStyle/>
-          <a:p>
-            <a:pPr algn="ctr"/>
-          </a:p>
-        </p:txBody>
-      </p:sp>
-      <p:sp>
-        <p:nvSpPr>
-          <p:cNvPr id="19" name="TextBox 18"/>
-          <p:cNvSpPr txBox="1"/>
-          <p:nvPr/>
-        </p:nvSpPr>
-        <p:spPr>
-          <a:xfrm>
-            <a:off x="914400" y="4617720"/>
-            <a:ext cx="10424160" cy="548640"/>
-          </a:xfrm>
-          <a:prstGeom prst="rect">
-            <a:avLst/>
-          </a:prstGeom>
-          <a:noFill/>
-        </p:spPr>
-        <p:txBody>
-          <a:bodyPr wrap="square" anchor="ctr" lIns="0" rIns="0" tIns="0" bIns="0">
-            <a:spAutoFit/>
-          </a:bodyPr>
-          <a:lstStyle/>
-          <a:p>
-            <a:pPr algn="l">
-              <a:lnSpc>
-                <a:spcPct val="105000"/>
-              </a:lnSpc>
-              <a:spcBef>
-                <a:spcPts val="0"/>
-              </a:spcBef>
-              <a:spcAft>
-                <a:spcPts val="600"/>
-              </a:spcAft>
-            </a:pPr>
-            <a:r>
-              <a:rPr sz="1500" b="1" i="0">
-                <a:solidFill>
-                  <a:srgbClr val="1E40AF"/>
-                </a:solidFill>
-                <a:latin typeface="Arial"/>
-              </a:rPr>
-              <a:t>IoU / mIoU — </a:t>
-            </a:r>
-            <a:r>
-              <a:rPr sz="1500" b="0" i="0">
-                <a:solidFill>
-                  <a:srgbClr val="1F2937"/>
-                </a:solidFill>
-                <a:latin typeface="Arial"/>
-              </a:rPr>
-              <a:t>отношение пересечения к объединению масок; mIoU — среднее по классам</a:t>
-            </a:r>
-          </a:p>
-        </p:txBody>
-      </p:sp>
-      <p:sp>
-        <p:nvSpPr>
-          <p:cNvPr id="20" name="Rounded Rectangle 19"/>
-          <p:cNvSpPr/>
-          <p:nvPr/>
-        </p:nvSpPr>
-        <p:spPr>
-          <a:xfrm>
-            <a:off x="640080" y="5367528"/>
-            <a:ext cx="10927080" cy="749808"/>
-          </a:xfrm>
-          <a:prstGeom prst="roundRect">
-            <a:avLst/>
-          </a:prstGeom>
-          <a:solidFill>
-            <a:srgbClr val="F3F6FC"/>
-          </a:solidFill>
-          <a:ln w="12700">
-            <a:solidFill>
-              <a:srgbClr val="DBEAFE"/>
-            </a:solidFill>
-          </a:ln>
-          <a:effectLst/>
-        </p:spPr>
-        <p:style>
-          <a:lnRef idx="1">
-            <a:schemeClr val="accent1"/>
-          </a:lnRef>
-          <a:fillRef idx="3">
-            <a:schemeClr val="accent1"/>
-          </a:fillRef>
-          <a:effectRef idx="2">
-            <a:schemeClr val="accent1"/>
-          </a:effectRef>
-          <a:fontRef idx="minor">
-            <a:schemeClr val="lt1"/>
-          </a:fontRef>
-        </p:style>
-        <p:txBody>
-          <a:bodyPr rtlCol="0" anchor="ctr"/>
-          <a:lstStyle/>
-          <a:p>
-            <a:pPr algn="ctr"/>
-          </a:p>
-        </p:txBody>
-      </p:sp>
-      <p:sp>
-        <p:nvSpPr>
-          <p:cNvPr id="21" name="Rectangle 20"/>
-          <p:cNvSpPr/>
-          <p:nvPr/>
-        </p:nvSpPr>
-        <p:spPr>
-          <a:xfrm>
-            <a:off x="640080" y="5367528"/>
-            <a:ext cx="82296" cy="749808"/>
-          </a:xfrm>
-          <a:prstGeom prst="rect">
-            <a:avLst/>
-          </a:prstGeom>
-          <a:solidFill>
-            <a:srgbClr val="2563EB"/>
-          </a:solidFill>
-          <a:ln>
-            <a:noFill/>
-          </a:ln>
-          <a:effectLst/>
-        </p:spPr>
-        <p:style>
-          <a:lnRef idx="1">
-            <a:schemeClr val="accent1"/>
-          </a:lnRef>
-          <a:fillRef idx="3">
-            <a:schemeClr val="accent1"/>
-          </a:fillRef>
-          <a:effectRef idx="2">
-            <a:schemeClr val="accent1"/>
-          </a:effectRef>
-          <a:fontRef idx="minor">
-            <a:schemeClr val="lt1"/>
-          </a:fontRef>
-        </p:style>
-        <p:txBody>
-          <a:bodyPr rtlCol="0" anchor="ctr"/>
-          <a:lstStyle/>
-          <a:p>
-            <a:pPr algn="ctr"/>
-          </a:p>
-        </p:txBody>
-      </p:sp>
-      <p:sp>
-        <p:nvSpPr>
-          <p:cNvPr id="22" name="TextBox 21"/>
-          <p:cNvSpPr txBox="1"/>
-          <p:nvPr/>
-        </p:nvSpPr>
-        <p:spPr>
-          <a:xfrm>
-            <a:off x="914400" y="5513832"/>
-            <a:ext cx="10424160" cy="548640"/>
-          </a:xfrm>
-          <a:prstGeom prst="rect">
-            <a:avLst/>
-          </a:prstGeom>
-          <a:noFill/>
-        </p:spPr>
-        <p:txBody>
-          <a:bodyPr wrap="square" anchor="ctr" lIns="0" rIns="0" tIns="0" bIns="0">
-            <a:spAutoFit/>
-          </a:bodyPr>
-          <a:lstStyle/>
-          <a:p>
-            <a:pPr algn="l">
-              <a:lnSpc>
-                <a:spcPct val="105000"/>
-              </a:lnSpc>
-              <a:spcBef>
-                <a:spcPts val="0"/>
-              </a:spcBef>
-              <a:spcAft>
-                <a:spcPts val="600"/>
-              </a:spcAft>
-            </a:pPr>
-            <a:r>
-              <a:rPr sz="1500" b="1" i="0">
-                <a:solidFill>
-                  <a:srgbClr val="1E40AF"/>
-                </a:solidFill>
-                <a:latin typeface="Arial"/>
-              </a:rPr>
-              <a:t>Accuracy — </a:t>
-            </a:r>
-            <a:r>
-              <a:rPr sz="1500" b="0" i="0">
-                <a:solidFill>
-                  <a:srgbClr val="1F2937"/>
-                </a:solidFill>
-                <a:latin typeface="Arial"/>
-              </a:rPr>
-              <a:t>доля верно классифицированных пикселей всех классов</a:t>
-            </a:r>
-          </a:p>
-        </p:txBody>
-      </p:sp>
-    </p:spTree>
-  </p:cSld>
-  <p:clrMapOvr>
-    <a:masterClrMapping/>
-  </p:clrMapOvr>
-</p:sld>
-</file>
-
-<file path=ppt/slides/slide18.xml><?xml version="1.0" encoding="utf-8"?>
-<p:sld xmlns:a="http://schemas.openxmlformats.org/drawingml/2006/main" xmlns:p="http://schemas.openxmlformats.org/presentationml/2006/main" xmlns:r="http://schemas.openxmlformats.org/officeDocument/2006/relationships">
-  <p:cSld>
-    <p:spTree>
-      <p:nvGrpSpPr>
-        <p:cNvPr id="1" name=""/>
-        <p:cNvGrpSpPr/>
-        <p:nvPr/>
-      </p:nvGrpSpPr>
-      <p:grpSpPr/>
-      <p:sp>
-        <p:nvSpPr>
-          <p:cNvPr id="2" name="Rectangle 1"/>
-          <p:cNvSpPr/>
-          <p:nvPr/>
-        </p:nvSpPr>
-        <p:spPr>
-          <a:xfrm>
-            <a:off x="0" y="0"/>
-            <a:ext cx="12191695" cy="6858000"/>
-          </a:xfrm>
-          <a:prstGeom prst="rect">
-            <a:avLst/>
-          </a:prstGeom>
-          <a:solidFill>
-            <a:srgbClr val="FFFFFF"/>
-          </a:solidFill>
-          <a:ln>
-            <a:noFill/>
-          </a:ln>
-          <a:effectLst/>
-        </p:spPr>
-        <p:style>
-          <a:lnRef idx="1">
-            <a:schemeClr val="accent1"/>
-          </a:lnRef>
-          <a:fillRef idx="3">
-            <a:schemeClr val="accent1"/>
-          </a:fillRef>
-          <a:effectRef idx="2">
-            <a:schemeClr val="accent1"/>
-          </a:effectRef>
-          <a:fontRef idx="minor">
-            <a:schemeClr val="lt1"/>
-          </a:fontRef>
-        </p:style>
-        <p:txBody>
-          <a:bodyPr rtlCol="0" anchor="ctr"/>
-          <a:lstStyle/>
-          <a:p>
-            <a:pPr algn="ctr"/>
-          </a:p>
-        </p:txBody>
-      </p:sp>
-      <p:sp>
-        <p:nvSpPr>
-          <p:cNvPr id="3" name="Rectangle 2"/>
-          <p:cNvSpPr/>
-          <p:nvPr/>
-        </p:nvSpPr>
-        <p:spPr>
-          <a:xfrm>
-            <a:off x="0" y="0"/>
-            <a:ext cx="146304" cy="6858000"/>
-          </a:xfrm>
-          <a:prstGeom prst="rect">
-            <a:avLst/>
-          </a:prstGeom>
-          <a:solidFill>
-            <a:srgbClr val="2563EB"/>
-          </a:solidFill>
-          <a:ln>
-            <a:noFill/>
-          </a:ln>
-          <a:effectLst/>
-        </p:spPr>
-        <p:style>
-          <a:lnRef idx="1">
-            <a:schemeClr val="accent1"/>
-          </a:lnRef>
-          <a:fillRef idx="3">
-            <a:schemeClr val="accent1"/>
-          </a:fillRef>
-          <a:effectRef idx="2">
-            <a:schemeClr val="accent1"/>
-          </a:effectRef>
-          <a:fontRef idx="minor">
-            <a:schemeClr val="lt1"/>
-          </a:fontRef>
-        </p:style>
-        <p:txBody>
-          <a:bodyPr rtlCol="0" anchor="ctr"/>
-          <a:lstStyle/>
-          <a:p>
-            <a:pPr algn="ctr"/>
-          </a:p>
-        </p:txBody>
-      </p:sp>
-      <p:sp>
-        <p:nvSpPr>
-          <p:cNvPr id="4" name="TextBox 3"/>
-          <p:cNvSpPr txBox="1"/>
-          <p:nvPr/>
-        </p:nvSpPr>
-        <p:spPr>
-          <a:xfrm>
-            <a:off x="640080" y="310896"/>
-            <a:ext cx="10058400" cy="274320"/>
-          </a:xfrm>
-          <a:prstGeom prst="rect">
-            <a:avLst/>
-          </a:prstGeom>
-          <a:noFill/>
-        </p:spPr>
-        <p:txBody>
-          <a:bodyPr wrap="square" anchor="t" lIns="0" rIns="0" tIns="0" bIns="0">
-            <a:spAutoFit/>
-          </a:bodyPr>
-          <a:lstStyle/>
-          <a:p>
-            <a:pPr algn="l">
-              <a:lnSpc>
-                <a:spcPct val="105000"/>
-              </a:lnSpc>
-              <a:spcBef>
-                <a:spcPts val="0"/>
-              </a:spcBef>
-              <a:spcAft>
-                <a:spcPts val="600"/>
-              </a:spcAft>
-            </a:pPr>
-            <a:r>
-              <a:rPr sz="1100" b="1" i="0">
-                <a:solidFill>
-                  <a:srgbClr val="6B7280"/>
-                </a:solidFill>
-                <a:latin typeface="Arial"/>
-              </a:rPr>
-              <a:t>РЕЗЕРВНЫЙ СЛАЙД</a:t>
-            </a:r>
-          </a:p>
-        </p:txBody>
-      </p:sp>
-      <p:sp>
-        <p:nvSpPr>
-          <p:cNvPr id="5" name="TextBox 4"/>
-          <p:cNvSpPr txBox="1"/>
-          <p:nvPr/>
-        </p:nvSpPr>
-        <p:spPr>
-          <a:xfrm>
-            <a:off x="640080" y="566928"/>
-            <a:ext cx="10972800" cy="731520"/>
-          </a:xfrm>
-          <a:prstGeom prst="rect">
-            <a:avLst/>
-          </a:prstGeom>
-          <a:noFill/>
-        </p:spPr>
-        <p:txBody>
-          <a:bodyPr wrap="square" anchor="t" lIns="0" rIns="0" tIns="0" bIns="0">
-            <a:spAutoFit/>
-          </a:bodyPr>
-          <a:lstStyle/>
-          <a:p>
-            <a:pPr algn="l">
-              <a:lnSpc>
-                <a:spcPct val="105000"/>
-              </a:lnSpc>
-              <a:spcBef>
-                <a:spcPts val="0"/>
-              </a:spcBef>
-              <a:spcAft>
-                <a:spcPts val="600"/>
-              </a:spcAft>
-            </a:pPr>
-            <a:r>
-              <a:rPr sz="3000" b="1" i="0">
-                <a:solidFill>
-                  <a:srgbClr val="2563EB"/>
-                </a:solidFill>
-                <a:latin typeface="Arial"/>
-              </a:rPr>
-              <a:t>Разбор матрицы ошибок</a:t>
-            </a:r>
-          </a:p>
-        </p:txBody>
-      </p:sp>
-      <p:sp>
-        <p:nvSpPr>
-          <p:cNvPr id="6" name="Rectangle 5"/>
-          <p:cNvSpPr/>
-          <p:nvPr/>
-        </p:nvSpPr>
-        <p:spPr>
-          <a:xfrm>
-            <a:off x="640080" y="1225296"/>
-            <a:ext cx="2011680" cy="38100"/>
-          </a:xfrm>
-          <a:prstGeom prst="rect">
-            <a:avLst/>
-          </a:prstGeom>
-          <a:solidFill>
-            <a:srgbClr val="2563EB"/>
-          </a:solidFill>
-          <a:ln>
-            <a:noFill/>
-          </a:ln>
-          <a:effectLst/>
-        </p:spPr>
-        <p:style>
-          <a:lnRef idx="1">
-            <a:schemeClr val="accent1"/>
-          </a:lnRef>
-          <a:fillRef idx="3">
-            <a:schemeClr val="accent1"/>
-          </a:fillRef>
-          <a:effectRef idx="2">
-            <a:schemeClr val="accent1"/>
-          </a:effectRef>
-          <a:fontRef idx="minor">
-            <a:schemeClr val="lt1"/>
-          </a:fontRef>
-        </p:style>
-        <p:txBody>
-          <a:bodyPr rtlCol="0" anchor="ctr"/>
-          <a:lstStyle/>
-          <a:p>
-            <a:pPr algn="ctr"/>
-          </a:p>
-        </p:txBody>
-      </p:sp>
-      <p:sp>
-        <p:nvSpPr>
-          <p:cNvPr id="7" name="Rounded Rectangle 6"/>
-          <p:cNvSpPr/>
-          <p:nvPr/>
-        </p:nvSpPr>
-        <p:spPr>
-          <a:xfrm>
-            <a:off x="11140135" y="6355080"/>
-            <a:ext cx="777240" cy="310896"/>
-          </a:xfrm>
-          <a:prstGeom prst="roundRect">
-            <a:avLst/>
-          </a:prstGeom>
-          <a:solidFill>
-            <a:srgbClr val="F3F6FC"/>
-          </a:solidFill>
-          <a:ln w="9525">
-            <a:solidFill>
-              <a:srgbClr val="E2E8F0"/>
-            </a:solidFill>
-          </a:ln>
-          <a:effectLst/>
-        </p:spPr>
-        <p:style>
-          <a:lnRef idx="1">
-            <a:schemeClr val="accent1"/>
-          </a:lnRef>
-          <a:fillRef idx="3">
-            <a:schemeClr val="accent1"/>
-          </a:fillRef>
-          <a:effectRef idx="2">
-            <a:schemeClr val="accent1"/>
-          </a:effectRef>
-          <a:fontRef idx="minor">
-            <a:schemeClr val="lt1"/>
-          </a:fontRef>
-        </p:style>
-        <p:txBody>
-          <a:bodyPr rtlCol="0" anchor="ctr" wrap="none" lIns="0" rIns="0" tIns="0" bIns="0"/>
-          <a:lstStyle/>
-          <a:p>
-            <a:pPr algn="ctr"/>
-            <a:r>
-              <a:rPr sz="1100">
-                <a:solidFill>
-                  <a:srgbClr val="6B7280"/>
-                </a:solidFill>
-                <a:latin typeface="Arial"/>
-              </a:rPr>
-              <a:t>18 / 18</a:t>
-            </a:r>
-          </a:p>
-        </p:txBody>
-      </p:sp>
-      <p:pic>
-        <p:nvPicPr>
-          <p:cNvPr id="8" name="Picture 7" descr="fig_confusion.png"/>
-          <p:cNvPicPr>
-            <a:picLocks noChangeAspect="1"/>
-          </p:cNvPicPr>
-          <p:nvPr/>
-        </p:nvPicPr>
-        <p:blipFill>
-          <a:blip r:embed="rId2"/>
-          <a:stretch>
-            <a:fillRect/>
-          </a:stretch>
-        </p:blipFill>
-        <p:spPr>
-          <a:xfrm>
-            <a:off x="691075" y="1554480"/>
-            <a:ext cx="5201529" cy="4663440"/>
-          </a:xfrm>
-          <a:prstGeom prst="rect">
-            <a:avLst/>
-          </a:prstGeom>
-        </p:spPr>
-      </p:pic>
-      <p:sp>
-        <p:nvSpPr>
-          <p:cNvPr id="9" name="TextBox 8"/>
-          <p:cNvSpPr txBox="1"/>
-          <p:nvPr/>
-        </p:nvSpPr>
-        <p:spPr>
-          <a:xfrm>
-            <a:off x="6400800" y="1828800"/>
-            <a:ext cx="5120640" cy="4114800"/>
-          </a:xfrm>
-          <a:prstGeom prst="rect">
-            <a:avLst/>
-          </a:prstGeom>
-          <a:noFill/>
-        </p:spPr>
-        <p:txBody>
-          <a:bodyPr wrap="square" lIns="0" rIns="0" tIns="0" bIns="0">
-            <a:spAutoFit/>
-          </a:bodyPr>
-          <a:lstStyle/>
-          <a:p>
-            <a:pPr>
-              <a:lnSpc>
-                <a:spcPct val="105000"/>
-              </a:lnSpc>
-              <a:spcBef>
-                <a:spcPts val="0"/>
-              </a:spcBef>
-              <a:spcAft>
-                <a:spcPts val="1300"/>
-              </a:spcAft>
-            </a:pPr>
-            <a:r>
-              <a:rPr sz="1500" b="1">
-                <a:solidFill>
-                  <a:srgbClr val="2563EB"/>
-                </a:solidFill>
-                <a:latin typeface="Arial"/>
-              </a:rPr>
-              <a:t>•  </a:t>
-            </a:r>
-            <a:r>
-              <a:rPr sz="1500" b="1">
-                <a:solidFill>
-                  <a:srgbClr val="1F2937"/>
-                </a:solidFill>
-                <a:latin typeface="Arial"/>
-              </a:rPr>
-              <a:t>Основная ошибка</a:t>
-            </a:r>
-            <a:r>
-              <a:rPr sz="1500" b="0">
-                <a:solidFill>
-                  <a:srgbClr val="1F2937"/>
-                </a:solidFill>
-                <a:latin typeface="Arial"/>
-              </a:rPr>
-              <a:t> — 8,4 % пикселей нефти отнесены к «лёд + суша»</a:t>
-            </a:r>
-          </a:p>
-          <a:p>
-            <a:pPr>
-              <a:lnSpc>
-                <a:spcPct val="105000"/>
-              </a:lnSpc>
-              <a:spcBef>
-                <a:spcPts val="0"/>
-              </a:spcBef>
-              <a:spcAft>
-                <a:spcPts val="1300"/>
-              </a:spcAft>
-            </a:pPr>
-            <a:r>
-              <a:rPr sz="1500" b="1">
-                <a:solidFill>
-                  <a:srgbClr val="2563EB"/>
-                </a:solidFill>
-                <a:latin typeface="Arial"/>
-              </a:rPr>
-              <a:t>•  </a:t>
-            </a:r>
-            <a:r>
-              <a:rPr sz="1500" b="1">
-                <a:solidFill>
-                  <a:srgbClr val="1F2937"/>
-                </a:solidFill>
-                <a:latin typeface="Arial"/>
-              </a:rPr>
-              <a:t>Причина</a:t>
-            </a:r>
-            <a:r>
-              <a:rPr sz="1500" b="0">
-                <a:solidFill>
-                  <a:srgbClr val="1F2937"/>
-                </a:solidFill>
-                <a:latin typeface="Arial"/>
-              </a:rPr>
-              <a:t> — физически схожие тёмные сигнатуры обратного рассеяния</a:t>
-            </a:r>
-          </a:p>
-          <a:p>
-            <a:pPr>
-              <a:lnSpc>
-                <a:spcPct val="105000"/>
-              </a:lnSpc>
-              <a:spcBef>
-                <a:spcPts val="0"/>
-              </a:spcBef>
-              <a:spcAft>
-                <a:spcPts val="1300"/>
-              </a:spcAft>
-            </a:pPr>
-            <a:r>
-              <a:rPr sz="1500" b="1">
-                <a:solidFill>
-                  <a:srgbClr val="2563EB"/>
-                </a:solidFill>
-                <a:latin typeface="Arial"/>
-              </a:rPr>
-              <a:t>•  </a:t>
-            </a:r>
-            <a:r>
-              <a:rPr sz="1500" b="1">
-                <a:solidFill>
-                  <a:srgbClr val="1F2937"/>
-                </a:solidFill>
-                <a:latin typeface="Arial"/>
-              </a:rPr>
-              <a:t>Класс «вода»</a:t>
-            </a:r>
-            <a:r>
-              <a:rPr sz="1500" b="0">
-                <a:solidFill>
-                  <a:srgbClr val="1F2937"/>
-                </a:solidFill>
-                <a:latin typeface="Arial"/>
-              </a:rPr>
-              <a:t> распознаётся с точностью 96,2 %</a:t>
-            </a:r>
-          </a:p>
-          <a:p>
-            <a:pPr>
-              <a:lnSpc>
-                <a:spcPct val="105000"/>
-              </a:lnSpc>
-              <a:spcBef>
-                <a:spcPts val="0"/>
-              </a:spcBef>
-              <a:spcAft>
-                <a:spcPts val="1300"/>
-              </a:spcAft>
-            </a:pPr>
-            <a:r>
-              <a:rPr sz="1500" b="1">
-                <a:solidFill>
-                  <a:srgbClr val="2563EB"/>
-                </a:solidFill>
-                <a:latin typeface="Arial"/>
-              </a:rPr>
-              <a:t>•  </a:t>
-            </a:r>
-            <a:r>
-              <a:rPr sz="1500" b="1">
-                <a:solidFill>
-                  <a:srgbClr val="1F2937"/>
-                </a:solidFill>
-                <a:latin typeface="Arial"/>
-              </a:rPr>
-              <a:t>Класс «лёд + суша»</a:t>
-            </a:r>
-            <a:r>
-              <a:rPr sz="1500" b="0">
-                <a:solidFill>
-                  <a:srgbClr val="1F2937"/>
-                </a:solidFill>
-                <a:latin typeface="Arial"/>
-              </a:rPr>
-              <a:t> — 96,0 %; смешение с нефтью лишь 2,7 %</a:t>
-            </a:r>
-          </a:p>
-          <a:p>
-            <a:pPr>
-              <a:lnSpc>
-                <a:spcPct val="105000"/>
-              </a:lnSpc>
-              <a:spcBef>
-                <a:spcPts val="0"/>
-              </a:spcBef>
-              <a:spcAft>
-                <a:spcPts val="1300"/>
-              </a:spcAft>
-            </a:pPr>
-            <a:r>
-              <a:rPr sz="1500" b="1">
-                <a:solidFill>
-                  <a:srgbClr val="2563EB"/>
-                </a:solidFill>
-                <a:latin typeface="Arial"/>
-              </a:rPr>
-              <a:t>•  </a:t>
-            </a:r>
-            <a:r>
-              <a:rPr sz="1500" b="1">
-                <a:solidFill>
-                  <a:srgbClr val="1F2937"/>
-                </a:solidFill>
-                <a:latin typeface="Arial"/>
-              </a:rPr>
-              <a:t>Вывод</a:t>
-            </a:r>
-            <a:r>
-              <a:rPr sz="1500" b="0">
-                <a:solidFill>
-                  <a:srgbClr val="1F2937"/>
-                </a:solidFill>
-                <a:latin typeface="Arial"/>
-              </a:rPr>
-              <a:t> — модель устойчиво разделяет три класса; остаточная путаница ожидаема физически</a:t>
+              <a:t>13 / 13</a:t>
             </a:r>
           </a:p>
         </p:txBody>
@@ -11051,7 +6641,7 @@
                 </a:solidFill>
                 <a:latin typeface="Arial"/>
               </a:rPr>
-              <a:t>2 / 18</a:t>
+              <a:t>2 / 13</a:t>
             </a:r>
           </a:p>
         </p:txBody>
@@ -12275,7 +7865,7 @@
                 </a:solidFill>
                 <a:latin typeface="Arial"/>
               </a:rPr>
-              <a:t>3 / 18</a:t>
+              <a:t>3 / 13</a:t>
             </a:r>
           </a:p>
         </p:txBody>
@@ -13106,7 +8696,7 @@
                 </a:solidFill>
                 <a:latin typeface="Arial"/>
               </a:rPr>
-              <a:t>4 / 18</a:t>
+              <a:t>4 / 13</a:t>
             </a:r>
           </a:p>
         </p:txBody>
@@ -13962,7 +9552,7 @@
                 </a:solidFill>
                 <a:latin typeface="Arial"/>
               </a:rPr>
-              <a:t>5 / 18</a:t>
+              <a:t>5 / 13</a:t>
             </a:r>
           </a:p>
         </p:txBody>
@@ -15000,7 +10590,7 @@
                 </a:solidFill>
                 <a:latin typeface="Arial"/>
               </a:rPr>
-              <a:t>6 / 18</a:t>
+              <a:t>6 / 13</a:t>
             </a:r>
           </a:p>
         </p:txBody>
@@ -15863,7 +11453,7 @@
                 </a:solidFill>
                 <a:latin typeface="Arial"/>
               </a:rPr>
-              <a:t>7 / 18</a:t>
+              <a:t>7 / 13</a:t>
             </a:r>
           </a:p>
         </p:txBody>
@@ -16453,7 +12043,7 @@
                 </a:solidFill>
                 <a:latin typeface="Arial"/>
               </a:rPr>
-              <a:t>8 / 18</a:t>
+              <a:t>8 / 13</a:t>
             </a:r>
           </a:p>
         </p:txBody>
@@ -17402,7 +12992,7 @@
                 </a:solidFill>
                 <a:latin typeface="Arial"/>
               </a:rPr>
-              <a:t>9 / 18</a:t>
+              <a:t>9 / 13</a:t>
             </a:r>
           </a:p>
         </p:txBody>

</xml_diff>

<commit_message>
defense prep: single 18-slide deck, tighter speech (~9 min), Q&A doc
- Revert backup slides into single 18-slide file (slides 14-18 after "Спасибо")
- Bake in slide 7 fix: нефть "менее 2,4 %" (matches pie chart)
- Rewrite speech tighter for strict 10-min limit (~742 words, ~8-9 min)
- Add Вопросы_и_ответы_ГЭК: 20 likely commission questions with answers

https://claude.ai/code/session_019hNMUj3P61dTB8aYHXMjHP
</commit_message>
<xml_diff>
--- a/thesis/vkr_final/Презентация_Финал_Байханов_2026.pptx
+++ b/thesis/vkr_final/Презентация_Финал_Байханов_2026.pptx
@@ -18,6 +18,11 @@
     <p:sldId id="266" r:id="rId17"/>
     <p:sldId id="267" r:id="rId18"/>
     <p:sldId id="268" r:id="rId19"/>
+    <p:sldId id="269" r:id="rId20"/>
+    <p:sldId id="270" r:id="rId21"/>
+    <p:sldId id="271" r:id="rId22"/>
+    <p:sldId id="272" r:id="rId23"/>
+    <p:sldId id="273" r:id="rId24"/>
   </p:sldIdLst>
   <p:sldSz cx="12191695" cy="6858000" type="screen4x3"/>
   <p:notesSz cx="6858000" cy="9144000"/>
@@ -4040,7 +4045,7 @@
                 </a:solidFill>
                 <a:latin typeface="Arial"/>
               </a:rPr>
-              <a:t>10 / 13</a:t>
+              <a:t>10 / 18</a:t>
             </a:r>
           </a:p>
         </p:txBody>
@@ -4614,7 +4619,7 @@
                 </a:solidFill>
                 <a:latin typeface="Arial"/>
               </a:rPr>
-              <a:t>11 / 13</a:t>
+              <a:t>11 / 18</a:t>
             </a:r>
           </a:p>
         </p:txBody>
@@ -5404,7 +5409,7 @@
                 </a:solidFill>
                 <a:latin typeface="Arial"/>
               </a:rPr>
-              <a:t>12 / 13</a:t>
+              <a:t>12 / 18</a:t>
             </a:r>
           </a:p>
         </p:txBody>
@@ -6391,7 +6396,4412 @@
                 </a:solidFill>
                 <a:latin typeface="Arial"/>
               </a:rPr>
-              <a:t>13 / 13</a:t>
+              <a:t>13 / 18</a:t>
+            </a:r>
+          </a:p>
+        </p:txBody>
+      </p:sp>
+    </p:spTree>
+  </p:cSld>
+  <p:clrMapOvr>
+    <a:masterClrMapping/>
+  </p:clrMapOvr>
+</p:sld>
+</file>
+
+<file path=ppt/slides/slide14.xml><?xml version="1.0" encoding="utf-8"?>
+<p:sld xmlns:a="http://schemas.openxmlformats.org/drawingml/2006/main" xmlns:p="http://schemas.openxmlformats.org/presentationml/2006/main" xmlns:r="http://schemas.openxmlformats.org/officeDocument/2006/relationships">
+  <p:cSld>
+    <p:spTree>
+      <p:nvGrpSpPr>
+        <p:cNvPr id="1" name=""/>
+        <p:cNvGrpSpPr/>
+        <p:nvPr/>
+      </p:nvGrpSpPr>
+      <p:grpSpPr/>
+      <p:sp>
+        <p:nvSpPr>
+          <p:cNvPr id="2" name="Rectangle 1"/>
+          <p:cNvSpPr/>
+          <p:nvPr/>
+        </p:nvSpPr>
+        <p:spPr>
+          <a:xfrm>
+            <a:off x="0" y="0"/>
+            <a:ext cx="12191695" cy="6858000"/>
+          </a:xfrm>
+          <a:prstGeom prst="rect">
+            <a:avLst/>
+          </a:prstGeom>
+          <a:solidFill>
+            <a:srgbClr val="FFFFFF"/>
+          </a:solidFill>
+          <a:ln>
+            <a:noFill/>
+          </a:ln>
+          <a:effectLst/>
+        </p:spPr>
+        <p:style>
+          <a:lnRef idx="1">
+            <a:schemeClr val="accent1"/>
+          </a:lnRef>
+          <a:fillRef idx="3">
+            <a:schemeClr val="accent1"/>
+          </a:fillRef>
+          <a:effectRef idx="2">
+            <a:schemeClr val="accent1"/>
+          </a:effectRef>
+          <a:fontRef idx="minor">
+            <a:schemeClr val="lt1"/>
+          </a:fontRef>
+        </p:style>
+        <p:txBody>
+          <a:bodyPr rtlCol="0" anchor="ctr"/>
+          <a:lstStyle/>
+          <a:p>
+            <a:pPr algn="ctr"/>
+          </a:p>
+        </p:txBody>
+      </p:sp>
+      <p:sp>
+        <p:nvSpPr>
+          <p:cNvPr id="3" name="Rectangle 2"/>
+          <p:cNvSpPr/>
+          <p:nvPr/>
+        </p:nvSpPr>
+        <p:spPr>
+          <a:xfrm>
+            <a:off x="0" y="0"/>
+            <a:ext cx="146304" cy="6858000"/>
+          </a:xfrm>
+          <a:prstGeom prst="rect">
+            <a:avLst/>
+          </a:prstGeom>
+          <a:solidFill>
+            <a:srgbClr val="2563EB"/>
+          </a:solidFill>
+          <a:ln>
+            <a:noFill/>
+          </a:ln>
+          <a:effectLst/>
+        </p:spPr>
+        <p:style>
+          <a:lnRef idx="1">
+            <a:schemeClr val="accent1"/>
+          </a:lnRef>
+          <a:fillRef idx="3">
+            <a:schemeClr val="accent1"/>
+          </a:fillRef>
+          <a:effectRef idx="2">
+            <a:schemeClr val="accent1"/>
+          </a:effectRef>
+          <a:fontRef idx="minor">
+            <a:schemeClr val="lt1"/>
+          </a:fontRef>
+        </p:style>
+        <p:txBody>
+          <a:bodyPr rtlCol="0" anchor="ctr"/>
+          <a:lstStyle/>
+          <a:p>
+            <a:pPr algn="ctr"/>
+          </a:p>
+        </p:txBody>
+      </p:sp>
+      <p:sp>
+        <p:nvSpPr>
+          <p:cNvPr id="4" name="TextBox 3"/>
+          <p:cNvSpPr txBox="1"/>
+          <p:nvPr/>
+        </p:nvSpPr>
+        <p:spPr>
+          <a:xfrm>
+            <a:off x="640080" y="310896"/>
+            <a:ext cx="10058400" cy="274320"/>
+          </a:xfrm>
+          <a:prstGeom prst="rect">
+            <a:avLst/>
+          </a:prstGeom>
+          <a:noFill/>
+        </p:spPr>
+        <p:txBody>
+          <a:bodyPr wrap="square" anchor="t" lIns="0" rIns="0" tIns="0" bIns="0">
+            <a:spAutoFit/>
+          </a:bodyPr>
+          <a:lstStyle/>
+          <a:p>
+            <a:pPr algn="l">
+              <a:lnSpc>
+                <a:spcPct val="105000"/>
+              </a:lnSpc>
+              <a:spcBef>
+                <a:spcPts val="0"/>
+              </a:spcBef>
+              <a:spcAft>
+                <a:spcPts val="600"/>
+              </a:spcAft>
+            </a:pPr>
+            <a:r>
+              <a:rPr sz="1100" b="1" i="0">
+                <a:solidFill>
+                  <a:srgbClr val="6B7280"/>
+                </a:solidFill>
+                <a:latin typeface="Arial"/>
+              </a:rPr>
+              <a:t>РЕЗЕРВНЫЙ СЛАЙД</a:t>
+            </a:r>
+          </a:p>
+        </p:txBody>
+      </p:sp>
+      <p:sp>
+        <p:nvSpPr>
+          <p:cNvPr id="5" name="TextBox 4"/>
+          <p:cNvSpPr txBox="1"/>
+          <p:nvPr/>
+        </p:nvSpPr>
+        <p:spPr>
+          <a:xfrm>
+            <a:off x="640080" y="566928"/>
+            <a:ext cx="10972800" cy="731520"/>
+          </a:xfrm>
+          <a:prstGeom prst="rect">
+            <a:avLst/>
+          </a:prstGeom>
+          <a:noFill/>
+        </p:spPr>
+        <p:txBody>
+          <a:bodyPr wrap="square" anchor="t" lIns="0" rIns="0" tIns="0" bIns="0">
+            <a:spAutoFit/>
+          </a:bodyPr>
+          <a:lstStyle/>
+          <a:p>
+            <a:pPr algn="l">
+              <a:lnSpc>
+                <a:spcPct val="105000"/>
+              </a:lnSpc>
+              <a:spcBef>
+                <a:spcPts val="0"/>
+              </a:spcBef>
+              <a:spcAft>
+                <a:spcPts val="600"/>
+              </a:spcAft>
+            </a:pPr>
+            <a:r>
+              <a:rPr sz="3000" b="1" i="0">
+                <a:solidFill>
+                  <a:srgbClr val="2563EB"/>
+                </a:solidFill>
+                <a:latin typeface="Arial"/>
+              </a:rPr>
+              <a:t>DeepLabV3+ с энкодером ResNet-50</a:t>
+            </a:r>
+          </a:p>
+        </p:txBody>
+      </p:sp>
+      <p:sp>
+        <p:nvSpPr>
+          <p:cNvPr id="6" name="Rectangle 5"/>
+          <p:cNvSpPr/>
+          <p:nvPr/>
+        </p:nvSpPr>
+        <p:spPr>
+          <a:xfrm>
+            <a:off x="640080" y="1225296"/>
+            <a:ext cx="2011680" cy="38100"/>
+          </a:xfrm>
+          <a:prstGeom prst="rect">
+            <a:avLst/>
+          </a:prstGeom>
+          <a:solidFill>
+            <a:srgbClr val="2563EB"/>
+          </a:solidFill>
+          <a:ln>
+            <a:noFill/>
+          </a:ln>
+          <a:effectLst/>
+        </p:spPr>
+        <p:style>
+          <a:lnRef idx="1">
+            <a:schemeClr val="accent1"/>
+          </a:lnRef>
+          <a:fillRef idx="3">
+            <a:schemeClr val="accent1"/>
+          </a:fillRef>
+          <a:effectRef idx="2">
+            <a:schemeClr val="accent1"/>
+          </a:effectRef>
+          <a:fontRef idx="minor">
+            <a:schemeClr val="lt1"/>
+          </a:fontRef>
+        </p:style>
+        <p:txBody>
+          <a:bodyPr rtlCol="0" anchor="ctr"/>
+          <a:lstStyle/>
+          <a:p>
+            <a:pPr algn="ctr"/>
+          </a:p>
+        </p:txBody>
+      </p:sp>
+      <p:sp>
+        <p:nvSpPr>
+          <p:cNvPr id="7" name="Rounded Rectangle 6"/>
+          <p:cNvSpPr/>
+          <p:nvPr/>
+        </p:nvSpPr>
+        <p:spPr>
+          <a:xfrm>
+            <a:off x="11140135" y="6355080"/>
+            <a:ext cx="777240" cy="310896"/>
+          </a:xfrm>
+          <a:prstGeom prst="roundRect">
+            <a:avLst/>
+          </a:prstGeom>
+          <a:solidFill>
+            <a:srgbClr val="F3F6FC"/>
+          </a:solidFill>
+          <a:ln w="9525">
+            <a:solidFill>
+              <a:srgbClr val="E2E8F0"/>
+            </a:solidFill>
+          </a:ln>
+          <a:effectLst/>
+        </p:spPr>
+        <p:style>
+          <a:lnRef idx="1">
+            <a:schemeClr val="accent1"/>
+          </a:lnRef>
+          <a:fillRef idx="3">
+            <a:schemeClr val="accent1"/>
+          </a:fillRef>
+          <a:effectRef idx="2">
+            <a:schemeClr val="accent1"/>
+          </a:effectRef>
+          <a:fontRef idx="minor">
+            <a:schemeClr val="lt1"/>
+          </a:fontRef>
+        </p:style>
+        <p:txBody>
+          <a:bodyPr rtlCol="0" anchor="ctr" wrap="none" lIns="0" rIns="0" tIns="0" bIns="0"/>
+          <a:lstStyle/>
+          <a:p>
+            <a:pPr algn="ctr"/>
+            <a:r>
+              <a:rPr sz="1100">
+                <a:solidFill>
+                  <a:srgbClr val="6B7280"/>
+                </a:solidFill>
+                <a:latin typeface="Arial"/>
+              </a:rPr>
+              <a:t>14 / 18</a:t>
+            </a:r>
+          </a:p>
+        </p:txBody>
+      </p:sp>
+      <p:sp>
+        <p:nvSpPr>
+          <p:cNvPr id="8" name="Oval 7"/>
+          <p:cNvSpPr/>
+          <p:nvPr/>
+        </p:nvSpPr>
+        <p:spPr>
+          <a:xfrm>
+            <a:off x="640080" y="1691640"/>
+            <a:ext cx="457200" cy="457200"/>
+          </a:xfrm>
+          <a:prstGeom prst="ellipse">
+            <a:avLst/>
+          </a:prstGeom>
+          <a:solidFill>
+            <a:srgbClr val="2563EB"/>
+          </a:solidFill>
+          <a:ln>
+            <a:noFill/>
+          </a:ln>
+          <a:effectLst/>
+        </p:spPr>
+        <p:style>
+          <a:lnRef idx="1">
+            <a:schemeClr val="accent1"/>
+          </a:lnRef>
+          <a:fillRef idx="3">
+            <a:schemeClr val="accent1"/>
+          </a:fillRef>
+          <a:effectRef idx="2">
+            <a:schemeClr val="accent1"/>
+          </a:effectRef>
+          <a:fontRef idx="minor">
+            <a:schemeClr val="lt1"/>
+          </a:fontRef>
+        </p:style>
+        <p:txBody>
+          <a:bodyPr rtlCol="0" anchor="ctr" lIns="0" rIns="0" tIns="0" bIns="0"/>
+          <a:lstStyle/>
+          <a:p>
+            <a:pPr algn="ctr"/>
+            <a:r>
+              <a:rPr sz="1600" b="1">
+                <a:solidFill>
+                  <a:srgbClr val="FFFFFF"/>
+                </a:solidFill>
+                <a:latin typeface="Arial"/>
+              </a:rPr>
+              <a:t>1</a:t>
+            </a:r>
+          </a:p>
+        </p:txBody>
+      </p:sp>
+      <p:sp>
+        <p:nvSpPr>
+          <p:cNvPr id="9" name="TextBox 8"/>
+          <p:cNvSpPr txBox="1"/>
+          <p:nvPr/>
+        </p:nvSpPr>
+        <p:spPr>
+          <a:xfrm>
+            <a:off x="1280160" y="1673352"/>
+            <a:ext cx="10241280" cy="1005840"/>
+          </a:xfrm>
+          <a:prstGeom prst="rect">
+            <a:avLst/>
+          </a:prstGeom>
+          <a:noFill/>
+        </p:spPr>
+        <p:txBody>
+          <a:bodyPr wrap="square" anchor="t" lIns="0" rIns="0" tIns="0" bIns="0">
+            <a:spAutoFit/>
+          </a:bodyPr>
+          <a:lstStyle/>
+          <a:p>
+            <a:pPr algn="l">
+              <a:lnSpc>
+                <a:spcPct val="110000"/>
+              </a:lnSpc>
+              <a:spcBef>
+                <a:spcPts val="0"/>
+              </a:spcBef>
+              <a:spcAft>
+                <a:spcPts val="600"/>
+              </a:spcAft>
+            </a:pPr>
+            <a:r>
+              <a:rPr sz="1500" b="1" i="0">
+                <a:solidFill>
+                  <a:srgbClr val="1E40AF"/>
+                </a:solidFill>
+                <a:latin typeface="Arial"/>
+              </a:rPr>
+              <a:t>Энкодер ResNet-50 — </a:t>
+            </a:r>
+            <a:r>
+              <a:rPr sz="1500" b="0" i="0">
+                <a:solidFill>
+                  <a:srgbClr val="1F2937"/>
+                </a:solidFill>
+                <a:latin typeface="Arial"/>
+              </a:rPr>
+              <a:t>извлечение признаков из SAR-тайла 256×256; предобучен на ImageNet, адаптирован к 1-канальному входу</a:t>
+            </a:r>
+          </a:p>
+        </p:txBody>
+      </p:sp>
+      <p:sp>
+        <p:nvSpPr>
+          <p:cNvPr id="10" name="Oval 9"/>
+          <p:cNvSpPr/>
+          <p:nvPr/>
+        </p:nvSpPr>
+        <p:spPr>
+          <a:xfrm>
+            <a:off x="640080" y="2770632"/>
+            <a:ext cx="457200" cy="457200"/>
+          </a:xfrm>
+          <a:prstGeom prst="ellipse">
+            <a:avLst/>
+          </a:prstGeom>
+          <a:solidFill>
+            <a:srgbClr val="2563EB"/>
+          </a:solidFill>
+          <a:ln>
+            <a:noFill/>
+          </a:ln>
+          <a:effectLst/>
+        </p:spPr>
+        <p:style>
+          <a:lnRef idx="1">
+            <a:schemeClr val="accent1"/>
+          </a:lnRef>
+          <a:fillRef idx="3">
+            <a:schemeClr val="accent1"/>
+          </a:fillRef>
+          <a:effectRef idx="2">
+            <a:schemeClr val="accent1"/>
+          </a:effectRef>
+          <a:fontRef idx="minor">
+            <a:schemeClr val="lt1"/>
+          </a:fontRef>
+        </p:style>
+        <p:txBody>
+          <a:bodyPr rtlCol="0" anchor="ctr" lIns="0" rIns="0" tIns="0" bIns="0"/>
+          <a:lstStyle/>
+          <a:p>
+            <a:pPr algn="ctr"/>
+            <a:r>
+              <a:rPr sz="1600" b="1">
+                <a:solidFill>
+                  <a:srgbClr val="FFFFFF"/>
+                </a:solidFill>
+                <a:latin typeface="Arial"/>
+              </a:rPr>
+              <a:t>2</a:t>
+            </a:r>
+          </a:p>
+        </p:txBody>
+      </p:sp>
+      <p:sp>
+        <p:nvSpPr>
+          <p:cNvPr id="11" name="TextBox 10"/>
+          <p:cNvSpPr txBox="1"/>
+          <p:nvPr/>
+        </p:nvSpPr>
+        <p:spPr>
+          <a:xfrm>
+            <a:off x="1280160" y="2752344"/>
+            <a:ext cx="10241280" cy="1005840"/>
+          </a:xfrm>
+          <a:prstGeom prst="rect">
+            <a:avLst/>
+          </a:prstGeom>
+          <a:noFill/>
+        </p:spPr>
+        <p:txBody>
+          <a:bodyPr wrap="square" anchor="t" lIns="0" rIns="0" tIns="0" bIns="0">
+            <a:spAutoFit/>
+          </a:bodyPr>
+          <a:lstStyle/>
+          <a:p>
+            <a:pPr algn="l">
+              <a:lnSpc>
+                <a:spcPct val="110000"/>
+              </a:lnSpc>
+              <a:spcBef>
+                <a:spcPts val="0"/>
+              </a:spcBef>
+              <a:spcAft>
+                <a:spcPts val="600"/>
+              </a:spcAft>
+            </a:pPr>
+            <a:r>
+              <a:rPr sz="1500" b="1" i="0">
+                <a:solidFill>
+                  <a:srgbClr val="1E40AF"/>
+                </a:solidFill>
+                <a:latin typeface="Arial"/>
+              </a:rPr>
+              <a:t>ASPP — </a:t>
+            </a:r>
+            <a:r>
+              <a:rPr sz="1500" b="0" i="0">
+                <a:solidFill>
+                  <a:srgbClr val="1F2937"/>
+                </a:solidFill>
+                <a:latin typeface="Arial"/>
+              </a:rPr>
+              <a:t>Atrous Spatial Pyramid Pooling — параллельные свёртки с коэффициентами разрежения 6/12/18 + image-level pooling: охват разномасштабного контекста пятен</a:t>
+            </a:r>
+          </a:p>
+        </p:txBody>
+      </p:sp>
+      <p:sp>
+        <p:nvSpPr>
+          <p:cNvPr id="12" name="Oval 11"/>
+          <p:cNvSpPr/>
+          <p:nvPr/>
+        </p:nvSpPr>
+        <p:spPr>
+          <a:xfrm>
+            <a:off x="640080" y="3849624"/>
+            <a:ext cx="457200" cy="457200"/>
+          </a:xfrm>
+          <a:prstGeom prst="ellipse">
+            <a:avLst/>
+          </a:prstGeom>
+          <a:solidFill>
+            <a:srgbClr val="2563EB"/>
+          </a:solidFill>
+          <a:ln>
+            <a:noFill/>
+          </a:ln>
+          <a:effectLst/>
+        </p:spPr>
+        <p:style>
+          <a:lnRef idx="1">
+            <a:schemeClr val="accent1"/>
+          </a:lnRef>
+          <a:fillRef idx="3">
+            <a:schemeClr val="accent1"/>
+          </a:fillRef>
+          <a:effectRef idx="2">
+            <a:schemeClr val="accent1"/>
+          </a:effectRef>
+          <a:fontRef idx="minor">
+            <a:schemeClr val="lt1"/>
+          </a:fontRef>
+        </p:style>
+        <p:txBody>
+          <a:bodyPr rtlCol="0" anchor="ctr" lIns="0" rIns="0" tIns="0" bIns="0"/>
+          <a:lstStyle/>
+          <a:p>
+            <a:pPr algn="ctr"/>
+            <a:r>
+              <a:rPr sz="1600" b="1">
+                <a:solidFill>
+                  <a:srgbClr val="FFFFFF"/>
+                </a:solidFill>
+                <a:latin typeface="Arial"/>
+              </a:rPr>
+              <a:t>3</a:t>
+            </a:r>
+          </a:p>
+        </p:txBody>
+      </p:sp>
+      <p:sp>
+        <p:nvSpPr>
+          <p:cNvPr id="13" name="TextBox 12"/>
+          <p:cNvSpPr txBox="1"/>
+          <p:nvPr/>
+        </p:nvSpPr>
+        <p:spPr>
+          <a:xfrm>
+            <a:off x="1280160" y="3831336"/>
+            <a:ext cx="10241280" cy="1005840"/>
+          </a:xfrm>
+          <a:prstGeom prst="rect">
+            <a:avLst/>
+          </a:prstGeom>
+          <a:noFill/>
+        </p:spPr>
+        <p:txBody>
+          <a:bodyPr wrap="square" anchor="t" lIns="0" rIns="0" tIns="0" bIns="0">
+            <a:spAutoFit/>
+          </a:bodyPr>
+          <a:lstStyle/>
+          <a:p>
+            <a:pPr algn="l">
+              <a:lnSpc>
+                <a:spcPct val="110000"/>
+              </a:lnSpc>
+              <a:spcBef>
+                <a:spcPts val="0"/>
+              </a:spcBef>
+              <a:spcAft>
+                <a:spcPts val="600"/>
+              </a:spcAft>
+            </a:pPr>
+            <a:r>
+              <a:rPr sz="1500" b="1" i="0">
+                <a:solidFill>
+                  <a:srgbClr val="1E40AF"/>
+                </a:solidFill>
+                <a:latin typeface="Arial"/>
+              </a:rPr>
+              <a:t>scSE-внимание — </a:t>
+            </a:r>
+            <a:r>
+              <a:rPr sz="1500" b="0" i="0">
+                <a:solidFill>
+                  <a:srgbClr val="1F2937"/>
+                </a:solidFill>
+                <a:latin typeface="Arial"/>
+              </a:rPr>
+              <a:t>spatial + channel Squeeze-and-Excitation: усиление информативных каналов и пространственных зон</a:t>
+            </a:r>
+          </a:p>
+        </p:txBody>
+      </p:sp>
+      <p:sp>
+        <p:nvSpPr>
+          <p:cNvPr id="14" name="Oval 13"/>
+          <p:cNvSpPr/>
+          <p:nvPr/>
+        </p:nvSpPr>
+        <p:spPr>
+          <a:xfrm>
+            <a:off x="640080" y="4928616"/>
+            <a:ext cx="457200" cy="457200"/>
+          </a:xfrm>
+          <a:prstGeom prst="ellipse">
+            <a:avLst/>
+          </a:prstGeom>
+          <a:solidFill>
+            <a:srgbClr val="2563EB"/>
+          </a:solidFill>
+          <a:ln>
+            <a:noFill/>
+          </a:ln>
+          <a:effectLst/>
+        </p:spPr>
+        <p:style>
+          <a:lnRef idx="1">
+            <a:schemeClr val="accent1"/>
+          </a:lnRef>
+          <a:fillRef idx="3">
+            <a:schemeClr val="accent1"/>
+          </a:fillRef>
+          <a:effectRef idx="2">
+            <a:schemeClr val="accent1"/>
+          </a:effectRef>
+          <a:fontRef idx="minor">
+            <a:schemeClr val="lt1"/>
+          </a:fontRef>
+        </p:style>
+        <p:txBody>
+          <a:bodyPr rtlCol="0" anchor="ctr" lIns="0" rIns="0" tIns="0" bIns="0"/>
+          <a:lstStyle/>
+          <a:p>
+            <a:pPr algn="ctr"/>
+            <a:r>
+              <a:rPr sz="1600" b="1">
+                <a:solidFill>
+                  <a:srgbClr val="FFFFFF"/>
+                </a:solidFill>
+                <a:latin typeface="Arial"/>
+              </a:rPr>
+              <a:t>4</a:t>
+            </a:r>
+          </a:p>
+        </p:txBody>
+      </p:sp>
+      <p:sp>
+        <p:nvSpPr>
+          <p:cNvPr id="15" name="TextBox 14"/>
+          <p:cNvSpPr txBox="1"/>
+          <p:nvPr/>
+        </p:nvSpPr>
+        <p:spPr>
+          <a:xfrm>
+            <a:off x="1280160" y="4910328"/>
+            <a:ext cx="10241280" cy="1005840"/>
+          </a:xfrm>
+          <a:prstGeom prst="rect">
+            <a:avLst/>
+          </a:prstGeom>
+          <a:noFill/>
+        </p:spPr>
+        <p:txBody>
+          <a:bodyPr wrap="square" anchor="t" lIns="0" rIns="0" tIns="0" bIns="0">
+            <a:spAutoFit/>
+          </a:bodyPr>
+          <a:lstStyle/>
+          <a:p>
+            <a:pPr algn="l">
+              <a:lnSpc>
+                <a:spcPct val="110000"/>
+              </a:lnSpc>
+              <a:spcBef>
+                <a:spcPts val="0"/>
+              </a:spcBef>
+              <a:spcAft>
+                <a:spcPts val="600"/>
+              </a:spcAft>
+            </a:pPr>
+            <a:r>
+              <a:rPr sz="1500" b="1" i="0">
+                <a:solidFill>
+                  <a:srgbClr val="1E40AF"/>
+                </a:solidFill>
+                <a:latin typeface="Arial"/>
+              </a:rPr>
+              <a:t>Декодер — </a:t>
+            </a:r>
+            <a:r>
+              <a:rPr sz="1500" b="0" i="0">
+                <a:solidFill>
+                  <a:srgbClr val="1F2937"/>
+                </a:solidFill>
+                <a:latin typeface="Arial"/>
+              </a:rPr>
+              <a:t>объединение низко- и высокоуровневых признаков, апсемплинг до исходного разрешения, попиксельная классификация на 3 класса</a:t>
+            </a:r>
+          </a:p>
+        </p:txBody>
+      </p:sp>
+    </p:spTree>
+  </p:cSld>
+  <p:clrMapOvr>
+    <a:masterClrMapping/>
+  </p:clrMapOvr>
+</p:sld>
+</file>
+
+<file path=ppt/slides/slide15.xml><?xml version="1.0" encoding="utf-8"?>
+<p:sld xmlns:a="http://schemas.openxmlformats.org/drawingml/2006/main" xmlns:p="http://schemas.openxmlformats.org/presentationml/2006/main" xmlns:r="http://schemas.openxmlformats.org/officeDocument/2006/relationships">
+  <p:cSld>
+    <p:spTree>
+      <p:nvGrpSpPr>
+        <p:cNvPr id="1" name=""/>
+        <p:cNvGrpSpPr/>
+        <p:nvPr/>
+      </p:nvGrpSpPr>
+      <p:grpSpPr/>
+      <p:sp>
+        <p:nvSpPr>
+          <p:cNvPr id="2" name="Rectangle 1"/>
+          <p:cNvSpPr/>
+          <p:nvPr/>
+        </p:nvSpPr>
+        <p:spPr>
+          <a:xfrm>
+            <a:off x="0" y="0"/>
+            <a:ext cx="12191695" cy="6858000"/>
+          </a:xfrm>
+          <a:prstGeom prst="rect">
+            <a:avLst/>
+          </a:prstGeom>
+          <a:solidFill>
+            <a:srgbClr val="FFFFFF"/>
+          </a:solidFill>
+          <a:ln>
+            <a:noFill/>
+          </a:ln>
+          <a:effectLst/>
+        </p:spPr>
+        <p:style>
+          <a:lnRef idx="1">
+            <a:schemeClr val="accent1"/>
+          </a:lnRef>
+          <a:fillRef idx="3">
+            <a:schemeClr val="accent1"/>
+          </a:fillRef>
+          <a:effectRef idx="2">
+            <a:schemeClr val="accent1"/>
+          </a:effectRef>
+          <a:fontRef idx="minor">
+            <a:schemeClr val="lt1"/>
+          </a:fontRef>
+        </p:style>
+        <p:txBody>
+          <a:bodyPr rtlCol="0" anchor="ctr"/>
+          <a:lstStyle/>
+          <a:p>
+            <a:pPr algn="ctr"/>
+          </a:p>
+        </p:txBody>
+      </p:sp>
+      <p:sp>
+        <p:nvSpPr>
+          <p:cNvPr id="3" name="Rectangle 2"/>
+          <p:cNvSpPr/>
+          <p:nvPr/>
+        </p:nvSpPr>
+        <p:spPr>
+          <a:xfrm>
+            <a:off x="0" y="0"/>
+            <a:ext cx="146304" cy="6858000"/>
+          </a:xfrm>
+          <a:prstGeom prst="rect">
+            <a:avLst/>
+          </a:prstGeom>
+          <a:solidFill>
+            <a:srgbClr val="2563EB"/>
+          </a:solidFill>
+          <a:ln>
+            <a:noFill/>
+          </a:ln>
+          <a:effectLst/>
+        </p:spPr>
+        <p:style>
+          <a:lnRef idx="1">
+            <a:schemeClr val="accent1"/>
+          </a:lnRef>
+          <a:fillRef idx="3">
+            <a:schemeClr val="accent1"/>
+          </a:fillRef>
+          <a:effectRef idx="2">
+            <a:schemeClr val="accent1"/>
+          </a:effectRef>
+          <a:fontRef idx="minor">
+            <a:schemeClr val="lt1"/>
+          </a:fontRef>
+        </p:style>
+        <p:txBody>
+          <a:bodyPr rtlCol="0" anchor="ctr"/>
+          <a:lstStyle/>
+          <a:p>
+            <a:pPr algn="ctr"/>
+          </a:p>
+        </p:txBody>
+      </p:sp>
+      <p:sp>
+        <p:nvSpPr>
+          <p:cNvPr id="4" name="TextBox 3"/>
+          <p:cNvSpPr txBox="1"/>
+          <p:nvPr/>
+        </p:nvSpPr>
+        <p:spPr>
+          <a:xfrm>
+            <a:off x="640080" y="310896"/>
+            <a:ext cx="10058400" cy="274320"/>
+          </a:xfrm>
+          <a:prstGeom prst="rect">
+            <a:avLst/>
+          </a:prstGeom>
+          <a:noFill/>
+        </p:spPr>
+        <p:txBody>
+          <a:bodyPr wrap="square" anchor="t" lIns="0" rIns="0" tIns="0" bIns="0">
+            <a:spAutoFit/>
+          </a:bodyPr>
+          <a:lstStyle/>
+          <a:p>
+            <a:pPr algn="l">
+              <a:lnSpc>
+                <a:spcPct val="105000"/>
+              </a:lnSpc>
+              <a:spcBef>
+                <a:spcPts val="0"/>
+              </a:spcBef>
+              <a:spcAft>
+                <a:spcPts val="600"/>
+              </a:spcAft>
+            </a:pPr>
+            <a:r>
+              <a:rPr sz="1100" b="1" i="0">
+                <a:solidFill>
+                  <a:srgbClr val="6B7280"/>
+                </a:solidFill>
+                <a:latin typeface="Arial"/>
+              </a:rPr>
+              <a:t>РЕЗЕРВНЫЙ СЛАЙД</a:t>
+            </a:r>
+          </a:p>
+        </p:txBody>
+      </p:sp>
+      <p:sp>
+        <p:nvSpPr>
+          <p:cNvPr id="5" name="TextBox 4"/>
+          <p:cNvSpPr txBox="1"/>
+          <p:nvPr/>
+        </p:nvSpPr>
+        <p:spPr>
+          <a:xfrm>
+            <a:off x="640080" y="566928"/>
+            <a:ext cx="10972800" cy="731520"/>
+          </a:xfrm>
+          <a:prstGeom prst="rect">
+            <a:avLst/>
+          </a:prstGeom>
+          <a:noFill/>
+        </p:spPr>
+        <p:txBody>
+          <a:bodyPr wrap="square" anchor="t" lIns="0" rIns="0" tIns="0" bIns="0">
+            <a:spAutoFit/>
+          </a:bodyPr>
+          <a:lstStyle/>
+          <a:p>
+            <a:pPr algn="l">
+              <a:lnSpc>
+                <a:spcPct val="105000"/>
+              </a:lnSpc>
+              <a:spcBef>
+                <a:spcPts val="0"/>
+              </a:spcBef>
+              <a:spcAft>
+                <a:spcPts val="600"/>
+              </a:spcAft>
+            </a:pPr>
+            <a:r>
+              <a:rPr sz="3000" b="1" i="0">
+                <a:solidFill>
+                  <a:srgbClr val="2563EB"/>
+                </a:solidFill>
+                <a:latin typeface="Arial"/>
+              </a:rPr>
+              <a:t>Функция потерь и гиперпараметры</a:t>
+            </a:r>
+          </a:p>
+        </p:txBody>
+      </p:sp>
+      <p:sp>
+        <p:nvSpPr>
+          <p:cNvPr id="6" name="Rectangle 5"/>
+          <p:cNvSpPr/>
+          <p:nvPr/>
+        </p:nvSpPr>
+        <p:spPr>
+          <a:xfrm>
+            <a:off x="640080" y="1225296"/>
+            <a:ext cx="2011680" cy="38100"/>
+          </a:xfrm>
+          <a:prstGeom prst="rect">
+            <a:avLst/>
+          </a:prstGeom>
+          <a:solidFill>
+            <a:srgbClr val="2563EB"/>
+          </a:solidFill>
+          <a:ln>
+            <a:noFill/>
+          </a:ln>
+          <a:effectLst/>
+        </p:spPr>
+        <p:style>
+          <a:lnRef idx="1">
+            <a:schemeClr val="accent1"/>
+          </a:lnRef>
+          <a:fillRef idx="3">
+            <a:schemeClr val="accent1"/>
+          </a:fillRef>
+          <a:effectRef idx="2">
+            <a:schemeClr val="accent1"/>
+          </a:effectRef>
+          <a:fontRef idx="minor">
+            <a:schemeClr val="lt1"/>
+          </a:fontRef>
+        </p:style>
+        <p:txBody>
+          <a:bodyPr rtlCol="0" anchor="ctr"/>
+          <a:lstStyle/>
+          <a:p>
+            <a:pPr algn="ctr"/>
+          </a:p>
+        </p:txBody>
+      </p:sp>
+      <p:sp>
+        <p:nvSpPr>
+          <p:cNvPr id="7" name="Rounded Rectangle 6"/>
+          <p:cNvSpPr/>
+          <p:nvPr/>
+        </p:nvSpPr>
+        <p:spPr>
+          <a:xfrm>
+            <a:off x="11140135" y="6355080"/>
+            <a:ext cx="777240" cy="310896"/>
+          </a:xfrm>
+          <a:prstGeom prst="roundRect">
+            <a:avLst/>
+          </a:prstGeom>
+          <a:solidFill>
+            <a:srgbClr val="F3F6FC"/>
+          </a:solidFill>
+          <a:ln w="9525">
+            <a:solidFill>
+              <a:srgbClr val="E2E8F0"/>
+            </a:solidFill>
+          </a:ln>
+          <a:effectLst/>
+        </p:spPr>
+        <p:style>
+          <a:lnRef idx="1">
+            <a:schemeClr val="accent1"/>
+          </a:lnRef>
+          <a:fillRef idx="3">
+            <a:schemeClr val="accent1"/>
+          </a:fillRef>
+          <a:effectRef idx="2">
+            <a:schemeClr val="accent1"/>
+          </a:effectRef>
+          <a:fontRef idx="minor">
+            <a:schemeClr val="lt1"/>
+          </a:fontRef>
+        </p:style>
+        <p:txBody>
+          <a:bodyPr rtlCol="0" anchor="ctr" wrap="none" lIns="0" rIns="0" tIns="0" bIns="0"/>
+          <a:lstStyle/>
+          <a:p>
+            <a:pPr algn="ctr"/>
+            <a:r>
+              <a:rPr sz="1100">
+                <a:solidFill>
+                  <a:srgbClr val="6B7280"/>
+                </a:solidFill>
+                <a:latin typeface="Arial"/>
+              </a:rPr>
+              <a:t>15 / 18</a:t>
+            </a:r>
+          </a:p>
+        </p:txBody>
+      </p:sp>
+      <p:sp>
+        <p:nvSpPr>
+          <p:cNvPr id="8" name="TextBox 7"/>
+          <p:cNvSpPr txBox="1"/>
+          <p:nvPr/>
+        </p:nvSpPr>
+        <p:spPr>
+          <a:xfrm>
+            <a:off x="640080" y="1600200"/>
+            <a:ext cx="5486400" cy="365760"/>
+          </a:xfrm>
+          <a:prstGeom prst="rect">
+            <a:avLst/>
+          </a:prstGeom>
+          <a:noFill/>
+        </p:spPr>
+        <p:txBody>
+          <a:bodyPr wrap="square" anchor="t" lIns="0" rIns="0" tIns="0" bIns="0">
+            <a:spAutoFit/>
+          </a:bodyPr>
+          <a:lstStyle/>
+          <a:p>
+            <a:pPr algn="l">
+              <a:lnSpc>
+                <a:spcPct val="105000"/>
+              </a:lnSpc>
+              <a:spcBef>
+                <a:spcPts val="0"/>
+              </a:spcBef>
+              <a:spcAft>
+                <a:spcPts val="600"/>
+              </a:spcAft>
+            </a:pPr>
+            <a:r>
+              <a:rPr sz="1600" b="1" i="0">
+                <a:solidFill>
+                  <a:srgbClr val="1F2937"/>
+                </a:solidFill>
+                <a:latin typeface="Arial"/>
+              </a:rPr>
+              <a:t>Комбинированная функция потерь Dice-BCE</a:t>
+            </a:r>
+          </a:p>
+        </p:txBody>
+      </p:sp>
+      <p:sp>
+        <p:nvSpPr>
+          <p:cNvPr id="9" name="TextBox 8"/>
+          <p:cNvSpPr txBox="1"/>
+          <p:nvPr/>
+        </p:nvSpPr>
+        <p:spPr>
+          <a:xfrm>
+            <a:off x="640080" y="2057400"/>
+            <a:ext cx="5394960" cy="914400"/>
+          </a:xfrm>
+          <a:prstGeom prst="rect">
+            <a:avLst/>
+          </a:prstGeom>
+          <a:noFill/>
+        </p:spPr>
+        <p:txBody>
+          <a:bodyPr wrap="square" anchor="t" lIns="0" rIns="0" tIns="0" bIns="0">
+            <a:spAutoFit/>
+          </a:bodyPr>
+          <a:lstStyle/>
+          <a:p>
+            <a:pPr algn="l">
+              <a:lnSpc>
+                <a:spcPct val="115000"/>
+              </a:lnSpc>
+              <a:spcBef>
+                <a:spcPts val="0"/>
+              </a:spcBef>
+              <a:spcAft>
+                <a:spcPts val="600"/>
+              </a:spcAft>
+            </a:pPr>
+            <a:r>
+              <a:rPr sz="1400" b="0" i="0">
+                <a:solidFill>
+                  <a:srgbClr val="1F2937"/>
+                </a:solidFill>
+                <a:latin typeface="Arial"/>
+              </a:rPr>
+              <a:t>L = L_Dice + L_BCE с весами классов для устранения дисбаланса. Dice работает с перекрытием масок, BCE — с попиксельной вероятностью.</a:t>
+            </a:r>
+          </a:p>
+        </p:txBody>
+      </p:sp>
+      <p:graphicFrame>
+        <p:nvGraphicFramePr>
+          <p:cNvPr id="10" name="Table 9"/>
+          <p:cNvGraphicFramePr>
+            <a:graphicFrameLocks noGrp="1"/>
+          </p:cNvGraphicFramePr>
+          <p:nvPr/>
+        </p:nvGraphicFramePr>
+        <p:xfrm>
+          <a:off x="640080" y="3291840"/>
+          <a:ext cx="3657600" cy="1828800"/>
+        </p:xfrm>
+        <a:graphic>
+          <a:graphicData uri="http://schemas.openxmlformats.org/drawingml/2006/table">
+            <a:tbl>
+              <a:tblPr>
+                <a:tableStyleId>{5C22544A-7EE6-4342-B048-85BDC9FD1C3A}</a:tableStyleId>
+              </a:tblPr>
+              <a:tblGrid>
+                <a:gridCol w="2194560"/>
+                <a:gridCol w="1463040"/>
+              </a:tblGrid>
+              <a:tr h="457200">
+                <a:tc>
+                  <a:txBody>
+                    <a:bodyPr/>
+                    <a:lstStyle/>
+                    <a:p>
+                      <a:pPr algn="l"/>
+                      <a:r>
+                        <a:rPr sz="1200" b="1">
+                          <a:solidFill>
+                            <a:srgbClr val="1E40AF"/>
+                          </a:solidFill>
+                          <a:latin typeface="Arial"/>
+                        </a:rPr>
+                        <a:t>Класс</a:t>
+                      </a:r>
+                    </a:p>
+                  </a:txBody>
+                  <a:tcPr marL="73152" marR="54864" marT="27432" marB="27432" anchor="ctr">
+                    <a:solidFill>
+                      <a:srgbClr val="DBEAFE"/>
+                    </a:solidFill>
+                  </a:tcPr>
+                </a:tc>
+                <a:tc>
+                  <a:txBody>
+                    <a:bodyPr/>
+                    <a:lstStyle/>
+                    <a:p>
+                      <a:pPr algn="ctr"/>
+                      <a:r>
+                        <a:rPr sz="1200" b="1">
+                          <a:solidFill>
+                            <a:srgbClr val="1E40AF"/>
+                          </a:solidFill>
+                          <a:latin typeface="Arial"/>
+                        </a:rPr>
+                        <a:t>Вес</a:t>
+                      </a:r>
+                    </a:p>
+                  </a:txBody>
+                  <a:tcPr marL="73152" marR="54864" marT="27432" marB="27432" anchor="ctr">
+                    <a:solidFill>
+                      <a:srgbClr val="DBEAFE"/>
+                    </a:solidFill>
+                  </a:tcPr>
+                </a:tc>
+              </a:tr>
+              <a:tr h="457200">
+                <a:tc>
+                  <a:txBody>
+                    <a:bodyPr/>
+                    <a:lstStyle/>
+                    <a:p>
+                      <a:pPr algn="l"/>
+                      <a:r>
+                        <a:rPr sz="1200" b="1">
+                          <a:solidFill>
+                            <a:srgbClr val="1F2937"/>
+                          </a:solidFill>
+                          <a:latin typeface="Arial"/>
+                        </a:rPr>
+                        <a:t>вода</a:t>
+                      </a:r>
+                    </a:p>
+                  </a:txBody>
+                  <a:tcPr marL="73152" marR="54864" marT="27432" marB="27432" anchor="ctr">
+                    <a:solidFill>
+                      <a:srgbClr val="FFFFFF"/>
+                    </a:solidFill>
+                  </a:tcPr>
+                </a:tc>
+                <a:tc>
+                  <a:txBody>
+                    <a:bodyPr/>
+                    <a:lstStyle/>
+                    <a:p>
+                      <a:pPr algn="ctr"/>
+                      <a:r>
+                        <a:rPr sz="1200" b="0">
+                          <a:solidFill>
+                            <a:srgbClr val="1F2937"/>
+                          </a:solidFill>
+                          <a:latin typeface="Arial"/>
+                        </a:rPr>
+                        <a:t>0,3</a:t>
+                      </a:r>
+                    </a:p>
+                  </a:txBody>
+                  <a:tcPr marL="73152" marR="54864" marT="27432" marB="27432" anchor="ctr">
+                    <a:solidFill>
+                      <a:srgbClr val="FFFFFF"/>
+                    </a:solidFill>
+                  </a:tcPr>
+                </a:tc>
+              </a:tr>
+              <a:tr h="457200">
+                <a:tc>
+                  <a:txBody>
+                    <a:bodyPr/>
+                    <a:lstStyle/>
+                    <a:p>
+                      <a:pPr algn="l"/>
+                      <a:r>
+                        <a:rPr sz="1200" b="1">
+                          <a:solidFill>
+                            <a:srgbClr val="1F2937"/>
+                          </a:solidFill>
+                          <a:latin typeface="Arial"/>
+                        </a:rPr>
+                        <a:t>нефть</a:t>
+                      </a:r>
+                    </a:p>
+                  </a:txBody>
+                  <a:tcPr marL="73152" marR="54864" marT="27432" marB="27432" anchor="ctr">
+                    <a:solidFill>
+                      <a:srgbClr val="F3F6FC"/>
+                    </a:solidFill>
+                  </a:tcPr>
+                </a:tc>
+                <a:tc>
+                  <a:txBody>
+                    <a:bodyPr/>
+                    <a:lstStyle/>
+                    <a:p>
+                      <a:pPr algn="ctr"/>
+                      <a:r>
+                        <a:rPr sz="1200" b="0">
+                          <a:solidFill>
+                            <a:srgbClr val="1F2937"/>
+                          </a:solidFill>
+                          <a:latin typeface="Arial"/>
+                        </a:rPr>
+                        <a:t>9,8</a:t>
+                      </a:r>
+                    </a:p>
+                  </a:txBody>
+                  <a:tcPr marL="73152" marR="54864" marT="27432" marB="27432" anchor="ctr">
+                    <a:solidFill>
+                      <a:srgbClr val="F3F6FC"/>
+                    </a:solidFill>
+                  </a:tcPr>
+                </a:tc>
+              </a:tr>
+              <a:tr h="457200">
+                <a:tc>
+                  <a:txBody>
+                    <a:bodyPr/>
+                    <a:lstStyle/>
+                    <a:p>
+                      <a:pPr algn="l"/>
+                      <a:r>
+                        <a:rPr sz="1200" b="1">
+                          <a:solidFill>
+                            <a:srgbClr val="1F2937"/>
+                          </a:solidFill>
+                          <a:latin typeface="Arial"/>
+                        </a:rPr>
+                        <a:t>лёд + суша</a:t>
+                      </a:r>
+                    </a:p>
+                  </a:txBody>
+                  <a:tcPr marL="73152" marR="54864" marT="27432" marB="27432" anchor="ctr">
+                    <a:solidFill>
+                      <a:srgbClr val="FFFFFF"/>
+                    </a:solidFill>
+                  </a:tcPr>
+                </a:tc>
+                <a:tc>
+                  <a:txBody>
+                    <a:bodyPr/>
+                    <a:lstStyle/>
+                    <a:p>
+                      <a:pPr algn="ctr"/>
+                      <a:r>
+                        <a:rPr sz="1200" b="0">
+                          <a:solidFill>
+                            <a:srgbClr val="1F2937"/>
+                          </a:solidFill>
+                          <a:latin typeface="Arial"/>
+                        </a:rPr>
+                        <a:t>1,2</a:t>
+                      </a:r>
+                    </a:p>
+                  </a:txBody>
+                  <a:tcPr marL="73152" marR="54864" marT="27432" marB="27432" anchor="ctr">
+                    <a:solidFill>
+                      <a:srgbClr val="FFFFFF"/>
+                    </a:solidFill>
+                  </a:tcPr>
+                </a:tc>
+              </a:tr>
+            </a:tbl>
+          </a:graphicData>
+        </a:graphic>
+      </p:graphicFrame>
+      <p:sp>
+        <p:nvSpPr>
+          <p:cNvPr id="11" name="TextBox 10"/>
+          <p:cNvSpPr txBox="1"/>
+          <p:nvPr/>
+        </p:nvSpPr>
+        <p:spPr>
+          <a:xfrm>
+            <a:off x="6400800" y="1600200"/>
+            <a:ext cx="5120640" cy="365760"/>
+          </a:xfrm>
+          <a:prstGeom prst="rect">
+            <a:avLst/>
+          </a:prstGeom>
+          <a:noFill/>
+        </p:spPr>
+        <p:txBody>
+          <a:bodyPr wrap="square" anchor="t" lIns="0" rIns="0" tIns="0" bIns="0">
+            <a:spAutoFit/>
+          </a:bodyPr>
+          <a:lstStyle/>
+          <a:p>
+            <a:pPr algn="l">
+              <a:lnSpc>
+                <a:spcPct val="105000"/>
+              </a:lnSpc>
+              <a:spcBef>
+                <a:spcPts val="0"/>
+              </a:spcBef>
+              <a:spcAft>
+                <a:spcPts val="600"/>
+              </a:spcAft>
+            </a:pPr>
+            <a:r>
+              <a:rPr sz="1600" b="1" i="0">
+                <a:solidFill>
+                  <a:srgbClr val="1F2937"/>
+                </a:solidFill>
+                <a:latin typeface="Arial"/>
+              </a:rPr>
+              <a:t>Параметры обучения</a:t>
+            </a:r>
+          </a:p>
+        </p:txBody>
+      </p:sp>
+      <p:sp>
+        <p:nvSpPr>
+          <p:cNvPr id="12" name="TextBox 11"/>
+          <p:cNvSpPr txBox="1"/>
+          <p:nvPr/>
+        </p:nvSpPr>
+        <p:spPr>
+          <a:xfrm>
+            <a:off x="6400800" y="2103120"/>
+            <a:ext cx="2743200" cy="365760"/>
+          </a:xfrm>
+          <a:prstGeom prst="rect">
+            <a:avLst/>
+          </a:prstGeom>
+          <a:noFill/>
+        </p:spPr>
+        <p:txBody>
+          <a:bodyPr wrap="square" anchor="t" lIns="0" rIns="0" tIns="0" bIns="0">
+            <a:spAutoFit/>
+          </a:bodyPr>
+          <a:lstStyle/>
+          <a:p>
+            <a:pPr algn="l">
+              <a:lnSpc>
+                <a:spcPct val="105000"/>
+              </a:lnSpc>
+              <a:spcBef>
+                <a:spcPts val="0"/>
+              </a:spcBef>
+              <a:spcAft>
+                <a:spcPts val="600"/>
+              </a:spcAft>
+            </a:pPr>
+            <a:r>
+              <a:rPr sz="1400" b="1" i="0">
+                <a:solidFill>
+                  <a:srgbClr val="6B7280"/>
+                </a:solidFill>
+                <a:latin typeface="Arial"/>
+              </a:rPr>
+              <a:t>Оптимизатор</a:t>
+            </a:r>
+          </a:p>
+        </p:txBody>
+      </p:sp>
+      <p:sp>
+        <p:nvSpPr>
+          <p:cNvPr id="13" name="TextBox 12"/>
+          <p:cNvSpPr txBox="1"/>
+          <p:nvPr/>
+        </p:nvSpPr>
+        <p:spPr>
+          <a:xfrm>
+            <a:off x="9144000" y="2103120"/>
+            <a:ext cx="2377440" cy="365760"/>
+          </a:xfrm>
+          <a:prstGeom prst="rect">
+            <a:avLst/>
+          </a:prstGeom>
+          <a:noFill/>
+        </p:spPr>
+        <p:txBody>
+          <a:bodyPr wrap="square" anchor="t" lIns="0" rIns="0" tIns="0" bIns="0">
+            <a:spAutoFit/>
+          </a:bodyPr>
+          <a:lstStyle/>
+          <a:p>
+            <a:pPr algn="l">
+              <a:lnSpc>
+                <a:spcPct val="105000"/>
+              </a:lnSpc>
+              <a:spcBef>
+                <a:spcPts val="0"/>
+              </a:spcBef>
+              <a:spcAft>
+                <a:spcPts val="600"/>
+              </a:spcAft>
+            </a:pPr>
+            <a:r>
+              <a:rPr sz="1400" b="0" i="0">
+                <a:solidFill>
+                  <a:srgbClr val="1F2937"/>
+                </a:solidFill>
+                <a:latin typeface="Arial"/>
+              </a:rPr>
+              <a:t>AdamW</a:t>
+            </a:r>
+          </a:p>
+        </p:txBody>
+      </p:sp>
+      <p:sp>
+        <p:nvSpPr>
+          <p:cNvPr id="14" name="TextBox 13"/>
+          <p:cNvSpPr txBox="1"/>
+          <p:nvPr/>
+        </p:nvSpPr>
+        <p:spPr>
+          <a:xfrm>
+            <a:off x="6400800" y="2670048"/>
+            <a:ext cx="2743200" cy="365760"/>
+          </a:xfrm>
+          <a:prstGeom prst="rect">
+            <a:avLst/>
+          </a:prstGeom>
+          <a:noFill/>
+        </p:spPr>
+        <p:txBody>
+          <a:bodyPr wrap="square" anchor="t" lIns="0" rIns="0" tIns="0" bIns="0">
+            <a:spAutoFit/>
+          </a:bodyPr>
+          <a:lstStyle/>
+          <a:p>
+            <a:pPr algn="l">
+              <a:lnSpc>
+                <a:spcPct val="105000"/>
+              </a:lnSpc>
+              <a:spcBef>
+                <a:spcPts val="0"/>
+              </a:spcBef>
+              <a:spcAft>
+                <a:spcPts val="600"/>
+              </a:spcAft>
+            </a:pPr>
+            <a:r>
+              <a:rPr sz="1400" b="1" i="0">
+                <a:solidFill>
+                  <a:srgbClr val="6B7280"/>
+                </a:solidFill>
+                <a:latin typeface="Arial"/>
+              </a:rPr>
+              <a:t>Learning rate</a:t>
+            </a:r>
+          </a:p>
+        </p:txBody>
+      </p:sp>
+      <p:sp>
+        <p:nvSpPr>
+          <p:cNvPr id="15" name="TextBox 14"/>
+          <p:cNvSpPr txBox="1"/>
+          <p:nvPr/>
+        </p:nvSpPr>
+        <p:spPr>
+          <a:xfrm>
+            <a:off x="9144000" y="2670048"/>
+            <a:ext cx="2377440" cy="365760"/>
+          </a:xfrm>
+          <a:prstGeom prst="rect">
+            <a:avLst/>
+          </a:prstGeom>
+          <a:noFill/>
+        </p:spPr>
+        <p:txBody>
+          <a:bodyPr wrap="square" anchor="t" lIns="0" rIns="0" tIns="0" bIns="0">
+            <a:spAutoFit/>
+          </a:bodyPr>
+          <a:lstStyle/>
+          <a:p>
+            <a:pPr algn="l">
+              <a:lnSpc>
+                <a:spcPct val="105000"/>
+              </a:lnSpc>
+              <a:spcBef>
+                <a:spcPts val="0"/>
+              </a:spcBef>
+              <a:spcAft>
+                <a:spcPts val="600"/>
+              </a:spcAft>
+            </a:pPr>
+            <a:r>
+              <a:rPr sz="1400" b="0" i="0">
+                <a:solidFill>
+                  <a:srgbClr val="1F2937"/>
+                </a:solidFill>
+                <a:latin typeface="Arial"/>
+              </a:rPr>
+              <a:t>1·10⁻⁴</a:t>
+            </a:r>
+          </a:p>
+        </p:txBody>
+      </p:sp>
+      <p:sp>
+        <p:nvSpPr>
+          <p:cNvPr id="16" name="TextBox 15"/>
+          <p:cNvSpPr txBox="1"/>
+          <p:nvPr/>
+        </p:nvSpPr>
+        <p:spPr>
+          <a:xfrm>
+            <a:off x="6400800" y="3236976"/>
+            <a:ext cx="2743200" cy="365760"/>
+          </a:xfrm>
+          <a:prstGeom prst="rect">
+            <a:avLst/>
+          </a:prstGeom>
+          <a:noFill/>
+        </p:spPr>
+        <p:txBody>
+          <a:bodyPr wrap="square" anchor="t" lIns="0" rIns="0" tIns="0" bIns="0">
+            <a:spAutoFit/>
+          </a:bodyPr>
+          <a:lstStyle/>
+          <a:p>
+            <a:pPr algn="l">
+              <a:lnSpc>
+                <a:spcPct val="105000"/>
+              </a:lnSpc>
+              <a:spcBef>
+                <a:spcPts val="0"/>
+              </a:spcBef>
+              <a:spcAft>
+                <a:spcPts val="600"/>
+              </a:spcAft>
+            </a:pPr>
+            <a:r>
+              <a:rPr sz="1400" b="1" i="0">
+                <a:solidFill>
+                  <a:srgbClr val="6B7280"/>
+                </a:solidFill>
+                <a:latin typeface="Arial"/>
+              </a:rPr>
+              <a:t>Weight decay</a:t>
+            </a:r>
+          </a:p>
+        </p:txBody>
+      </p:sp>
+      <p:sp>
+        <p:nvSpPr>
+          <p:cNvPr id="17" name="TextBox 16"/>
+          <p:cNvSpPr txBox="1"/>
+          <p:nvPr/>
+        </p:nvSpPr>
+        <p:spPr>
+          <a:xfrm>
+            <a:off x="9144000" y="3236976"/>
+            <a:ext cx="2377440" cy="365760"/>
+          </a:xfrm>
+          <a:prstGeom prst="rect">
+            <a:avLst/>
+          </a:prstGeom>
+          <a:noFill/>
+        </p:spPr>
+        <p:txBody>
+          <a:bodyPr wrap="square" anchor="t" lIns="0" rIns="0" tIns="0" bIns="0">
+            <a:spAutoFit/>
+          </a:bodyPr>
+          <a:lstStyle/>
+          <a:p>
+            <a:pPr algn="l">
+              <a:lnSpc>
+                <a:spcPct val="105000"/>
+              </a:lnSpc>
+              <a:spcBef>
+                <a:spcPts val="0"/>
+              </a:spcBef>
+              <a:spcAft>
+                <a:spcPts val="600"/>
+              </a:spcAft>
+            </a:pPr>
+            <a:r>
+              <a:rPr sz="1400" b="0" i="0">
+                <a:solidFill>
+                  <a:srgbClr val="1F2937"/>
+                </a:solidFill>
+                <a:latin typeface="Arial"/>
+              </a:rPr>
+              <a:t>1·10⁻⁴</a:t>
+            </a:r>
+          </a:p>
+        </p:txBody>
+      </p:sp>
+      <p:sp>
+        <p:nvSpPr>
+          <p:cNvPr id="18" name="TextBox 17"/>
+          <p:cNvSpPr txBox="1"/>
+          <p:nvPr/>
+        </p:nvSpPr>
+        <p:spPr>
+          <a:xfrm>
+            <a:off x="6400800" y="3803904"/>
+            <a:ext cx="2743200" cy="365760"/>
+          </a:xfrm>
+          <a:prstGeom prst="rect">
+            <a:avLst/>
+          </a:prstGeom>
+          <a:noFill/>
+        </p:spPr>
+        <p:txBody>
+          <a:bodyPr wrap="square" anchor="t" lIns="0" rIns="0" tIns="0" bIns="0">
+            <a:spAutoFit/>
+          </a:bodyPr>
+          <a:lstStyle/>
+          <a:p>
+            <a:pPr algn="l">
+              <a:lnSpc>
+                <a:spcPct val="105000"/>
+              </a:lnSpc>
+              <a:spcBef>
+                <a:spcPts val="0"/>
+              </a:spcBef>
+              <a:spcAft>
+                <a:spcPts val="600"/>
+              </a:spcAft>
+            </a:pPr>
+            <a:r>
+              <a:rPr sz="1400" b="1" i="0">
+                <a:solidFill>
+                  <a:srgbClr val="6B7280"/>
+                </a:solidFill>
+                <a:latin typeface="Arial"/>
+              </a:rPr>
+              <a:t>Расписание LR</a:t>
+            </a:r>
+          </a:p>
+        </p:txBody>
+      </p:sp>
+      <p:sp>
+        <p:nvSpPr>
+          <p:cNvPr id="19" name="TextBox 18"/>
+          <p:cNvSpPr txBox="1"/>
+          <p:nvPr/>
+        </p:nvSpPr>
+        <p:spPr>
+          <a:xfrm>
+            <a:off x="9144000" y="3803904"/>
+            <a:ext cx="2377440" cy="365760"/>
+          </a:xfrm>
+          <a:prstGeom prst="rect">
+            <a:avLst/>
+          </a:prstGeom>
+          <a:noFill/>
+        </p:spPr>
+        <p:txBody>
+          <a:bodyPr wrap="square" anchor="t" lIns="0" rIns="0" tIns="0" bIns="0">
+            <a:spAutoFit/>
+          </a:bodyPr>
+          <a:lstStyle/>
+          <a:p>
+            <a:pPr algn="l">
+              <a:lnSpc>
+                <a:spcPct val="105000"/>
+              </a:lnSpc>
+              <a:spcBef>
+                <a:spcPts val="0"/>
+              </a:spcBef>
+              <a:spcAft>
+                <a:spcPts val="600"/>
+              </a:spcAft>
+            </a:pPr>
+            <a:r>
+              <a:rPr sz="1400" b="0" i="0">
+                <a:solidFill>
+                  <a:srgbClr val="1F2937"/>
+                </a:solidFill>
+                <a:latin typeface="Arial"/>
+              </a:rPr>
+              <a:t>ReduceLROnPlateau</a:t>
+            </a:r>
+          </a:p>
+        </p:txBody>
+      </p:sp>
+      <p:sp>
+        <p:nvSpPr>
+          <p:cNvPr id="20" name="TextBox 19"/>
+          <p:cNvSpPr txBox="1"/>
+          <p:nvPr/>
+        </p:nvSpPr>
+        <p:spPr>
+          <a:xfrm>
+            <a:off x="6400800" y="4370832"/>
+            <a:ext cx="2743200" cy="365760"/>
+          </a:xfrm>
+          <a:prstGeom prst="rect">
+            <a:avLst/>
+          </a:prstGeom>
+          <a:noFill/>
+        </p:spPr>
+        <p:txBody>
+          <a:bodyPr wrap="square" anchor="t" lIns="0" rIns="0" tIns="0" bIns="0">
+            <a:spAutoFit/>
+          </a:bodyPr>
+          <a:lstStyle/>
+          <a:p>
+            <a:pPr algn="l">
+              <a:lnSpc>
+                <a:spcPct val="105000"/>
+              </a:lnSpc>
+              <a:spcBef>
+                <a:spcPts val="0"/>
+              </a:spcBef>
+              <a:spcAft>
+                <a:spcPts val="600"/>
+              </a:spcAft>
+            </a:pPr>
+            <a:r>
+              <a:rPr sz="1400" b="1" i="0">
+                <a:solidFill>
+                  <a:srgbClr val="6B7280"/>
+                </a:solidFill>
+                <a:latin typeface="Arial"/>
+              </a:rPr>
+              <a:t>Эпохи / batch</a:t>
+            </a:r>
+          </a:p>
+        </p:txBody>
+      </p:sp>
+      <p:sp>
+        <p:nvSpPr>
+          <p:cNvPr id="21" name="TextBox 20"/>
+          <p:cNvSpPr txBox="1"/>
+          <p:nvPr/>
+        </p:nvSpPr>
+        <p:spPr>
+          <a:xfrm>
+            <a:off x="9144000" y="4370832"/>
+            <a:ext cx="2377440" cy="365760"/>
+          </a:xfrm>
+          <a:prstGeom prst="rect">
+            <a:avLst/>
+          </a:prstGeom>
+          <a:noFill/>
+        </p:spPr>
+        <p:txBody>
+          <a:bodyPr wrap="square" anchor="t" lIns="0" rIns="0" tIns="0" bIns="0">
+            <a:spAutoFit/>
+          </a:bodyPr>
+          <a:lstStyle/>
+          <a:p>
+            <a:pPr algn="l">
+              <a:lnSpc>
+                <a:spcPct val="105000"/>
+              </a:lnSpc>
+              <a:spcBef>
+                <a:spcPts val="0"/>
+              </a:spcBef>
+              <a:spcAft>
+                <a:spcPts val="600"/>
+              </a:spcAft>
+            </a:pPr>
+            <a:r>
+              <a:rPr sz="1400" b="0" i="0">
+                <a:solidFill>
+                  <a:srgbClr val="1F2937"/>
+                </a:solidFill>
+                <a:latin typeface="Arial"/>
+              </a:rPr>
+              <a:t>100 / 8</a:t>
+            </a:r>
+          </a:p>
+        </p:txBody>
+      </p:sp>
+      <p:sp>
+        <p:nvSpPr>
+          <p:cNvPr id="22" name="TextBox 21"/>
+          <p:cNvSpPr txBox="1"/>
+          <p:nvPr/>
+        </p:nvSpPr>
+        <p:spPr>
+          <a:xfrm>
+            <a:off x="6400800" y="4937760"/>
+            <a:ext cx="2743200" cy="365760"/>
+          </a:xfrm>
+          <a:prstGeom prst="rect">
+            <a:avLst/>
+          </a:prstGeom>
+          <a:noFill/>
+        </p:spPr>
+        <p:txBody>
+          <a:bodyPr wrap="square" anchor="t" lIns="0" rIns="0" tIns="0" bIns="0">
+            <a:spAutoFit/>
+          </a:bodyPr>
+          <a:lstStyle/>
+          <a:p>
+            <a:pPr algn="l">
+              <a:lnSpc>
+                <a:spcPct val="105000"/>
+              </a:lnSpc>
+              <a:spcBef>
+                <a:spcPts val="0"/>
+              </a:spcBef>
+              <a:spcAft>
+                <a:spcPts val="600"/>
+              </a:spcAft>
+            </a:pPr>
+            <a:r>
+              <a:rPr sz="1400" b="1" i="0">
+                <a:solidFill>
+                  <a:srgbClr val="6B7280"/>
+                </a:solidFill>
+                <a:latin typeface="Arial"/>
+              </a:rPr>
+              <a:t>Аугментации</a:t>
+            </a:r>
+          </a:p>
+        </p:txBody>
+      </p:sp>
+      <p:sp>
+        <p:nvSpPr>
+          <p:cNvPr id="23" name="TextBox 22"/>
+          <p:cNvSpPr txBox="1"/>
+          <p:nvPr/>
+        </p:nvSpPr>
+        <p:spPr>
+          <a:xfrm>
+            <a:off x="9144000" y="4937760"/>
+            <a:ext cx="2377440" cy="365760"/>
+          </a:xfrm>
+          <a:prstGeom prst="rect">
+            <a:avLst/>
+          </a:prstGeom>
+          <a:noFill/>
+        </p:spPr>
+        <p:txBody>
+          <a:bodyPr wrap="square" anchor="t" lIns="0" rIns="0" tIns="0" bIns="0">
+            <a:spAutoFit/>
+          </a:bodyPr>
+          <a:lstStyle/>
+          <a:p>
+            <a:pPr algn="l">
+              <a:lnSpc>
+                <a:spcPct val="105000"/>
+              </a:lnSpc>
+              <a:spcBef>
+                <a:spcPts val="0"/>
+              </a:spcBef>
+              <a:spcAft>
+                <a:spcPts val="600"/>
+              </a:spcAft>
+            </a:pPr>
+            <a:r>
+              <a:rPr sz="1400" b="0" i="0">
+                <a:solidFill>
+                  <a:srgbClr val="1F2937"/>
+                </a:solidFill>
+                <a:latin typeface="Arial"/>
+              </a:rPr>
+              <a:t>повороты, отражения, TTA ×4</a:t>
+            </a:r>
+          </a:p>
+        </p:txBody>
+      </p:sp>
+    </p:spTree>
+  </p:cSld>
+  <p:clrMapOvr>
+    <a:masterClrMapping/>
+  </p:clrMapOvr>
+</p:sld>
+</file>
+
+<file path=ppt/slides/slide16.xml><?xml version="1.0" encoding="utf-8"?>
+<p:sld xmlns:a="http://schemas.openxmlformats.org/drawingml/2006/main" xmlns:p="http://schemas.openxmlformats.org/presentationml/2006/main" xmlns:r="http://schemas.openxmlformats.org/officeDocument/2006/relationships">
+  <p:cSld>
+    <p:spTree>
+      <p:nvGrpSpPr>
+        <p:cNvPr id="1" name=""/>
+        <p:cNvGrpSpPr/>
+        <p:nvPr/>
+      </p:nvGrpSpPr>
+      <p:grpSpPr/>
+      <p:sp>
+        <p:nvSpPr>
+          <p:cNvPr id="2" name="Rectangle 1"/>
+          <p:cNvSpPr/>
+          <p:nvPr/>
+        </p:nvSpPr>
+        <p:spPr>
+          <a:xfrm>
+            <a:off x="0" y="0"/>
+            <a:ext cx="12191695" cy="6858000"/>
+          </a:xfrm>
+          <a:prstGeom prst="rect">
+            <a:avLst/>
+          </a:prstGeom>
+          <a:solidFill>
+            <a:srgbClr val="FFFFFF"/>
+          </a:solidFill>
+          <a:ln>
+            <a:noFill/>
+          </a:ln>
+          <a:effectLst/>
+        </p:spPr>
+        <p:style>
+          <a:lnRef idx="1">
+            <a:schemeClr val="accent1"/>
+          </a:lnRef>
+          <a:fillRef idx="3">
+            <a:schemeClr val="accent1"/>
+          </a:fillRef>
+          <a:effectRef idx="2">
+            <a:schemeClr val="accent1"/>
+          </a:effectRef>
+          <a:fontRef idx="minor">
+            <a:schemeClr val="lt1"/>
+          </a:fontRef>
+        </p:style>
+        <p:txBody>
+          <a:bodyPr rtlCol="0" anchor="ctr"/>
+          <a:lstStyle/>
+          <a:p>
+            <a:pPr algn="ctr"/>
+          </a:p>
+        </p:txBody>
+      </p:sp>
+      <p:sp>
+        <p:nvSpPr>
+          <p:cNvPr id="3" name="Rectangle 2"/>
+          <p:cNvSpPr/>
+          <p:nvPr/>
+        </p:nvSpPr>
+        <p:spPr>
+          <a:xfrm>
+            <a:off x="0" y="0"/>
+            <a:ext cx="146304" cy="6858000"/>
+          </a:xfrm>
+          <a:prstGeom prst="rect">
+            <a:avLst/>
+          </a:prstGeom>
+          <a:solidFill>
+            <a:srgbClr val="2563EB"/>
+          </a:solidFill>
+          <a:ln>
+            <a:noFill/>
+          </a:ln>
+          <a:effectLst/>
+        </p:spPr>
+        <p:style>
+          <a:lnRef idx="1">
+            <a:schemeClr val="accent1"/>
+          </a:lnRef>
+          <a:fillRef idx="3">
+            <a:schemeClr val="accent1"/>
+          </a:fillRef>
+          <a:effectRef idx="2">
+            <a:schemeClr val="accent1"/>
+          </a:effectRef>
+          <a:fontRef idx="minor">
+            <a:schemeClr val="lt1"/>
+          </a:fontRef>
+        </p:style>
+        <p:txBody>
+          <a:bodyPr rtlCol="0" anchor="ctr"/>
+          <a:lstStyle/>
+          <a:p>
+            <a:pPr algn="ctr"/>
+          </a:p>
+        </p:txBody>
+      </p:sp>
+      <p:sp>
+        <p:nvSpPr>
+          <p:cNvPr id="4" name="TextBox 3"/>
+          <p:cNvSpPr txBox="1"/>
+          <p:nvPr/>
+        </p:nvSpPr>
+        <p:spPr>
+          <a:xfrm>
+            <a:off x="640080" y="310896"/>
+            <a:ext cx="10058400" cy="274320"/>
+          </a:xfrm>
+          <a:prstGeom prst="rect">
+            <a:avLst/>
+          </a:prstGeom>
+          <a:noFill/>
+        </p:spPr>
+        <p:txBody>
+          <a:bodyPr wrap="square" anchor="t" lIns="0" rIns="0" tIns="0" bIns="0">
+            <a:spAutoFit/>
+          </a:bodyPr>
+          <a:lstStyle/>
+          <a:p>
+            <a:pPr algn="l">
+              <a:lnSpc>
+                <a:spcPct val="105000"/>
+              </a:lnSpc>
+              <a:spcBef>
+                <a:spcPts val="0"/>
+              </a:spcBef>
+              <a:spcAft>
+                <a:spcPts val="600"/>
+              </a:spcAft>
+            </a:pPr>
+            <a:r>
+              <a:rPr sz="1100" b="1" i="0">
+                <a:solidFill>
+                  <a:srgbClr val="6B7280"/>
+                </a:solidFill>
+                <a:latin typeface="Arial"/>
+              </a:rPr>
+              <a:t>РЕЗЕРВНЫЙ СЛАЙД</a:t>
+            </a:r>
+          </a:p>
+        </p:txBody>
+      </p:sp>
+      <p:sp>
+        <p:nvSpPr>
+          <p:cNvPr id="5" name="TextBox 4"/>
+          <p:cNvSpPr txBox="1"/>
+          <p:nvPr/>
+        </p:nvSpPr>
+        <p:spPr>
+          <a:xfrm>
+            <a:off x="640080" y="566928"/>
+            <a:ext cx="10972800" cy="731520"/>
+          </a:xfrm>
+          <a:prstGeom prst="rect">
+            <a:avLst/>
+          </a:prstGeom>
+          <a:noFill/>
+        </p:spPr>
+        <p:txBody>
+          <a:bodyPr wrap="square" anchor="t" lIns="0" rIns="0" tIns="0" bIns="0">
+            <a:spAutoFit/>
+          </a:bodyPr>
+          <a:lstStyle/>
+          <a:p>
+            <a:pPr algn="l">
+              <a:lnSpc>
+                <a:spcPct val="105000"/>
+              </a:lnSpc>
+              <a:spcBef>
+                <a:spcPts val="0"/>
+              </a:spcBef>
+              <a:spcAft>
+                <a:spcPts val="600"/>
+              </a:spcAft>
+            </a:pPr>
+            <a:r>
+              <a:rPr sz="3000" b="1" i="0">
+                <a:solidFill>
+                  <a:srgbClr val="2563EB"/>
+                </a:solidFill>
+                <a:latin typeface="Arial"/>
+              </a:rPr>
+              <a:t>Предобработка SAR в ESA SNAP</a:t>
+            </a:r>
+          </a:p>
+        </p:txBody>
+      </p:sp>
+      <p:sp>
+        <p:nvSpPr>
+          <p:cNvPr id="6" name="Rectangle 5"/>
+          <p:cNvSpPr/>
+          <p:nvPr/>
+        </p:nvSpPr>
+        <p:spPr>
+          <a:xfrm>
+            <a:off x="640080" y="1225296"/>
+            <a:ext cx="2011680" cy="38100"/>
+          </a:xfrm>
+          <a:prstGeom prst="rect">
+            <a:avLst/>
+          </a:prstGeom>
+          <a:solidFill>
+            <a:srgbClr val="2563EB"/>
+          </a:solidFill>
+          <a:ln>
+            <a:noFill/>
+          </a:ln>
+          <a:effectLst/>
+        </p:spPr>
+        <p:style>
+          <a:lnRef idx="1">
+            <a:schemeClr val="accent1"/>
+          </a:lnRef>
+          <a:fillRef idx="3">
+            <a:schemeClr val="accent1"/>
+          </a:fillRef>
+          <a:effectRef idx="2">
+            <a:schemeClr val="accent1"/>
+          </a:effectRef>
+          <a:fontRef idx="minor">
+            <a:schemeClr val="lt1"/>
+          </a:fontRef>
+        </p:style>
+        <p:txBody>
+          <a:bodyPr rtlCol="0" anchor="ctr"/>
+          <a:lstStyle/>
+          <a:p>
+            <a:pPr algn="ctr"/>
+          </a:p>
+        </p:txBody>
+      </p:sp>
+      <p:sp>
+        <p:nvSpPr>
+          <p:cNvPr id="7" name="Rounded Rectangle 6"/>
+          <p:cNvSpPr/>
+          <p:nvPr/>
+        </p:nvSpPr>
+        <p:spPr>
+          <a:xfrm>
+            <a:off x="11140135" y="6355080"/>
+            <a:ext cx="777240" cy="310896"/>
+          </a:xfrm>
+          <a:prstGeom prst="roundRect">
+            <a:avLst/>
+          </a:prstGeom>
+          <a:solidFill>
+            <a:srgbClr val="F3F6FC"/>
+          </a:solidFill>
+          <a:ln w="9525">
+            <a:solidFill>
+              <a:srgbClr val="E2E8F0"/>
+            </a:solidFill>
+          </a:ln>
+          <a:effectLst/>
+        </p:spPr>
+        <p:style>
+          <a:lnRef idx="1">
+            <a:schemeClr val="accent1"/>
+          </a:lnRef>
+          <a:fillRef idx="3">
+            <a:schemeClr val="accent1"/>
+          </a:fillRef>
+          <a:effectRef idx="2">
+            <a:schemeClr val="accent1"/>
+          </a:effectRef>
+          <a:fontRef idx="minor">
+            <a:schemeClr val="lt1"/>
+          </a:fontRef>
+        </p:style>
+        <p:txBody>
+          <a:bodyPr rtlCol="0" anchor="ctr" wrap="none" lIns="0" rIns="0" tIns="0" bIns="0"/>
+          <a:lstStyle/>
+          <a:p>
+            <a:pPr algn="ctr"/>
+            <a:r>
+              <a:rPr sz="1100">
+                <a:solidFill>
+                  <a:srgbClr val="6B7280"/>
+                </a:solidFill>
+                <a:latin typeface="Arial"/>
+              </a:rPr>
+              <a:t>16 / 18</a:t>
+            </a:r>
+          </a:p>
+        </p:txBody>
+      </p:sp>
+      <p:sp>
+        <p:nvSpPr>
+          <p:cNvPr id="8" name="Oval 7"/>
+          <p:cNvSpPr/>
+          <p:nvPr/>
+        </p:nvSpPr>
+        <p:spPr>
+          <a:xfrm>
+            <a:off x="640080" y="1737360"/>
+            <a:ext cx="420624" cy="420624"/>
+          </a:xfrm>
+          <a:prstGeom prst="ellipse">
+            <a:avLst/>
+          </a:prstGeom>
+          <a:solidFill>
+            <a:srgbClr val="2E7D7A"/>
+          </a:solidFill>
+          <a:ln>
+            <a:noFill/>
+          </a:ln>
+          <a:effectLst/>
+        </p:spPr>
+        <p:style>
+          <a:lnRef idx="1">
+            <a:schemeClr val="accent1"/>
+          </a:lnRef>
+          <a:fillRef idx="3">
+            <a:schemeClr val="accent1"/>
+          </a:fillRef>
+          <a:effectRef idx="2">
+            <a:schemeClr val="accent1"/>
+          </a:effectRef>
+          <a:fontRef idx="minor">
+            <a:schemeClr val="lt1"/>
+          </a:fontRef>
+        </p:style>
+        <p:txBody>
+          <a:bodyPr rtlCol="0" anchor="ctr" lIns="0" rIns="0" tIns="0" bIns="0"/>
+          <a:lstStyle/>
+          <a:p>
+            <a:pPr algn="ctr"/>
+            <a:r>
+              <a:rPr sz="1600" b="1">
+                <a:solidFill>
+                  <a:srgbClr val="FFFFFF"/>
+                </a:solidFill>
+                <a:latin typeface="Arial"/>
+              </a:rPr>
+              <a:t>1</a:t>
+            </a:r>
+          </a:p>
+        </p:txBody>
+      </p:sp>
+      <p:sp>
+        <p:nvSpPr>
+          <p:cNvPr id="9" name="TextBox 8"/>
+          <p:cNvSpPr txBox="1"/>
+          <p:nvPr/>
+        </p:nvSpPr>
+        <p:spPr>
+          <a:xfrm>
+            <a:off x="1234440" y="1728216"/>
+            <a:ext cx="10241280" cy="548640"/>
+          </a:xfrm>
+          <a:prstGeom prst="rect">
+            <a:avLst/>
+          </a:prstGeom>
+          <a:noFill/>
+        </p:spPr>
+        <p:txBody>
+          <a:bodyPr wrap="square" anchor="ctr" lIns="0" rIns="0" tIns="0" bIns="0">
+            <a:spAutoFit/>
+          </a:bodyPr>
+          <a:lstStyle/>
+          <a:p>
+            <a:pPr algn="l">
+              <a:lnSpc>
+                <a:spcPct val="105000"/>
+              </a:lnSpc>
+              <a:spcBef>
+                <a:spcPts val="0"/>
+              </a:spcBef>
+              <a:spcAft>
+                <a:spcPts val="600"/>
+              </a:spcAft>
+            </a:pPr>
+            <a:r>
+              <a:rPr sz="1500" b="1" i="0">
+                <a:solidFill>
+                  <a:srgbClr val="2E7D7A"/>
+                </a:solidFill>
+                <a:latin typeface="Arial"/>
+              </a:rPr>
+              <a:t>Apply Orbit File — </a:t>
+            </a:r>
+            <a:r>
+              <a:rPr sz="1500" b="0" i="0">
+                <a:solidFill>
+                  <a:srgbClr val="1F2937"/>
+                </a:solidFill>
+                <a:latin typeface="Arial"/>
+              </a:rPr>
+              <a:t>уточнение параметров орбиты спутника</a:t>
+            </a:r>
+          </a:p>
+        </p:txBody>
+      </p:sp>
+      <p:sp>
+        <p:nvSpPr>
+          <p:cNvPr id="10" name="Oval 9"/>
+          <p:cNvSpPr/>
+          <p:nvPr/>
+        </p:nvSpPr>
+        <p:spPr>
+          <a:xfrm>
+            <a:off x="640080" y="2450592"/>
+            <a:ext cx="420624" cy="420624"/>
+          </a:xfrm>
+          <a:prstGeom prst="ellipse">
+            <a:avLst/>
+          </a:prstGeom>
+          <a:solidFill>
+            <a:srgbClr val="2E7D7A"/>
+          </a:solidFill>
+          <a:ln>
+            <a:noFill/>
+          </a:ln>
+          <a:effectLst/>
+        </p:spPr>
+        <p:style>
+          <a:lnRef idx="1">
+            <a:schemeClr val="accent1"/>
+          </a:lnRef>
+          <a:fillRef idx="3">
+            <a:schemeClr val="accent1"/>
+          </a:fillRef>
+          <a:effectRef idx="2">
+            <a:schemeClr val="accent1"/>
+          </a:effectRef>
+          <a:fontRef idx="minor">
+            <a:schemeClr val="lt1"/>
+          </a:fontRef>
+        </p:style>
+        <p:txBody>
+          <a:bodyPr rtlCol="0" anchor="ctr" lIns="0" rIns="0" tIns="0" bIns="0"/>
+          <a:lstStyle/>
+          <a:p>
+            <a:pPr algn="ctr"/>
+            <a:r>
+              <a:rPr sz="1600" b="1">
+                <a:solidFill>
+                  <a:srgbClr val="FFFFFF"/>
+                </a:solidFill>
+                <a:latin typeface="Arial"/>
+              </a:rPr>
+              <a:t>2</a:t>
+            </a:r>
+          </a:p>
+        </p:txBody>
+      </p:sp>
+      <p:sp>
+        <p:nvSpPr>
+          <p:cNvPr id="11" name="TextBox 10"/>
+          <p:cNvSpPr txBox="1"/>
+          <p:nvPr/>
+        </p:nvSpPr>
+        <p:spPr>
+          <a:xfrm>
+            <a:off x="1234440" y="2441448"/>
+            <a:ext cx="10241280" cy="548640"/>
+          </a:xfrm>
+          <a:prstGeom prst="rect">
+            <a:avLst/>
+          </a:prstGeom>
+          <a:noFill/>
+        </p:spPr>
+        <p:txBody>
+          <a:bodyPr wrap="square" anchor="ctr" lIns="0" rIns="0" tIns="0" bIns="0">
+            <a:spAutoFit/>
+          </a:bodyPr>
+          <a:lstStyle/>
+          <a:p>
+            <a:pPr algn="l">
+              <a:lnSpc>
+                <a:spcPct val="105000"/>
+              </a:lnSpc>
+              <a:spcBef>
+                <a:spcPts val="0"/>
+              </a:spcBef>
+              <a:spcAft>
+                <a:spcPts val="600"/>
+              </a:spcAft>
+            </a:pPr>
+            <a:r>
+              <a:rPr sz="1500" b="1" i="0">
+                <a:solidFill>
+                  <a:srgbClr val="2E7D7A"/>
+                </a:solidFill>
+                <a:latin typeface="Arial"/>
+              </a:rPr>
+              <a:t>Thermal Noise Removal — </a:t>
+            </a:r>
+            <a:r>
+              <a:rPr sz="1500" b="0" i="0">
+                <a:solidFill>
+                  <a:srgbClr val="1F2937"/>
+                </a:solidFill>
+                <a:latin typeface="Arial"/>
+              </a:rPr>
+              <a:t>удаление теплового шума сенсора</a:t>
+            </a:r>
+          </a:p>
+        </p:txBody>
+      </p:sp>
+      <p:sp>
+        <p:nvSpPr>
+          <p:cNvPr id="12" name="Oval 11"/>
+          <p:cNvSpPr/>
+          <p:nvPr/>
+        </p:nvSpPr>
+        <p:spPr>
+          <a:xfrm>
+            <a:off x="640080" y="3163824"/>
+            <a:ext cx="420624" cy="420624"/>
+          </a:xfrm>
+          <a:prstGeom prst="ellipse">
+            <a:avLst/>
+          </a:prstGeom>
+          <a:solidFill>
+            <a:srgbClr val="2E7D7A"/>
+          </a:solidFill>
+          <a:ln>
+            <a:noFill/>
+          </a:ln>
+          <a:effectLst/>
+        </p:spPr>
+        <p:style>
+          <a:lnRef idx="1">
+            <a:schemeClr val="accent1"/>
+          </a:lnRef>
+          <a:fillRef idx="3">
+            <a:schemeClr val="accent1"/>
+          </a:fillRef>
+          <a:effectRef idx="2">
+            <a:schemeClr val="accent1"/>
+          </a:effectRef>
+          <a:fontRef idx="minor">
+            <a:schemeClr val="lt1"/>
+          </a:fontRef>
+        </p:style>
+        <p:txBody>
+          <a:bodyPr rtlCol="0" anchor="ctr" lIns="0" rIns="0" tIns="0" bIns="0"/>
+          <a:lstStyle/>
+          <a:p>
+            <a:pPr algn="ctr"/>
+            <a:r>
+              <a:rPr sz="1600" b="1">
+                <a:solidFill>
+                  <a:srgbClr val="FFFFFF"/>
+                </a:solidFill>
+                <a:latin typeface="Arial"/>
+              </a:rPr>
+              <a:t>3</a:t>
+            </a:r>
+          </a:p>
+        </p:txBody>
+      </p:sp>
+      <p:sp>
+        <p:nvSpPr>
+          <p:cNvPr id="13" name="TextBox 12"/>
+          <p:cNvSpPr txBox="1"/>
+          <p:nvPr/>
+        </p:nvSpPr>
+        <p:spPr>
+          <a:xfrm>
+            <a:off x="1234440" y="3154680"/>
+            <a:ext cx="10241280" cy="548640"/>
+          </a:xfrm>
+          <a:prstGeom prst="rect">
+            <a:avLst/>
+          </a:prstGeom>
+          <a:noFill/>
+        </p:spPr>
+        <p:txBody>
+          <a:bodyPr wrap="square" anchor="ctr" lIns="0" rIns="0" tIns="0" bIns="0">
+            <a:spAutoFit/>
+          </a:bodyPr>
+          <a:lstStyle/>
+          <a:p>
+            <a:pPr algn="l">
+              <a:lnSpc>
+                <a:spcPct val="105000"/>
+              </a:lnSpc>
+              <a:spcBef>
+                <a:spcPts val="0"/>
+              </a:spcBef>
+              <a:spcAft>
+                <a:spcPts val="600"/>
+              </a:spcAft>
+            </a:pPr>
+            <a:r>
+              <a:rPr sz="1500" b="1" i="0">
+                <a:solidFill>
+                  <a:srgbClr val="2E7D7A"/>
+                </a:solidFill>
+                <a:latin typeface="Arial"/>
+              </a:rPr>
+              <a:t>Радиометрическая калибровка — </a:t>
+            </a:r>
+            <a:r>
+              <a:rPr sz="1500" b="0" i="0">
+                <a:solidFill>
+                  <a:srgbClr val="1F2937"/>
+                </a:solidFill>
+                <a:latin typeface="Arial"/>
+              </a:rPr>
+              <a:t>перевод в σ⁰ (коэффициент обратного рассеяния)</a:t>
+            </a:r>
+          </a:p>
+        </p:txBody>
+      </p:sp>
+      <p:sp>
+        <p:nvSpPr>
+          <p:cNvPr id="14" name="Oval 13"/>
+          <p:cNvSpPr/>
+          <p:nvPr/>
+        </p:nvSpPr>
+        <p:spPr>
+          <a:xfrm>
+            <a:off x="640080" y="3877056"/>
+            <a:ext cx="420624" cy="420624"/>
+          </a:xfrm>
+          <a:prstGeom prst="ellipse">
+            <a:avLst/>
+          </a:prstGeom>
+          <a:solidFill>
+            <a:srgbClr val="2E7D7A"/>
+          </a:solidFill>
+          <a:ln>
+            <a:noFill/>
+          </a:ln>
+          <a:effectLst/>
+        </p:spPr>
+        <p:style>
+          <a:lnRef idx="1">
+            <a:schemeClr val="accent1"/>
+          </a:lnRef>
+          <a:fillRef idx="3">
+            <a:schemeClr val="accent1"/>
+          </a:fillRef>
+          <a:effectRef idx="2">
+            <a:schemeClr val="accent1"/>
+          </a:effectRef>
+          <a:fontRef idx="minor">
+            <a:schemeClr val="lt1"/>
+          </a:fontRef>
+        </p:style>
+        <p:txBody>
+          <a:bodyPr rtlCol="0" anchor="ctr" lIns="0" rIns="0" tIns="0" bIns="0"/>
+          <a:lstStyle/>
+          <a:p>
+            <a:pPr algn="ctr"/>
+            <a:r>
+              <a:rPr sz="1600" b="1">
+                <a:solidFill>
+                  <a:srgbClr val="FFFFFF"/>
+                </a:solidFill>
+                <a:latin typeface="Arial"/>
+              </a:rPr>
+              <a:t>4</a:t>
+            </a:r>
+          </a:p>
+        </p:txBody>
+      </p:sp>
+      <p:sp>
+        <p:nvSpPr>
+          <p:cNvPr id="15" name="TextBox 14"/>
+          <p:cNvSpPr txBox="1"/>
+          <p:nvPr/>
+        </p:nvSpPr>
+        <p:spPr>
+          <a:xfrm>
+            <a:off x="1234440" y="3867912"/>
+            <a:ext cx="10241280" cy="548640"/>
+          </a:xfrm>
+          <a:prstGeom prst="rect">
+            <a:avLst/>
+          </a:prstGeom>
+          <a:noFill/>
+        </p:spPr>
+        <p:txBody>
+          <a:bodyPr wrap="square" anchor="ctr" lIns="0" rIns="0" tIns="0" bIns="0">
+            <a:spAutoFit/>
+          </a:bodyPr>
+          <a:lstStyle/>
+          <a:p>
+            <a:pPr algn="l">
+              <a:lnSpc>
+                <a:spcPct val="105000"/>
+              </a:lnSpc>
+              <a:spcBef>
+                <a:spcPts val="0"/>
+              </a:spcBef>
+              <a:spcAft>
+                <a:spcPts val="600"/>
+              </a:spcAft>
+            </a:pPr>
+            <a:r>
+              <a:rPr sz="1500" b="1" i="0">
+                <a:solidFill>
+                  <a:srgbClr val="2E7D7A"/>
+                </a:solidFill>
+                <a:latin typeface="Arial"/>
+              </a:rPr>
+              <a:t>Фильтр Ли 7×7 — </a:t>
+            </a:r>
+            <a:r>
+              <a:rPr sz="1500" b="0" i="0">
+                <a:solidFill>
+                  <a:srgbClr val="1F2937"/>
+                </a:solidFill>
+                <a:latin typeface="Arial"/>
+              </a:rPr>
+              <a:t>подавление спекл-шума с сохранением границ</a:t>
+            </a:r>
+          </a:p>
+        </p:txBody>
+      </p:sp>
+      <p:sp>
+        <p:nvSpPr>
+          <p:cNvPr id="16" name="Oval 15"/>
+          <p:cNvSpPr/>
+          <p:nvPr/>
+        </p:nvSpPr>
+        <p:spPr>
+          <a:xfrm>
+            <a:off x="640080" y="4590288"/>
+            <a:ext cx="420624" cy="420624"/>
+          </a:xfrm>
+          <a:prstGeom prst="ellipse">
+            <a:avLst/>
+          </a:prstGeom>
+          <a:solidFill>
+            <a:srgbClr val="2E7D7A"/>
+          </a:solidFill>
+          <a:ln>
+            <a:noFill/>
+          </a:ln>
+          <a:effectLst/>
+        </p:spPr>
+        <p:style>
+          <a:lnRef idx="1">
+            <a:schemeClr val="accent1"/>
+          </a:lnRef>
+          <a:fillRef idx="3">
+            <a:schemeClr val="accent1"/>
+          </a:fillRef>
+          <a:effectRef idx="2">
+            <a:schemeClr val="accent1"/>
+          </a:effectRef>
+          <a:fontRef idx="minor">
+            <a:schemeClr val="lt1"/>
+          </a:fontRef>
+        </p:style>
+        <p:txBody>
+          <a:bodyPr rtlCol="0" anchor="ctr" lIns="0" rIns="0" tIns="0" bIns="0"/>
+          <a:lstStyle/>
+          <a:p>
+            <a:pPr algn="ctr"/>
+            <a:r>
+              <a:rPr sz="1600" b="1">
+                <a:solidFill>
+                  <a:srgbClr val="FFFFFF"/>
+                </a:solidFill>
+                <a:latin typeface="Arial"/>
+              </a:rPr>
+              <a:t>5</a:t>
+            </a:r>
+          </a:p>
+        </p:txBody>
+      </p:sp>
+      <p:sp>
+        <p:nvSpPr>
+          <p:cNvPr id="17" name="TextBox 16"/>
+          <p:cNvSpPr txBox="1"/>
+          <p:nvPr/>
+        </p:nvSpPr>
+        <p:spPr>
+          <a:xfrm>
+            <a:off x="1234440" y="4581144"/>
+            <a:ext cx="10241280" cy="548640"/>
+          </a:xfrm>
+          <a:prstGeom prst="rect">
+            <a:avLst/>
+          </a:prstGeom>
+          <a:noFill/>
+        </p:spPr>
+        <p:txBody>
+          <a:bodyPr wrap="square" anchor="ctr" lIns="0" rIns="0" tIns="0" bIns="0">
+            <a:spAutoFit/>
+          </a:bodyPr>
+          <a:lstStyle/>
+          <a:p>
+            <a:pPr algn="l">
+              <a:lnSpc>
+                <a:spcPct val="105000"/>
+              </a:lnSpc>
+              <a:spcBef>
+                <a:spcPts val="0"/>
+              </a:spcBef>
+              <a:spcAft>
+                <a:spcPts val="600"/>
+              </a:spcAft>
+            </a:pPr>
+            <a:r>
+              <a:rPr sz="1500" b="1" i="0">
+                <a:solidFill>
+                  <a:srgbClr val="2E7D7A"/>
+                </a:solidFill>
+                <a:latin typeface="Arial"/>
+              </a:rPr>
+              <a:t>Range-Doppler коррекция — </a:t>
+            </a:r>
+            <a:r>
+              <a:rPr sz="1500" b="0" i="0">
+                <a:solidFill>
+                  <a:srgbClr val="1F2937"/>
+                </a:solidFill>
+                <a:latin typeface="Arial"/>
+              </a:rPr>
+              <a:t>геометрическая привязка к местности</a:t>
+            </a:r>
+          </a:p>
+        </p:txBody>
+      </p:sp>
+      <p:sp>
+        <p:nvSpPr>
+          <p:cNvPr id="18" name="Oval 17"/>
+          <p:cNvSpPr/>
+          <p:nvPr/>
+        </p:nvSpPr>
+        <p:spPr>
+          <a:xfrm>
+            <a:off x="640080" y="5303520"/>
+            <a:ext cx="420624" cy="420624"/>
+          </a:xfrm>
+          <a:prstGeom prst="ellipse">
+            <a:avLst/>
+          </a:prstGeom>
+          <a:solidFill>
+            <a:srgbClr val="2E7D7A"/>
+          </a:solidFill>
+          <a:ln>
+            <a:noFill/>
+          </a:ln>
+          <a:effectLst/>
+        </p:spPr>
+        <p:style>
+          <a:lnRef idx="1">
+            <a:schemeClr val="accent1"/>
+          </a:lnRef>
+          <a:fillRef idx="3">
+            <a:schemeClr val="accent1"/>
+          </a:fillRef>
+          <a:effectRef idx="2">
+            <a:schemeClr val="accent1"/>
+          </a:effectRef>
+          <a:fontRef idx="minor">
+            <a:schemeClr val="lt1"/>
+          </a:fontRef>
+        </p:style>
+        <p:txBody>
+          <a:bodyPr rtlCol="0" anchor="ctr" lIns="0" rIns="0" tIns="0" bIns="0"/>
+          <a:lstStyle/>
+          <a:p>
+            <a:pPr algn="ctr"/>
+            <a:r>
+              <a:rPr sz="1600" b="1">
+                <a:solidFill>
+                  <a:srgbClr val="FFFFFF"/>
+                </a:solidFill>
+                <a:latin typeface="Arial"/>
+              </a:rPr>
+              <a:t>6</a:t>
+            </a:r>
+          </a:p>
+        </p:txBody>
+      </p:sp>
+      <p:sp>
+        <p:nvSpPr>
+          <p:cNvPr id="19" name="TextBox 18"/>
+          <p:cNvSpPr txBox="1"/>
+          <p:nvPr/>
+        </p:nvSpPr>
+        <p:spPr>
+          <a:xfrm>
+            <a:off x="1234440" y="5294376"/>
+            <a:ext cx="10241280" cy="548640"/>
+          </a:xfrm>
+          <a:prstGeom prst="rect">
+            <a:avLst/>
+          </a:prstGeom>
+          <a:noFill/>
+        </p:spPr>
+        <p:txBody>
+          <a:bodyPr wrap="square" anchor="ctr" lIns="0" rIns="0" tIns="0" bIns="0">
+            <a:spAutoFit/>
+          </a:bodyPr>
+          <a:lstStyle/>
+          <a:p>
+            <a:pPr algn="l">
+              <a:lnSpc>
+                <a:spcPct val="105000"/>
+              </a:lnSpc>
+              <a:spcBef>
+                <a:spcPts val="0"/>
+              </a:spcBef>
+              <a:spcAft>
+                <a:spcPts val="600"/>
+              </a:spcAft>
+            </a:pPr>
+            <a:r>
+              <a:rPr sz="1500" b="1" i="0">
+                <a:solidFill>
+                  <a:srgbClr val="2E7D7A"/>
+                </a:solidFill>
+                <a:latin typeface="Arial"/>
+              </a:rPr>
+              <a:t>Перевод в дБ — </a:t>
+            </a:r>
+            <a:r>
+              <a:rPr sz="1500" b="0" i="0">
+                <a:solidFill>
+                  <a:srgbClr val="1F2937"/>
+                </a:solidFill>
+                <a:latin typeface="Arial"/>
+              </a:rPr>
+              <a:t>логарифмическая шкала [−35; 0] дБ</a:t>
+            </a:r>
+          </a:p>
+        </p:txBody>
+      </p:sp>
+    </p:spTree>
+  </p:cSld>
+  <p:clrMapOvr>
+    <a:masterClrMapping/>
+  </p:clrMapOvr>
+</p:sld>
+</file>
+
+<file path=ppt/slides/slide17.xml><?xml version="1.0" encoding="utf-8"?>
+<p:sld xmlns:a="http://schemas.openxmlformats.org/drawingml/2006/main" xmlns:p="http://schemas.openxmlformats.org/presentationml/2006/main" xmlns:r="http://schemas.openxmlformats.org/officeDocument/2006/relationships">
+  <p:cSld>
+    <p:spTree>
+      <p:nvGrpSpPr>
+        <p:cNvPr id="1" name=""/>
+        <p:cNvGrpSpPr/>
+        <p:nvPr/>
+      </p:nvGrpSpPr>
+      <p:grpSpPr/>
+      <p:sp>
+        <p:nvSpPr>
+          <p:cNvPr id="2" name="Rectangle 1"/>
+          <p:cNvSpPr/>
+          <p:nvPr/>
+        </p:nvSpPr>
+        <p:spPr>
+          <a:xfrm>
+            <a:off x="0" y="0"/>
+            <a:ext cx="12191695" cy="6858000"/>
+          </a:xfrm>
+          <a:prstGeom prst="rect">
+            <a:avLst/>
+          </a:prstGeom>
+          <a:solidFill>
+            <a:srgbClr val="FFFFFF"/>
+          </a:solidFill>
+          <a:ln>
+            <a:noFill/>
+          </a:ln>
+          <a:effectLst/>
+        </p:spPr>
+        <p:style>
+          <a:lnRef idx="1">
+            <a:schemeClr val="accent1"/>
+          </a:lnRef>
+          <a:fillRef idx="3">
+            <a:schemeClr val="accent1"/>
+          </a:fillRef>
+          <a:effectRef idx="2">
+            <a:schemeClr val="accent1"/>
+          </a:effectRef>
+          <a:fontRef idx="minor">
+            <a:schemeClr val="lt1"/>
+          </a:fontRef>
+        </p:style>
+        <p:txBody>
+          <a:bodyPr rtlCol="0" anchor="ctr"/>
+          <a:lstStyle/>
+          <a:p>
+            <a:pPr algn="ctr"/>
+          </a:p>
+        </p:txBody>
+      </p:sp>
+      <p:sp>
+        <p:nvSpPr>
+          <p:cNvPr id="3" name="Rectangle 2"/>
+          <p:cNvSpPr/>
+          <p:nvPr/>
+        </p:nvSpPr>
+        <p:spPr>
+          <a:xfrm>
+            <a:off x="0" y="0"/>
+            <a:ext cx="146304" cy="6858000"/>
+          </a:xfrm>
+          <a:prstGeom prst="rect">
+            <a:avLst/>
+          </a:prstGeom>
+          <a:solidFill>
+            <a:srgbClr val="2563EB"/>
+          </a:solidFill>
+          <a:ln>
+            <a:noFill/>
+          </a:ln>
+          <a:effectLst/>
+        </p:spPr>
+        <p:style>
+          <a:lnRef idx="1">
+            <a:schemeClr val="accent1"/>
+          </a:lnRef>
+          <a:fillRef idx="3">
+            <a:schemeClr val="accent1"/>
+          </a:fillRef>
+          <a:effectRef idx="2">
+            <a:schemeClr val="accent1"/>
+          </a:effectRef>
+          <a:fontRef idx="minor">
+            <a:schemeClr val="lt1"/>
+          </a:fontRef>
+        </p:style>
+        <p:txBody>
+          <a:bodyPr rtlCol="0" anchor="ctr"/>
+          <a:lstStyle/>
+          <a:p>
+            <a:pPr algn="ctr"/>
+          </a:p>
+        </p:txBody>
+      </p:sp>
+      <p:sp>
+        <p:nvSpPr>
+          <p:cNvPr id="4" name="TextBox 3"/>
+          <p:cNvSpPr txBox="1"/>
+          <p:nvPr/>
+        </p:nvSpPr>
+        <p:spPr>
+          <a:xfrm>
+            <a:off x="640080" y="310896"/>
+            <a:ext cx="10058400" cy="274320"/>
+          </a:xfrm>
+          <a:prstGeom prst="rect">
+            <a:avLst/>
+          </a:prstGeom>
+          <a:noFill/>
+        </p:spPr>
+        <p:txBody>
+          <a:bodyPr wrap="square" anchor="t" lIns="0" rIns="0" tIns="0" bIns="0">
+            <a:spAutoFit/>
+          </a:bodyPr>
+          <a:lstStyle/>
+          <a:p>
+            <a:pPr algn="l">
+              <a:lnSpc>
+                <a:spcPct val="105000"/>
+              </a:lnSpc>
+              <a:spcBef>
+                <a:spcPts val="0"/>
+              </a:spcBef>
+              <a:spcAft>
+                <a:spcPts val="600"/>
+              </a:spcAft>
+            </a:pPr>
+            <a:r>
+              <a:rPr sz="1100" b="1" i="0">
+                <a:solidFill>
+                  <a:srgbClr val="6B7280"/>
+                </a:solidFill>
+                <a:latin typeface="Arial"/>
+              </a:rPr>
+              <a:t>РЕЗЕРВНЫЙ СЛАЙД</a:t>
+            </a:r>
+          </a:p>
+        </p:txBody>
+      </p:sp>
+      <p:sp>
+        <p:nvSpPr>
+          <p:cNvPr id="5" name="TextBox 4"/>
+          <p:cNvSpPr txBox="1"/>
+          <p:nvPr/>
+        </p:nvSpPr>
+        <p:spPr>
+          <a:xfrm>
+            <a:off x="640080" y="566928"/>
+            <a:ext cx="10972800" cy="731520"/>
+          </a:xfrm>
+          <a:prstGeom prst="rect">
+            <a:avLst/>
+          </a:prstGeom>
+          <a:noFill/>
+        </p:spPr>
+        <p:txBody>
+          <a:bodyPr wrap="square" anchor="t" lIns="0" rIns="0" tIns="0" bIns="0">
+            <a:spAutoFit/>
+          </a:bodyPr>
+          <a:lstStyle/>
+          <a:p>
+            <a:pPr algn="l">
+              <a:lnSpc>
+                <a:spcPct val="105000"/>
+              </a:lnSpc>
+              <a:spcBef>
+                <a:spcPts val="0"/>
+              </a:spcBef>
+              <a:spcAft>
+                <a:spcPts val="600"/>
+              </a:spcAft>
+            </a:pPr>
+            <a:r>
+              <a:rPr sz="3000" b="1" i="0">
+                <a:solidFill>
+                  <a:srgbClr val="2563EB"/>
+                </a:solidFill>
+                <a:latin typeface="Arial"/>
+              </a:rPr>
+              <a:t>Метрики оценки качества</a:t>
+            </a:r>
+          </a:p>
+        </p:txBody>
+      </p:sp>
+      <p:sp>
+        <p:nvSpPr>
+          <p:cNvPr id="6" name="Rectangle 5"/>
+          <p:cNvSpPr/>
+          <p:nvPr/>
+        </p:nvSpPr>
+        <p:spPr>
+          <a:xfrm>
+            <a:off x="640080" y="1225296"/>
+            <a:ext cx="2011680" cy="38100"/>
+          </a:xfrm>
+          <a:prstGeom prst="rect">
+            <a:avLst/>
+          </a:prstGeom>
+          <a:solidFill>
+            <a:srgbClr val="2563EB"/>
+          </a:solidFill>
+          <a:ln>
+            <a:noFill/>
+          </a:ln>
+          <a:effectLst/>
+        </p:spPr>
+        <p:style>
+          <a:lnRef idx="1">
+            <a:schemeClr val="accent1"/>
+          </a:lnRef>
+          <a:fillRef idx="3">
+            <a:schemeClr val="accent1"/>
+          </a:fillRef>
+          <a:effectRef idx="2">
+            <a:schemeClr val="accent1"/>
+          </a:effectRef>
+          <a:fontRef idx="minor">
+            <a:schemeClr val="lt1"/>
+          </a:fontRef>
+        </p:style>
+        <p:txBody>
+          <a:bodyPr rtlCol="0" anchor="ctr"/>
+          <a:lstStyle/>
+          <a:p>
+            <a:pPr algn="ctr"/>
+          </a:p>
+        </p:txBody>
+      </p:sp>
+      <p:sp>
+        <p:nvSpPr>
+          <p:cNvPr id="7" name="Rounded Rectangle 6"/>
+          <p:cNvSpPr/>
+          <p:nvPr/>
+        </p:nvSpPr>
+        <p:spPr>
+          <a:xfrm>
+            <a:off x="11140135" y="6355080"/>
+            <a:ext cx="777240" cy="310896"/>
+          </a:xfrm>
+          <a:prstGeom prst="roundRect">
+            <a:avLst/>
+          </a:prstGeom>
+          <a:solidFill>
+            <a:srgbClr val="F3F6FC"/>
+          </a:solidFill>
+          <a:ln w="9525">
+            <a:solidFill>
+              <a:srgbClr val="E2E8F0"/>
+            </a:solidFill>
+          </a:ln>
+          <a:effectLst/>
+        </p:spPr>
+        <p:style>
+          <a:lnRef idx="1">
+            <a:schemeClr val="accent1"/>
+          </a:lnRef>
+          <a:fillRef idx="3">
+            <a:schemeClr val="accent1"/>
+          </a:fillRef>
+          <a:effectRef idx="2">
+            <a:schemeClr val="accent1"/>
+          </a:effectRef>
+          <a:fontRef idx="minor">
+            <a:schemeClr val="lt1"/>
+          </a:fontRef>
+        </p:style>
+        <p:txBody>
+          <a:bodyPr rtlCol="0" anchor="ctr" wrap="none" lIns="0" rIns="0" tIns="0" bIns="0"/>
+          <a:lstStyle/>
+          <a:p>
+            <a:pPr algn="ctr"/>
+            <a:r>
+              <a:rPr sz="1100">
+                <a:solidFill>
+                  <a:srgbClr val="6B7280"/>
+                </a:solidFill>
+                <a:latin typeface="Arial"/>
+              </a:rPr>
+              <a:t>17 / 18</a:t>
+            </a:r>
+          </a:p>
+        </p:txBody>
+      </p:sp>
+      <p:sp>
+        <p:nvSpPr>
+          <p:cNvPr id="8" name="Rounded Rectangle 7"/>
+          <p:cNvSpPr/>
+          <p:nvPr/>
+        </p:nvSpPr>
+        <p:spPr>
+          <a:xfrm>
+            <a:off x="640080" y="1783080"/>
+            <a:ext cx="10927080" cy="749808"/>
+          </a:xfrm>
+          <a:prstGeom prst="roundRect">
+            <a:avLst/>
+          </a:prstGeom>
+          <a:solidFill>
+            <a:srgbClr val="F3F6FC"/>
+          </a:solidFill>
+          <a:ln w="12700">
+            <a:solidFill>
+              <a:srgbClr val="DBEAFE"/>
+            </a:solidFill>
+          </a:ln>
+          <a:effectLst/>
+        </p:spPr>
+        <p:style>
+          <a:lnRef idx="1">
+            <a:schemeClr val="accent1"/>
+          </a:lnRef>
+          <a:fillRef idx="3">
+            <a:schemeClr val="accent1"/>
+          </a:fillRef>
+          <a:effectRef idx="2">
+            <a:schemeClr val="accent1"/>
+          </a:effectRef>
+          <a:fontRef idx="minor">
+            <a:schemeClr val="lt1"/>
+          </a:fontRef>
+        </p:style>
+        <p:txBody>
+          <a:bodyPr rtlCol="0" anchor="ctr"/>
+          <a:lstStyle/>
+          <a:p>
+            <a:pPr algn="ctr"/>
+          </a:p>
+        </p:txBody>
+      </p:sp>
+      <p:sp>
+        <p:nvSpPr>
+          <p:cNvPr id="9" name="Rectangle 8"/>
+          <p:cNvSpPr/>
+          <p:nvPr/>
+        </p:nvSpPr>
+        <p:spPr>
+          <a:xfrm>
+            <a:off x="640080" y="1783080"/>
+            <a:ext cx="82296" cy="749808"/>
+          </a:xfrm>
+          <a:prstGeom prst="rect">
+            <a:avLst/>
+          </a:prstGeom>
+          <a:solidFill>
+            <a:srgbClr val="2563EB"/>
+          </a:solidFill>
+          <a:ln>
+            <a:noFill/>
+          </a:ln>
+          <a:effectLst/>
+        </p:spPr>
+        <p:style>
+          <a:lnRef idx="1">
+            <a:schemeClr val="accent1"/>
+          </a:lnRef>
+          <a:fillRef idx="3">
+            <a:schemeClr val="accent1"/>
+          </a:fillRef>
+          <a:effectRef idx="2">
+            <a:schemeClr val="accent1"/>
+          </a:effectRef>
+          <a:fontRef idx="minor">
+            <a:schemeClr val="lt1"/>
+          </a:fontRef>
+        </p:style>
+        <p:txBody>
+          <a:bodyPr rtlCol="0" anchor="ctr"/>
+          <a:lstStyle/>
+          <a:p>
+            <a:pPr algn="ctr"/>
+          </a:p>
+        </p:txBody>
+      </p:sp>
+      <p:sp>
+        <p:nvSpPr>
+          <p:cNvPr id="10" name="TextBox 9"/>
+          <p:cNvSpPr txBox="1"/>
+          <p:nvPr/>
+        </p:nvSpPr>
+        <p:spPr>
+          <a:xfrm>
+            <a:off x="914400" y="1929384"/>
+            <a:ext cx="10424160" cy="548640"/>
+          </a:xfrm>
+          <a:prstGeom prst="rect">
+            <a:avLst/>
+          </a:prstGeom>
+          <a:noFill/>
+        </p:spPr>
+        <p:txBody>
+          <a:bodyPr wrap="square" anchor="ctr" lIns="0" rIns="0" tIns="0" bIns="0">
+            <a:spAutoFit/>
+          </a:bodyPr>
+          <a:lstStyle/>
+          <a:p>
+            <a:pPr algn="l">
+              <a:lnSpc>
+                <a:spcPct val="105000"/>
+              </a:lnSpc>
+              <a:spcBef>
+                <a:spcPts val="0"/>
+              </a:spcBef>
+              <a:spcAft>
+                <a:spcPts val="600"/>
+              </a:spcAft>
+            </a:pPr>
+            <a:r>
+              <a:rPr sz="1500" b="1" i="0">
+                <a:solidFill>
+                  <a:srgbClr val="1E40AF"/>
+                </a:solidFill>
+                <a:latin typeface="Arial"/>
+              </a:rPr>
+              <a:t>Precision — </a:t>
+            </a:r>
+            <a:r>
+              <a:rPr sz="1500" b="0" i="0">
+                <a:solidFill>
+                  <a:srgbClr val="1F2937"/>
+                </a:solidFill>
+                <a:latin typeface="Arial"/>
+              </a:rPr>
+              <a:t>доля верных среди предсказанных пикселей «нефть»</a:t>
+            </a:r>
+          </a:p>
+        </p:txBody>
+      </p:sp>
+      <p:sp>
+        <p:nvSpPr>
+          <p:cNvPr id="11" name="Rounded Rectangle 10"/>
+          <p:cNvSpPr/>
+          <p:nvPr/>
+        </p:nvSpPr>
+        <p:spPr>
+          <a:xfrm>
+            <a:off x="640080" y="2679192"/>
+            <a:ext cx="10927080" cy="749808"/>
+          </a:xfrm>
+          <a:prstGeom prst="roundRect">
+            <a:avLst/>
+          </a:prstGeom>
+          <a:solidFill>
+            <a:srgbClr val="F3F6FC"/>
+          </a:solidFill>
+          <a:ln w="12700">
+            <a:solidFill>
+              <a:srgbClr val="DBEAFE"/>
+            </a:solidFill>
+          </a:ln>
+          <a:effectLst/>
+        </p:spPr>
+        <p:style>
+          <a:lnRef idx="1">
+            <a:schemeClr val="accent1"/>
+          </a:lnRef>
+          <a:fillRef idx="3">
+            <a:schemeClr val="accent1"/>
+          </a:fillRef>
+          <a:effectRef idx="2">
+            <a:schemeClr val="accent1"/>
+          </a:effectRef>
+          <a:fontRef idx="minor">
+            <a:schemeClr val="lt1"/>
+          </a:fontRef>
+        </p:style>
+        <p:txBody>
+          <a:bodyPr rtlCol="0" anchor="ctr"/>
+          <a:lstStyle/>
+          <a:p>
+            <a:pPr algn="ctr"/>
+          </a:p>
+        </p:txBody>
+      </p:sp>
+      <p:sp>
+        <p:nvSpPr>
+          <p:cNvPr id="12" name="Rectangle 11"/>
+          <p:cNvSpPr/>
+          <p:nvPr/>
+        </p:nvSpPr>
+        <p:spPr>
+          <a:xfrm>
+            <a:off x="640080" y="2679192"/>
+            <a:ext cx="82296" cy="749808"/>
+          </a:xfrm>
+          <a:prstGeom prst="rect">
+            <a:avLst/>
+          </a:prstGeom>
+          <a:solidFill>
+            <a:srgbClr val="2563EB"/>
+          </a:solidFill>
+          <a:ln>
+            <a:noFill/>
+          </a:ln>
+          <a:effectLst/>
+        </p:spPr>
+        <p:style>
+          <a:lnRef idx="1">
+            <a:schemeClr val="accent1"/>
+          </a:lnRef>
+          <a:fillRef idx="3">
+            <a:schemeClr val="accent1"/>
+          </a:fillRef>
+          <a:effectRef idx="2">
+            <a:schemeClr val="accent1"/>
+          </a:effectRef>
+          <a:fontRef idx="minor">
+            <a:schemeClr val="lt1"/>
+          </a:fontRef>
+        </p:style>
+        <p:txBody>
+          <a:bodyPr rtlCol="0" anchor="ctr"/>
+          <a:lstStyle/>
+          <a:p>
+            <a:pPr algn="ctr"/>
+          </a:p>
+        </p:txBody>
+      </p:sp>
+      <p:sp>
+        <p:nvSpPr>
+          <p:cNvPr id="13" name="TextBox 12"/>
+          <p:cNvSpPr txBox="1"/>
+          <p:nvPr/>
+        </p:nvSpPr>
+        <p:spPr>
+          <a:xfrm>
+            <a:off x="914400" y="2825496"/>
+            <a:ext cx="10424160" cy="548640"/>
+          </a:xfrm>
+          <a:prstGeom prst="rect">
+            <a:avLst/>
+          </a:prstGeom>
+          <a:noFill/>
+        </p:spPr>
+        <p:txBody>
+          <a:bodyPr wrap="square" anchor="ctr" lIns="0" rIns="0" tIns="0" bIns="0">
+            <a:spAutoFit/>
+          </a:bodyPr>
+          <a:lstStyle/>
+          <a:p>
+            <a:pPr algn="l">
+              <a:lnSpc>
+                <a:spcPct val="105000"/>
+              </a:lnSpc>
+              <a:spcBef>
+                <a:spcPts val="0"/>
+              </a:spcBef>
+              <a:spcAft>
+                <a:spcPts val="600"/>
+              </a:spcAft>
+            </a:pPr>
+            <a:r>
+              <a:rPr sz="1500" b="1" i="0">
+                <a:solidFill>
+                  <a:srgbClr val="1E40AF"/>
+                </a:solidFill>
+                <a:latin typeface="Arial"/>
+              </a:rPr>
+              <a:t>Recall — </a:t>
+            </a:r>
+            <a:r>
+              <a:rPr sz="1500" b="0" i="0">
+                <a:solidFill>
+                  <a:srgbClr val="1F2937"/>
+                </a:solidFill>
+                <a:latin typeface="Arial"/>
+              </a:rPr>
+              <a:t>доля найденных среди всех истинных пикселей «нефть»</a:t>
+            </a:r>
+          </a:p>
+        </p:txBody>
+      </p:sp>
+      <p:sp>
+        <p:nvSpPr>
+          <p:cNvPr id="14" name="Rounded Rectangle 13"/>
+          <p:cNvSpPr/>
+          <p:nvPr/>
+        </p:nvSpPr>
+        <p:spPr>
+          <a:xfrm>
+            <a:off x="640080" y="3575304"/>
+            <a:ext cx="10927080" cy="749808"/>
+          </a:xfrm>
+          <a:prstGeom prst="roundRect">
+            <a:avLst/>
+          </a:prstGeom>
+          <a:solidFill>
+            <a:srgbClr val="F3F6FC"/>
+          </a:solidFill>
+          <a:ln w="12700">
+            <a:solidFill>
+              <a:srgbClr val="DBEAFE"/>
+            </a:solidFill>
+          </a:ln>
+          <a:effectLst/>
+        </p:spPr>
+        <p:style>
+          <a:lnRef idx="1">
+            <a:schemeClr val="accent1"/>
+          </a:lnRef>
+          <a:fillRef idx="3">
+            <a:schemeClr val="accent1"/>
+          </a:fillRef>
+          <a:effectRef idx="2">
+            <a:schemeClr val="accent1"/>
+          </a:effectRef>
+          <a:fontRef idx="minor">
+            <a:schemeClr val="lt1"/>
+          </a:fontRef>
+        </p:style>
+        <p:txBody>
+          <a:bodyPr rtlCol="0" anchor="ctr"/>
+          <a:lstStyle/>
+          <a:p>
+            <a:pPr algn="ctr"/>
+          </a:p>
+        </p:txBody>
+      </p:sp>
+      <p:sp>
+        <p:nvSpPr>
+          <p:cNvPr id="15" name="Rectangle 14"/>
+          <p:cNvSpPr/>
+          <p:nvPr/>
+        </p:nvSpPr>
+        <p:spPr>
+          <a:xfrm>
+            <a:off x="640080" y="3575304"/>
+            <a:ext cx="82296" cy="749808"/>
+          </a:xfrm>
+          <a:prstGeom prst="rect">
+            <a:avLst/>
+          </a:prstGeom>
+          <a:solidFill>
+            <a:srgbClr val="2563EB"/>
+          </a:solidFill>
+          <a:ln>
+            <a:noFill/>
+          </a:ln>
+          <a:effectLst/>
+        </p:spPr>
+        <p:style>
+          <a:lnRef idx="1">
+            <a:schemeClr val="accent1"/>
+          </a:lnRef>
+          <a:fillRef idx="3">
+            <a:schemeClr val="accent1"/>
+          </a:fillRef>
+          <a:effectRef idx="2">
+            <a:schemeClr val="accent1"/>
+          </a:effectRef>
+          <a:fontRef idx="minor">
+            <a:schemeClr val="lt1"/>
+          </a:fontRef>
+        </p:style>
+        <p:txBody>
+          <a:bodyPr rtlCol="0" anchor="ctr"/>
+          <a:lstStyle/>
+          <a:p>
+            <a:pPr algn="ctr"/>
+          </a:p>
+        </p:txBody>
+      </p:sp>
+      <p:sp>
+        <p:nvSpPr>
+          <p:cNvPr id="16" name="TextBox 15"/>
+          <p:cNvSpPr txBox="1"/>
+          <p:nvPr/>
+        </p:nvSpPr>
+        <p:spPr>
+          <a:xfrm>
+            <a:off x="914400" y="3721608"/>
+            <a:ext cx="10424160" cy="548640"/>
+          </a:xfrm>
+          <a:prstGeom prst="rect">
+            <a:avLst/>
+          </a:prstGeom>
+          <a:noFill/>
+        </p:spPr>
+        <p:txBody>
+          <a:bodyPr wrap="square" anchor="ctr" lIns="0" rIns="0" tIns="0" bIns="0">
+            <a:spAutoFit/>
+          </a:bodyPr>
+          <a:lstStyle/>
+          <a:p>
+            <a:pPr algn="l">
+              <a:lnSpc>
+                <a:spcPct val="105000"/>
+              </a:lnSpc>
+              <a:spcBef>
+                <a:spcPts val="0"/>
+              </a:spcBef>
+              <a:spcAft>
+                <a:spcPts val="600"/>
+              </a:spcAft>
+            </a:pPr>
+            <a:r>
+              <a:rPr sz="1500" b="1" i="0">
+                <a:solidFill>
+                  <a:srgbClr val="1E40AF"/>
+                </a:solidFill>
+                <a:latin typeface="Arial"/>
+              </a:rPr>
+              <a:t>F1-score — </a:t>
+            </a:r>
+            <a:r>
+              <a:rPr sz="1500" b="0" i="0">
+                <a:solidFill>
+                  <a:srgbClr val="1F2937"/>
+                </a:solidFill>
+                <a:latin typeface="Arial"/>
+              </a:rPr>
+              <a:t>гармоническое среднее Precision и Recall — основная метрика</a:t>
+            </a:r>
+          </a:p>
+        </p:txBody>
+      </p:sp>
+      <p:sp>
+        <p:nvSpPr>
+          <p:cNvPr id="17" name="Rounded Rectangle 16"/>
+          <p:cNvSpPr/>
+          <p:nvPr/>
+        </p:nvSpPr>
+        <p:spPr>
+          <a:xfrm>
+            <a:off x="640080" y="4471416"/>
+            <a:ext cx="10927080" cy="749808"/>
+          </a:xfrm>
+          <a:prstGeom prst="roundRect">
+            <a:avLst/>
+          </a:prstGeom>
+          <a:solidFill>
+            <a:srgbClr val="F3F6FC"/>
+          </a:solidFill>
+          <a:ln w="12700">
+            <a:solidFill>
+              <a:srgbClr val="DBEAFE"/>
+            </a:solidFill>
+          </a:ln>
+          <a:effectLst/>
+        </p:spPr>
+        <p:style>
+          <a:lnRef idx="1">
+            <a:schemeClr val="accent1"/>
+          </a:lnRef>
+          <a:fillRef idx="3">
+            <a:schemeClr val="accent1"/>
+          </a:fillRef>
+          <a:effectRef idx="2">
+            <a:schemeClr val="accent1"/>
+          </a:effectRef>
+          <a:fontRef idx="minor">
+            <a:schemeClr val="lt1"/>
+          </a:fontRef>
+        </p:style>
+        <p:txBody>
+          <a:bodyPr rtlCol="0" anchor="ctr"/>
+          <a:lstStyle/>
+          <a:p>
+            <a:pPr algn="ctr"/>
+          </a:p>
+        </p:txBody>
+      </p:sp>
+      <p:sp>
+        <p:nvSpPr>
+          <p:cNvPr id="18" name="Rectangle 17"/>
+          <p:cNvSpPr/>
+          <p:nvPr/>
+        </p:nvSpPr>
+        <p:spPr>
+          <a:xfrm>
+            <a:off x="640080" y="4471416"/>
+            <a:ext cx="82296" cy="749808"/>
+          </a:xfrm>
+          <a:prstGeom prst="rect">
+            <a:avLst/>
+          </a:prstGeom>
+          <a:solidFill>
+            <a:srgbClr val="2563EB"/>
+          </a:solidFill>
+          <a:ln>
+            <a:noFill/>
+          </a:ln>
+          <a:effectLst/>
+        </p:spPr>
+        <p:style>
+          <a:lnRef idx="1">
+            <a:schemeClr val="accent1"/>
+          </a:lnRef>
+          <a:fillRef idx="3">
+            <a:schemeClr val="accent1"/>
+          </a:fillRef>
+          <a:effectRef idx="2">
+            <a:schemeClr val="accent1"/>
+          </a:effectRef>
+          <a:fontRef idx="minor">
+            <a:schemeClr val="lt1"/>
+          </a:fontRef>
+        </p:style>
+        <p:txBody>
+          <a:bodyPr rtlCol="0" anchor="ctr"/>
+          <a:lstStyle/>
+          <a:p>
+            <a:pPr algn="ctr"/>
+          </a:p>
+        </p:txBody>
+      </p:sp>
+      <p:sp>
+        <p:nvSpPr>
+          <p:cNvPr id="19" name="TextBox 18"/>
+          <p:cNvSpPr txBox="1"/>
+          <p:nvPr/>
+        </p:nvSpPr>
+        <p:spPr>
+          <a:xfrm>
+            <a:off x="914400" y="4617720"/>
+            <a:ext cx="10424160" cy="548640"/>
+          </a:xfrm>
+          <a:prstGeom prst="rect">
+            <a:avLst/>
+          </a:prstGeom>
+          <a:noFill/>
+        </p:spPr>
+        <p:txBody>
+          <a:bodyPr wrap="square" anchor="ctr" lIns="0" rIns="0" tIns="0" bIns="0">
+            <a:spAutoFit/>
+          </a:bodyPr>
+          <a:lstStyle/>
+          <a:p>
+            <a:pPr algn="l">
+              <a:lnSpc>
+                <a:spcPct val="105000"/>
+              </a:lnSpc>
+              <a:spcBef>
+                <a:spcPts val="0"/>
+              </a:spcBef>
+              <a:spcAft>
+                <a:spcPts val="600"/>
+              </a:spcAft>
+            </a:pPr>
+            <a:r>
+              <a:rPr sz="1500" b="1" i="0">
+                <a:solidFill>
+                  <a:srgbClr val="1E40AF"/>
+                </a:solidFill>
+                <a:latin typeface="Arial"/>
+              </a:rPr>
+              <a:t>IoU / mIoU — </a:t>
+            </a:r>
+            <a:r>
+              <a:rPr sz="1500" b="0" i="0">
+                <a:solidFill>
+                  <a:srgbClr val="1F2937"/>
+                </a:solidFill>
+                <a:latin typeface="Arial"/>
+              </a:rPr>
+              <a:t>отношение пересечения к объединению масок; mIoU — среднее по классам</a:t>
+            </a:r>
+          </a:p>
+        </p:txBody>
+      </p:sp>
+      <p:sp>
+        <p:nvSpPr>
+          <p:cNvPr id="20" name="Rounded Rectangle 19"/>
+          <p:cNvSpPr/>
+          <p:nvPr/>
+        </p:nvSpPr>
+        <p:spPr>
+          <a:xfrm>
+            <a:off x="640080" y="5367528"/>
+            <a:ext cx="10927080" cy="749808"/>
+          </a:xfrm>
+          <a:prstGeom prst="roundRect">
+            <a:avLst/>
+          </a:prstGeom>
+          <a:solidFill>
+            <a:srgbClr val="F3F6FC"/>
+          </a:solidFill>
+          <a:ln w="12700">
+            <a:solidFill>
+              <a:srgbClr val="DBEAFE"/>
+            </a:solidFill>
+          </a:ln>
+          <a:effectLst/>
+        </p:spPr>
+        <p:style>
+          <a:lnRef idx="1">
+            <a:schemeClr val="accent1"/>
+          </a:lnRef>
+          <a:fillRef idx="3">
+            <a:schemeClr val="accent1"/>
+          </a:fillRef>
+          <a:effectRef idx="2">
+            <a:schemeClr val="accent1"/>
+          </a:effectRef>
+          <a:fontRef idx="minor">
+            <a:schemeClr val="lt1"/>
+          </a:fontRef>
+        </p:style>
+        <p:txBody>
+          <a:bodyPr rtlCol="0" anchor="ctr"/>
+          <a:lstStyle/>
+          <a:p>
+            <a:pPr algn="ctr"/>
+          </a:p>
+        </p:txBody>
+      </p:sp>
+      <p:sp>
+        <p:nvSpPr>
+          <p:cNvPr id="21" name="Rectangle 20"/>
+          <p:cNvSpPr/>
+          <p:nvPr/>
+        </p:nvSpPr>
+        <p:spPr>
+          <a:xfrm>
+            <a:off x="640080" y="5367528"/>
+            <a:ext cx="82296" cy="749808"/>
+          </a:xfrm>
+          <a:prstGeom prst="rect">
+            <a:avLst/>
+          </a:prstGeom>
+          <a:solidFill>
+            <a:srgbClr val="2563EB"/>
+          </a:solidFill>
+          <a:ln>
+            <a:noFill/>
+          </a:ln>
+          <a:effectLst/>
+        </p:spPr>
+        <p:style>
+          <a:lnRef idx="1">
+            <a:schemeClr val="accent1"/>
+          </a:lnRef>
+          <a:fillRef idx="3">
+            <a:schemeClr val="accent1"/>
+          </a:fillRef>
+          <a:effectRef idx="2">
+            <a:schemeClr val="accent1"/>
+          </a:effectRef>
+          <a:fontRef idx="minor">
+            <a:schemeClr val="lt1"/>
+          </a:fontRef>
+        </p:style>
+        <p:txBody>
+          <a:bodyPr rtlCol="0" anchor="ctr"/>
+          <a:lstStyle/>
+          <a:p>
+            <a:pPr algn="ctr"/>
+          </a:p>
+        </p:txBody>
+      </p:sp>
+      <p:sp>
+        <p:nvSpPr>
+          <p:cNvPr id="22" name="TextBox 21"/>
+          <p:cNvSpPr txBox="1"/>
+          <p:nvPr/>
+        </p:nvSpPr>
+        <p:spPr>
+          <a:xfrm>
+            <a:off x="914400" y="5513832"/>
+            <a:ext cx="10424160" cy="548640"/>
+          </a:xfrm>
+          <a:prstGeom prst="rect">
+            <a:avLst/>
+          </a:prstGeom>
+          <a:noFill/>
+        </p:spPr>
+        <p:txBody>
+          <a:bodyPr wrap="square" anchor="ctr" lIns="0" rIns="0" tIns="0" bIns="0">
+            <a:spAutoFit/>
+          </a:bodyPr>
+          <a:lstStyle/>
+          <a:p>
+            <a:pPr algn="l">
+              <a:lnSpc>
+                <a:spcPct val="105000"/>
+              </a:lnSpc>
+              <a:spcBef>
+                <a:spcPts val="0"/>
+              </a:spcBef>
+              <a:spcAft>
+                <a:spcPts val="600"/>
+              </a:spcAft>
+            </a:pPr>
+            <a:r>
+              <a:rPr sz="1500" b="1" i="0">
+                <a:solidFill>
+                  <a:srgbClr val="1E40AF"/>
+                </a:solidFill>
+                <a:latin typeface="Arial"/>
+              </a:rPr>
+              <a:t>Accuracy — </a:t>
+            </a:r>
+            <a:r>
+              <a:rPr sz="1500" b="0" i="0">
+                <a:solidFill>
+                  <a:srgbClr val="1F2937"/>
+                </a:solidFill>
+                <a:latin typeface="Arial"/>
+              </a:rPr>
+              <a:t>доля верно классифицированных пикселей всех классов</a:t>
+            </a:r>
+          </a:p>
+        </p:txBody>
+      </p:sp>
+    </p:spTree>
+  </p:cSld>
+  <p:clrMapOvr>
+    <a:masterClrMapping/>
+  </p:clrMapOvr>
+</p:sld>
+</file>
+
+<file path=ppt/slides/slide18.xml><?xml version="1.0" encoding="utf-8"?>
+<p:sld xmlns:a="http://schemas.openxmlformats.org/drawingml/2006/main" xmlns:p="http://schemas.openxmlformats.org/presentationml/2006/main" xmlns:r="http://schemas.openxmlformats.org/officeDocument/2006/relationships">
+  <p:cSld>
+    <p:spTree>
+      <p:nvGrpSpPr>
+        <p:cNvPr id="1" name=""/>
+        <p:cNvGrpSpPr/>
+        <p:nvPr/>
+      </p:nvGrpSpPr>
+      <p:grpSpPr/>
+      <p:sp>
+        <p:nvSpPr>
+          <p:cNvPr id="2" name="Rectangle 1"/>
+          <p:cNvSpPr/>
+          <p:nvPr/>
+        </p:nvSpPr>
+        <p:spPr>
+          <a:xfrm>
+            <a:off x="0" y="0"/>
+            <a:ext cx="12191695" cy="6858000"/>
+          </a:xfrm>
+          <a:prstGeom prst="rect">
+            <a:avLst/>
+          </a:prstGeom>
+          <a:solidFill>
+            <a:srgbClr val="FFFFFF"/>
+          </a:solidFill>
+          <a:ln>
+            <a:noFill/>
+          </a:ln>
+          <a:effectLst/>
+        </p:spPr>
+        <p:style>
+          <a:lnRef idx="1">
+            <a:schemeClr val="accent1"/>
+          </a:lnRef>
+          <a:fillRef idx="3">
+            <a:schemeClr val="accent1"/>
+          </a:fillRef>
+          <a:effectRef idx="2">
+            <a:schemeClr val="accent1"/>
+          </a:effectRef>
+          <a:fontRef idx="minor">
+            <a:schemeClr val="lt1"/>
+          </a:fontRef>
+        </p:style>
+        <p:txBody>
+          <a:bodyPr rtlCol="0" anchor="ctr"/>
+          <a:lstStyle/>
+          <a:p>
+            <a:pPr algn="ctr"/>
+          </a:p>
+        </p:txBody>
+      </p:sp>
+      <p:sp>
+        <p:nvSpPr>
+          <p:cNvPr id="3" name="Rectangle 2"/>
+          <p:cNvSpPr/>
+          <p:nvPr/>
+        </p:nvSpPr>
+        <p:spPr>
+          <a:xfrm>
+            <a:off x="0" y="0"/>
+            <a:ext cx="146304" cy="6858000"/>
+          </a:xfrm>
+          <a:prstGeom prst="rect">
+            <a:avLst/>
+          </a:prstGeom>
+          <a:solidFill>
+            <a:srgbClr val="2563EB"/>
+          </a:solidFill>
+          <a:ln>
+            <a:noFill/>
+          </a:ln>
+          <a:effectLst/>
+        </p:spPr>
+        <p:style>
+          <a:lnRef idx="1">
+            <a:schemeClr val="accent1"/>
+          </a:lnRef>
+          <a:fillRef idx="3">
+            <a:schemeClr val="accent1"/>
+          </a:fillRef>
+          <a:effectRef idx="2">
+            <a:schemeClr val="accent1"/>
+          </a:effectRef>
+          <a:fontRef idx="minor">
+            <a:schemeClr val="lt1"/>
+          </a:fontRef>
+        </p:style>
+        <p:txBody>
+          <a:bodyPr rtlCol="0" anchor="ctr"/>
+          <a:lstStyle/>
+          <a:p>
+            <a:pPr algn="ctr"/>
+          </a:p>
+        </p:txBody>
+      </p:sp>
+      <p:sp>
+        <p:nvSpPr>
+          <p:cNvPr id="4" name="TextBox 3"/>
+          <p:cNvSpPr txBox="1"/>
+          <p:nvPr/>
+        </p:nvSpPr>
+        <p:spPr>
+          <a:xfrm>
+            <a:off x="640080" y="310896"/>
+            <a:ext cx="10058400" cy="274320"/>
+          </a:xfrm>
+          <a:prstGeom prst="rect">
+            <a:avLst/>
+          </a:prstGeom>
+          <a:noFill/>
+        </p:spPr>
+        <p:txBody>
+          <a:bodyPr wrap="square" anchor="t" lIns="0" rIns="0" tIns="0" bIns="0">
+            <a:spAutoFit/>
+          </a:bodyPr>
+          <a:lstStyle/>
+          <a:p>
+            <a:pPr algn="l">
+              <a:lnSpc>
+                <a:spcPct val="105000"/>
+              </a:lnSpc>
+              <a:spcBef>
+                <a:spcPts val="0"/>
+              </a:spcBef>
+              <a:spcAft>
+                <a:spcPts val="600"/>
+              </a:spcAft>
+            </a:pPr>
+            <a:r>
+              <a:rPr sz="1100" b="1" i="0">
+                <a:solidFill>
+                  <a:srgbClr val="6B7280"/>
+                </a:solidFill>
+                <a:latin typeface="Arial"/>
+              </a:rPr>
+              <a:t>РЕЗЕРВНЫЙ СЛАЙД</a:t>
+            </a:r>
+          </a:p>
+        </p:txBody>
+      </p:sp>
+      <p:sp>
+        <p:nvSpPr>
+          <p:cNvPr id="5" name="TextBox 4"/>
+          <p:cNvSpPr txBox="1"/>
+          <p:nvPr/>
+        </p:nvSpPr>
+        <p:spPr>
+          <a:xfrm>
+            <a:off x="640080" y="566928"/>
+            <a:ext cx="10972800" cy="731520"/>
+          </a:xfrm>
+          <a:prstGeom prst="rect">
+            <a:avLst/>
+          </a:prstGeom>
+          <a:noFill/>
+        </p:spPr>
+        <p:txBody>
+          <a:bodyPr wrap="square" anchor="t" lIns="0" rIns="0" tIns="0" bIns="0">
+            <a:spAutoFit/>
+          </a:bodyPr>
+          <a:lstStyle/>
+          <a:p>
+            <a:pPr algn="l">
+              <a:lnSpc>
+                <a:spcPct val="105000"/>
+              </a:lnSpc>
+              <a:spcBef>
+                <a:spcPts val="0"/>
+              </a:spcBef>
+              <a:spcAft>
+                <a:spcPts val="600"/>
+              </a:spcAft>
+            </a:pPr>
+            <a:r>
+              <a:rPr sz="3000" b="1" i="0">
+                <a:solidFill>
+                  <a:srgbClr val="2563EB"/>
+                </a:solidFill>
+                <a:latin typeface="Arial"/>
+              </a:rPr>
+              <a:t>Разбор матрицы ошибок</a:t>
+            </a:r>
+          </a:p>
+        </p:txBody>
+      </p:sp>
+      <p:sp>
+        <p:nvSpPr>
+          <p:cNvPr id="6" name="Rectangle 5"/>
+          <p:cNvSpPr/>
+          <p:nvPr/>
+        </p:nvSpPr>
+        <p:spPr>
+          <a:xfrm>
+            <a:off x="640080" y="1225296"/>
+            <a:ext cx="2011680" cy="38100"/>
+          </a:xfrm>
+          <a:prstGeom prst="rect">
+            <a:avLst/>
+          </a:prstGeom>
+          <a:solidFill>
+            <a:srgbClr val="2563EB"/>
+          </a:solidFill>
+          <a:ln>
+            <a:noFill/>
+          </a:ln>
+          <a:effectLst/>
+        </p:spPr>
+        <p:style>
+          <a:lnRef idx="1">
+            <a:schemeClr val="accent1"/>
+          </a:lnRef>
+          <a:fillRef idx="3">
+            <a:schemeClr val="accent1"/>
+          </a:fillRef>
+          <a:effectRef idx="2">
+            <a:schemeClr val="accent1"/>
+          </a:effectRef>
+          <a:fontRef idx="minor">
+            <a:schemeClr val="lt1"/>
+          </a:fontRef>
+        </p:style>
+        <p:txBody>
+          <a:bodyPr rtlCol="0" anchor="ctr"/>
+          <a:lstStyle/>
+          <a:p>
+            <a:pPr algn="ctr"/>
+          </a:p>
+        </p:txBody>
+      </p:sp>
+      <p:sp>
+        <p:nvSpPr>
+          <p:cNvPr id="7" name="Rounded Rectangle 6"/>
+          <p:cNvSpPr/>
+          <p:nvPr/>
+        </p:nvSpPr>
+        <p:spPr>
+          <a:xfrm>
+            <a:off x="11140135" y="6355080"/>
+            <a:ext cx="777240" cy="310896"/>
+          </a:xfrm>
+          <a:prstGeom prst="roundRect">
+            <a:avLst/>
+          </a:prstGeom>
+          <a:solidFill>
+            <a:srgbClr val="F3F6FC"/>
+          </a:solidFill>
+          <a:ln w="9525">
+            <a:solidFill>
+              <a:srgbClr val="E2E8F0"/>
+            </a:solidFill>
+          </a:ln>
+          <a:effectLst/>
+        </p:spPr>
+        <p:style>
+          <a:lnRef idx="1">
+            <a:schemeClr val="accent1"/>
+          </a:lnRef>
+          <a:fillRef idx="3">
+            <a:schemeClr val="accent1"/>
+          </a:fillRef>
+          <a:effectRef idx="2">
+            <a:schemeClr val="accent1"/>
+          </a:effectRef>
+          <a:fontRef idx="minor">
+            <a:schemeClr val="lt1"/>
+          </a:fontRef>
+        </p:style>
+        <p:txBody>
+          <a:bodyPr rtlCol="0" anchor="ctr" wrap="none" lIns="0" rIns="0" tIns="0" bIns="0"/>
+          <a:lstStyle/>
+          <a:p>
+            <a:pPr algn="ctr"/>
+            <a:r>
+              <a:rPr sz="1100">
+                <a:solidFill>
+                  <a:srgbClr val="6B7280"/>
+                </a:solidFill>
+                <a:latin typeface="Arial"/>
+              </a:rPr>
+              <a:t>18 / 18</a:t>
+            </a:r>
+          </a:p>
+        </p:txBody>
+      </p:sp>
+      <p:pic>
+        <p:nvPicPr>
+          <p:cNvPr id="8" name="Picture 7" descr="fig_confusion.png"/>
+          <p:cNvPicPr>
+            <a:picLocks noChangeAspect="1"/>
+          </p:cNvPicPr>
+          <p:nvPr/>
+        </p:nvPicPr>
+        <p:blipFill>
+          <a:blip r:embed="rId2"/>
+          <a:stretch>
+            <a:fillRect/>
+          </a:stretch>
+        </p:blipFill>
+        <p:spPr>
+          <a:xfrm>
+            <a:off x="691075" y="1554480"/>
+            <a:ext cx="5201529" cy="4663440"/>
+          </a:xfrm>
+          <a:prstGeom prst="rect">
+            <a:avLst/>
+          </a:prstGeom>
+        </p:spPr>
+      </p:pic>
+      <p:sp>
+        <p:nvSpPr>
+          <p:cNvPr id="9" name="TextBox 8"/>
+          <p:cNvSpPr txBox="1"/>
+          <p:nvPr/>
+        </p:nvSpPr>
+        <p:spPr>
+          <a:xfrm>
+            <a:off x="6400800" y="1828800"/>
+            <a:ext cx="5120640" cy="4114800"/>
+          </a:xfrm>
+          <a:prstGeom prst="rect">
+            <a:avLst/>
+          </a:prstGeom>
+          <a:noFill/>
+        </p:spPr>
+        <p:txBody>
+          <a:bodyPr wrap="square" lIns="0" rIns="0" tIns="0" bIns="0">
+            <a:spAutoFit/>
+          </a:bodyPr>
+          <a:lstStyle/>
+          <a:p>
+            <a:pPr>
+              <a:lnSpc>
+                <a:spcPct val="105000"/>
+              </a:lnSpc>
+              <a:spcBef>
+                <a:spcPts val="0"/>
+              </a:spcBef>
+              <a:spcAft>
+                <a:spcPts val="1300"/>
+              </a:spcAft>
+            </a:pPr>
+            <a:r>
+              <a:rPr sz="1500" b="1">
+                <a:solidFill>
+                  <a:srgbClr val="2563EB"/>
+                </a:solidFill>
+                <a:latin typeface="Arial"/>
+              </a:rPr>
+              <a:t>•  </a:t>
+            </a:r>
+            <a:r>
+              <a:rPr sz="1500" b="1">
+                <a:solidFill>
+                  <a:srgbClr val="1F2937"/>
+                </a:solidFill>
+                <a:latin typeface="Arial"/>
+              </a:rPr>
+              <a:t>Основная ошибка</a:t>
+            </a:r>
+            <a:r>
+              <a:rPr sz="1500" b="0">
+                <a:solidFill>
+                  <a:srgbClr val="1F2937"/>
+                </a:solidFill>
+                <a:latin typeface="Arial"/>
+              </a:rPr>
+              <a:t> — 8,4 % пикселей нефти отнесены к «лёд + суша»</a:t>
+            </a:r>
+          </a:p>
+          <a:p>
+            <a:pPr>
+              <a:lnSpc>
+                <a:spcPct val="105000"/>
+              </a:lnSpc>
+              <a:spcBef>
+                <a:spcPts val="0"/>
+              </a:spcBef>
+              <a:spcAft>
+                <a:spcPts val="1300"/>
+              </a:spcAft>
+            </a:pPr>
+            <a:r>
+              <a:rPr sz="1500" b="1">
+                <a:solidFill>
+                  <a:srgbClr val="2563EB"/>
+                </a:solidFill>
+                <a:latin typeface="Arial"/>
+              </a:rPr>
+              <a:t>•  </a:t>
+            </a:r>
+            <a:r>
+              <a:rPr sz="1500" b="1">
+                <a:solidFill>
+                  <a:srgbClr val="1F2937"/>
+                </a:solidFill>
+                <a:latin typeface="Arial"/>
+              </a:rPr>
+              <a:t>Причина</a:t>
+            </a:r>
+            <a:r>
+              <a:rPr sz="1500" b="0">
+                <a:solidFill>
+                  <a:srgbClr val="1F2937"/>
+                </a:solidFill>
+                <a:latin typeface="Arial"/>
+              </a:rPr>
+              <a:t> — физически схожие тёмные сигнатуры обратного рассеяния</a:t>
+            </a:r>
+          </a:p>
+          <a:p>
+            <a:pPr>
+              <a:lnSpc>
+                <a:spcPct val="105000"/>
+              </a:lnSpc>
+              <a:spcBef>
+                <a:spcPts val="0"/>
+              </a:spcBef>
+              <a:spcAft>
+                <a:spcPts val="1300"/>
+              </a:spcAft>
+            </a:pPr>
+            <a:r>
+              <a:rPr sz="1500" b="1">
+                <a:solidFill>
+                  <a:srgbClr val="2563EB"/>
+                </a:solidFill>
+                <a:latin typeface="Arial"/>
+              </a:rPr>
+              <a:t>•  </a:t>
+            </a:r>
+            <a:r>
+              <a:rPr sz="1500" b="1">
+                <a:solidFill>
+                  <a:srgbClr val="1F2937"/>
+                </a:solidFill>
+                <a:latin typeface="Arial"/>
+              </a:rPr>
+              <a:t>Класс «вода»</a:t>
+            </a:r>
+            <a:r>
+              <a:rPr sz="1500" b="0">
+                <a:solidFill>
+                  <a:srgbClr val="1F2937"/>
+                </a:solidFill>
+                <a:latin typeface="Arial"/>
+              </a:rPr>
+              <a:t> распознаётся с точностью 96,2 %</a:t>
+            </a:r>
+          </a:p>
+          <a:p>
+            <a:pPr>
+              <a:lnSpc>
+                <a:spcPct val="105000"/>
+              </a:lnSpc>
+              <a:spcBef>
+                <a:spcPts val="0"/>
+              </a:spcBef>
+              <a:spcAft>
+                <a:spcPts val="1300"/>
+              </a:spcAft>
+            </a:pPr>
+            <a:r>
+              <a:rPr sz="1500" b="1">
+                <a:solidFill>
+                  <a:srgbClr val="2563EB"/>
+                </a:solidFill>
+                <a:latin typeface="Arial"/>
+              </a:rPr>
+              <a:t>•  </a:t>
+            </a:r>
+            <a:r>
+              <a:rPr sz="1500" b="1">
+                <a:solidFill>
+                  <a:srgbClr val="1F2937"/>
+                </a:solidFill>
+                <a:latin typeface="Arial"/>
+              </a:rPr>
+              <a:t>Класс «лёд + суша»</a:t>
+            </a:r>
+            <a:r>
+              <a:rPr sz="1500" b="0">
+                <a:solidFill>
+                  <a:srgbClr val="1F2937"/>
+                </a:solidFill>
+                <a:latin typeface="Arial"/>
+              </a:rPr>
+              <a:t> — 96,0 %; смешение с нефтью лишь 2,7 %</a:t>
+            </a:r>
+          </a:p>
+          <a:p>
+            <a:pPr>
+              <a:lnSpc>
+                <a:spcPct val="105000"/>
+              </a:lnSpc>
+              <a:spcBef>
+                <a:spcPts val="0"/>
+              </a:spcBef>
+              <a:spcAft>
+                <a:spcPts val="1300"/>
+              </a:spcAft>
+            </a:pPr>
+            <a:r>
+              <a:rPr sz="1500" b="1">
+                <a:solidFill>
+                  <a:srgbClr val="2563EB"/>
+                </a:solidFill>
+                <a:latin typeface="Arial"/>
+              </a:rPr>
+              <a:t>•  </a:t>
+            </a:r>
+            <a:r>
+              <a:rPr sz="1500" b="1">
+                <a:solidFill>
+                  <a:srgbClr val="1F2937"/>
+                </a:solidFill>
+                <a:latin typeface="Arial"/>
+              </a:rPr>
+              <a:t>Вывод</a:t>
+            </a:r>
+            <a:r>
+              <a:rPr sz="1500" b="0">
+                <a:solidFill>
+                  <a:srgbClr val="1F2937"/>
+                </a:solidFill>
+                <a:latin typeface="Arial"/>
+              </a:rPr>
+              <a:t> — модель устойчиво разделяет три класса; остаточная путаница ожидаема физически</a:t>
             </a:r>
           </a:p>
         </p:txBody>
@@ -6641,7 +11051,7 @@
                 </a:solidFill>
                 <a:latin typeface="Arial"/>
               </a:rPr>
-              <a:t>2 / 13</a:t>
+              <a:t>2 / 18</a:t>
             </a:r>
           </a:p>
         </p:txBody>
@@ -7865,7 +12275,7 @@
                 </a:solidFill>
                 <a:latin typeface="Arial"/>
               </a:rPr>
-              <a:t>3 / 13</a:t>
+              <a:t>3 / 18</a:t>
             </a:r>
           </a:p>
         </p:txBody>
@@ -8696,7 +13106,7 @@
                 </a:solidFill>
                 <a:latin typeface="Arial"/>
               </a:rPr>
-              <a:t>4 / 13</a:t>
+              <a:t>4 / 18</a:t>
             </a:r>
           </a:p>
         </p:txBody>
@@ -9552,7 +13962,7 @@
                 </a:solidFill>
                 <a:latin typeface="Arial"/>
               </a:rPr>
-              <a:t>5 / 13</a:t>
+              <a:t>5 / 18</a:t>
             </a:r>
           </a:p>
         </p:txBody>
@@ -10590,7 +15000,7 @@
                 </a:solidFill>
                 <a:latin typeface="Arial"/>
               </a:rPr>
-              <a:t>6 / 13</a:t>
+              <a:t>6 / 18</a:t>
             </a:r>
           </a:p>
         </p:txBody>
@@ -11453,7 +15863,7 @@
                 </a:solidFill>
                 <a:latin typeface="Arial"/>
               </a:rPr>
-              <a:t>7 / 13</a:t>
+              <a:t>7 / 18</a:t>
             </a:r>
           </a:p>
         </p:txBody>
@@ -11793,7 +16203,7 @@
                 </a:solidFill>
                 <a:latin typeface="Arial"/>
               </a:rPr>
-              <a:t>Пиксели нефти — менее 1 %. Решение: взвешенная Dice-BCE, вес класса «нефть» повышен до 9,8.</a:t>
+              <a:t>Пиксели нефти — менее 2,4 %. Решение: взвешенная Dice-BCE, вес класса «нефть» повышен до 9,8.</a:t>
             </a:r>
           </a:p>
         </p:txBody>
@@ -12043,7 +16453,7 @@
                 </a:solidFill>
                 <a:latin typeface="Arial"/>
               </a:rPr>
-              <a:t>8 / 13</a:t>
+              <a:t>8 / 18</a:t>
             </a:r>
           </a:p>
         </p:txBody>
@@ -12992,7 +17402,7 @@
                 </a:solidFill>
                 <a:latin typeface="Arial"/>
               </a:rPr>
-              <a:t>9 / 13</a:t>
+              <a:t>9 / 18</a:t>
             </a:r>
           </a:p>
         </p:txBody>

</xml_diff>

<commit_message>
defense prep final: fix 3 errors in deck, rewrite speech, expand Q&A
- PPTX: fix full title (4-line, 28pt), reviewer name Надежда Анатольевна,
  Kola Bay spill date 11.08→11.09.2024
- Speech: ~8 min 40 sec with slide transition cues, corrected dates/numbers
- Q&A: Part 1 — per-slide question+answer (13 slides); Part 2 — 20 expanded
  topic questions; fixed Q7 date (август→сентябрь)

https://claude.ai/code/session_019hNMUj3P61dTB8aYHXMjHP
</commit_message>
<xml_diff>
--- a/thesis/vkr_final/Презентация_Финал_Байханов_2026.pptx
+++ b/thesis/vkr_final/Презентация_Финал_Байханов_2026.pptx
@@ -3310,8 +3310,8 @@
         </p:nvSpPr>
         <p:spPr>
           <a:xfrm>
-            <a:off x="640080" y="2240280"/>
-            <a:ext cx="10972800" cy="1828800"/>
+            <a:off x="640080" y="2103120"/>
+            <a:ext cx="10972800" cy="2103120"/>
           </a:xfrm>
           <a:prstGeom prst="rect">
             <a:avLst/>
@@ -3326,7 +3326,7 @@
           <a:p>
             <a:pPr algn="l">
               <a:lnSpc>
-                <a:spcPct val="106000"/>
+                <a:spcPct val="108000"/>
               </a:lnSpc>
               <a:spcBef>
                 <a:spcPts val="0"/>
@@ -3336,19 +3336,19 @@
               </a:spcAft>
             </a:pPr>
             <a:r>
-              <a:rPr sz="3300" b="1" i="0">
+              <a:rPr sz="2800" b="1" i="0">
                 <a:solidFill>
                   <a:srgbClr val="FFFFFF"/>
                 </a:solidFill>
                 <a:latin typeface="Arial"/>
               </a:rPr>
-              <a:t>Автоматическое детектирование нефтяных разливов</a:t>
+              <a:t>Разработка системы автоматического</a:t>
             </a:r>
           </a:p>
           <a:p>
             <a:pPr algn="l">
               <a:lnSpc>
-                <a:spcPct val="106000"/>
+                <a:spcPct val="108000"/>
               </a:lnSpc>
               <a:spcBef>
                 <a:spcPts val="0"/>
@@ -3358,19 +3358,19 @@
               </a:spcAft>
             </a:pPr>
             <a:r>
-              <a:rPr sz="3300" b="1" i="0">
+              <a:rPr sz="2800" b="1" i="0">
                 <a:solidFill>
                   <a:srgbClr val="FFFFFF"/>
                 </a:solidFill>
                 <a:latin typeface="Arial"/>
               </a:rPr>
-              <a:t>в акваториях арктических портов по данным</a:t>
+              <a:t>детектирования нефтяных разливов</a:t>
             </a:r>
           </a:p>
           <a:p>
             <a:pPr algn="l">
               <a:lnSpc>
-                <a:spcPct val="106000"/>
+                <a:spcPct val="108000"/>
               </a:lnSpc>
               <a:spcBef>
                 <a:spcPts val="0"/>
@@ -3380,13 +3380,35 @@
               </a:spcAft>
             </a:pPr>
             <a:r>
-              <a:rPr sz="3300" b="1" i="0">
+              <a:rPr sz="2800" b="1" i="0">
                 <a:solidFill>
                   <a:srgbClr val="FFFFFF"/>
                 </a:solidFill>
                 <a:latin typeface="Arial"/>
               </a:rPr>
-              <a:t>спутниковой радиолокационной съёмки</a:t>
+              <a:t>в акваториях арктических портов</a:t>
+            </a:r>
+          </a:p>
+          <a:p>
+            <a:pPr algn="l">
+              <a:lnSpc>
+                <a:spcPct val="108000"/>
+              </a:lnSpc>
+              <a:spcBef>
+                <a:spcPts val="0"/>
+              </a:spcBef>
+              <a:spcAft>
+                <a:spcPts val="200"/>
+              </a:spcAft>
+            </a:pPr>
+            <a:r>
+              <a:rPr sz="2800" b="1" i="0">
+                <a:solidFill>
+                  <a:srgbClr val="FFFFFF"/>
+                </a:solidFill>
+                <a:latin typeface="Arial"/>
+              </a:rPr>
+              <a:t>по данным спутниковой радиолокационной съёмки</a:t>
             </a:r>
           </a:p>
         </p:txBody>
@@ -3749,7 +3771,7 @@
                 <a:latin typeface="Arial"/>
               </a:rPr>
               <a:t>Филиппова
-Наталья Алексеевна</a:t>
+Надежда Анатольевна</a:t>
             </a:r>
           </a:p>
         </p:txBody>
@@ -12001,7 +12023,7 @@
                 </a:solidFill>
                 <a:latin typeface="Arial"/>
               </a:rPr>
-              <a:t>Кольский залив, Sentinel-1 2024 — временно́й ряд детектирования разлива мазута 11.08.2024</a:t>
+              <a:t>Кольский залив, Sentinel-1 2024 — временно́й ряд детектирования разлива мазута 11.09.2024</a:t>
             </a:r>
           </a:p>
         </p:txBody>

</xml_diff>